<commit_message>
fix: bind API to Render PORT and document live staging
Render injects PORT at runtime, so the Docker entrypoint no longer hardcodes 8000. Record the applied Blueprint hosts, queue squash auto-merge with the Alex review SOP, and keep the investor deck output path portable.

Co-authored-by: Cursor <cursoragent@cursor.com>
</commit_message>
<xml_diff>
--- a/docs/careflow-investor-pitch.pptx
+++ b/docs/careflow-investor-pitch.pptx
@@ -603,7 +603,7 @@
             <a:r>
               <a:rPr lang="en-US" dirty="0"/>
               <a:t>Sources: peak demand on Monday, 08:00–12:00 — Mwaura et al., AKUHN, PLOS One 2025. One-way SMS reminders and appointment attendance in Africa, odds ratio 2.03 — PLOS One 2019 meta-analysis. Kenya antenatal care missed appointments 35–42% — Homabay and Kisumu studies plus systematic reviews.
-Objection: who actually pays for this? Answer: not national insurance in this pass — that is deliberately deferred. The first budget we test is county and facility, where the pain is measurable: low-acuity load arriving at the wrong level, a peak window that is predictable enough to shift, and an SMS channel with published evidence that it improves attendance. Monetisation stays labelled as a hypothesis until a pilot prices it. We are not presenting a market-size calculation.</a:t>
+Objection: who actually pays for this? Answer: SHA is deferred. The first budget we test is county and facility, where the pain is measurable: low-acuity load arriving at the wrong level, a peak window that is predictable enough to shift, and an SMS channel with published evidence that it improves attendance. Monetisation stays labelled as a hypothesis until a pilot prices it. We are not presenting a market-size calculation.</a:t>
             </a:r>
             <a:endParaRPr lang="en-US" dirty="0"/>
           </a:p>
@@ -1049,7 +1049,7 @@
             <a:r>
               <a:rPr lang="en-US" dirty="0"/>
               <a:t>Sources: Singapore virtual care centre — 69% avoidance of an emergency department visit within 72 hours and 4.9% undertriage, JMIR Formative Research 2026. Label it out loud as an analog, not a Kenya randomised controlled trial. In-ED comparators: ETAT and Smart Triage (see the safety slide). Referral enforcement at Kenyatta National Hospital reduced direct Level 2–3 referrals, but reactively, at the door.
-Landscape whitespace [Likely]: no public product we can find combines community-entered symptoms, a KEPH minimum level, wait plus distance ranking, a booking, and an arrived/no-show close. Adjacent products worth naming in the room if asked, each as not-the-wedge: national digital-health and insurance rails, private booking marketplaces such as Vezeeta and Ponea, and teleconsult apps.
+Landscape whitespace [Likely]: no public product we can find combines community-entered symptoms, a KEPH minimum level, wait plus distance ranking, a booking, and an arrived/no-show close. Adjacent products worth naming in the room if asked, each as not-the-wedge: AfyaKE/AfyaLink (national rails), KNH referral enforcement, Smart Triage and ETAT (in-ED), Vezeeta/Ponea (booking marketplaces), and teleconsult apps.
 Objection: health tech in Kenya is crowded. Answer: it is, and we are not claiming there are no competitors. We are claiming none of those products occupies the before-the-door position. Marketplaces book the facility the family already picked; teleconsult replaces the visit; the rails move claims and records. None of them changes which KEPH level the family walks into or closes the loop with the desk.</a:t>
             </a:r>
             <a:endParaRPr lang="en-US" dirty="0"/>
@@ -1762,7 +1762,7 @@
     <p:bg>
       <p:bgPr>
         <a:solidFill>
-          <a:srgbClr val="14211E"/>
+          <a:srgbClr val="102A43"/>
         </a:solidFill>
       </p:bgPr>
     </p:bg>
@@ -1807,7 +1807,7 @@
             <a:r>
               <a:rPr lang="en-US" sz="6800" b="1" dirty="0">
                 <a:solidFill>
-                  <a:srgbClr val="F4F7F6"/>
+                  <a:srgbClr val="F4F7FB"/>
                 </a:solidFill>
                 <a:latin typeface="Cambria" pitchFamily="34" charset="0"/>
                 <a:ea typeface="Cambria" pitchFamily="34" charset="-122"/>
@@ -1849,7 +1849,7 @@
             <a:r>
               <a:rPr lang="en-US" sz="2000" dirty="0">
                 <a:solidFill>
-                  <a:srgbClr val="C5D4CF"/>
+                  <a:srgbClr val="B8C7DB"/>
                 </a:solidFill>
                 <a:latin typeface="Calibri" pitchFamily="34" charset="0"/>
                 <a:ea typeface="Calibri" pitchFamily="34" charset="-122"/>
@@ -1888,7 +1888,7 @@
             <a:r>
               <a:rPr lang="en-US" sz="1300" b="1" spc="240" kern="0" dirty="0">
                 <a:solidFill>
-                  <a:srgbClr val="F4F7F6"/>
+                  <a:srgbClr val="F4F7FB"/>
                 </a:solidFill>
                 <a:latin typeface="Calibri" pitchFamily="34" charset="0"/>
                 <a:ea typeface="Calibri" pitchFamily="34" charset="-122"/>
@@ -1917,12 +1917,12 @@
             </a:avLst>
           </a:prstGeom>
           <a:solidFill>
-            <a:srgbClr val="0F5C4C"/>
+            <a:srgbClr val="1B4F8A"/>
           </a:solidFill>
           <a:ln/>
           <a:effectLst>
             <a:outerShdw sx="100000" sy="100000" kx="0" ky="0" algn="bl" rotWithShape="0" blurRad="127000" dist="25400" dir="5400000">
-              <a:srgbClr val="14211e">
+              <a:srgbClr val="102a43">
                 <a:alpha val="10000"/>
               </a:srgbClr>
             </a:outerShdw>
@@ -1956,7 +1956,7 @@
             <a:r>
               <a:rPr lang="en-US" sz="1500" b="1" dirty="0">
                 <a:solidFill>
-                  <a:srgbClr val="F4F7F6"/>
+                  <a:srgbClr val="F4F7FB"/>
                 </a:solidFill>
                 <a:latin typeface="Calibri" pitchFamily="34" charset="0"/>
                 <a:ea typeface="Calibri" pitchFamily="34" charset="-122"/>
@@ -1998,7 +1998,7 @@
             <a:r>
               <a:rPr lang="en-US" sz="1150" dirty="0">
                 <a:solidFill>
-                  <a:srgbClr val="C5D4CF"/>
+                  <a:srgbClr val="C5D0E0"/>
                 </a:solidFill>
                 <a:latin typeface="Calibri" pitchFamily="34" charset="0"/>
                 <a:ea typeface="Calibri" pitchFamily="34" charset="-122"/>
@@ -2027,12 +2027,12 @@
             </a:avLst>
           </a:prstGeom>
           <a:solidFill>
-            <a:srgbClr val="0F5C4C"/>
+            <a:srgbClr val="1B4F8A"/>
           </a:solidFill>
           <a:ln/>
           <a:effectLst>
             <a:outerShdw sx="100000" sy="100000" kx="0" ky="0" algn="bl" rotWithShape="0" blurRad="127000" dist="25400" dir="5400000">
-              <a:srgbClr val="14211e">
+              <a:srgbClr val="102a43">
                 <a:alpha val="10000"/>
               </a:srgbClr>
             </a:outerShdw>
@@ -2066,7 +2066,7 @@
             <a:r>
               <a:rPr lang="en-US" sz="1500" b="1" dirty="0">
                 <a:solidFill>
-                  <a:srgbClr val="F4F7F6"/>
+                  <a:srgbClr val="F4F7FB"/>
                 </a:solidFill>
                 <a:latin typeface="Calibri" pitchFamily="34" charset="0"/>
                 <a:ea typeface="Calibri" pitchFamily="34" charset="-122"/>
@@ -2108,7 +2108,7 @@
             <a:r>
               <a:rPr lang="en-US" sz="1150" dirty="0">
                 <a:solidFill>
-                  <a:srgbClr val="C5D4CF"/>
+                  <a:srgbClr val="C5D0E0"/>
                 </a:solidFill>
                 <a:latin typeface="Calibri" pitchFamily="34" charset="0"/>
                 <a:ea typeface="Calibri" pitchFamily="34" charset="-122"/>
@@ -2137,12 +2137,12 @@
             </a:avLst>
           </a:prstGeom>
           <a:solidFill>
-            <a:srgbClr val="0F5C4C"/>
+            <a:srgbClr val="1B4F8A"/>
           </a:solidFill>
           <a:ln/>
           <a:effectLst>
             <a:outerShdw sx="100000" sy="100000" kx="0" ky="0" algn="bl" rotWithShape="0" blurRad="127000" dist="25400" dir="5400000">
-              <a:srgbClr val="14211e">
+              <a:srgbClr val="102a43">
                 <a:alpha val="10000"/>
               </a:srgbClr>
             </a:outerShdw>
@@ -2176,7 +2176,7 @@
             <a:r>
               <a:rPr lang="en-US" sz="1500" b="1" dirty="0">
                 <a:solidFill>
-                  <a:srgbClr val="F4F7F6"/>
+                  <a:srgbClr val="F4F7FB"/>
                 </a:solidFill>
                 <a:latin typeface="Calibri" pitchFamily="34" charset="0"/>
                 <a:ea typeface="Calibri" pitchFamily="34" charset="-122"/>
@@ -2218,7 +2218,7 @@
             <a:r>
               <a:rPr lang="en-US" sz="1150" dirty="0">
                 <a:solidFill>
-                  <a:srgbClr val="C5D4CF"/>
+                  <a:srgbClr val="C5D0E0"/>
                 </a:solidFill>
                 <a:latin typeface="Calibri" pitchFamily="34" charset="0"/>
                 <a:ea typeface="Calibri" pitchFamily="34" charset="-122"/>
@@ -2257,7 +2257,7 @@
             <a:r>
               <a:rPr lang="en-US" sz="1300" i="1" dirty="0">
                 <a:solidFill>
-                  <a:srgbClr val="C5D4CF"/>
+                  <a:srgbClr val="B8C7DB"/>
                 </a:solidFill>
                 <a:latin typeface="Calibri" pitchFamily="34" charset="0"/>
                 <a:ea typeface="Calibri" pitchFamily="34" charset="-122"/>
@@ -2283,7 +2283,7 @@
     <p:bg>
       <p:bgPr>
         <a:solidFill>
-          <a:srgbClr val="F4F7F6"/>
+          <a:srgbClr val="F4F7FB"/>
         </a:solidFill>
       </p:bgPr>
     </p:bg>
@@ -2328,7 +2328,7 @@
             <a:r>
               <a:rPr lang="en-US" sz="1150" b="1" spc="160" kern="0" dirty="0">
                 <a:solidFill>
-                  <a:srgbClr val="0F5C4C"/>
+                  <a:srgbClr val="1B4F8A"/>
                 </a:solidFill>
                 <a:latin typeface="Calibri" pitchFamily="34" charset="0"/>
                 <a:ea typeface="Calibri" pitchFamily="34" charset="-122"/>
@@ -2367,7 +2367,7 @@
             <a:r>
               <a:rPr lang="en-US" sz="3800" b="1" dirty="0">
                 <a:solidFill>
-                  <a:srgbClr val="14211E"/>
+                  <a:srgbClr val="102A43"/>
                 </a:solidFill>
                 <a:latin typeface="Cambria" pitchFamily="34" charset="0"/>
                 <a:ea typeface="Cambria" pitchFamily="34" charset="-122"/>
@@ -2400,13 +2400,13 @@
           </a:solidFill>
           <a:ln w="9525">
             <a:solidFill>
-              <a:srgbClr val="C5D4CF"/>
+              <a:srgbClr val="C5D0E0"/>
             </a:solidFill>
             <a:prstDash val="solid"/>
           </a:ln>
           <a:effectLst>
             <a:outerShdw sx="100000" sy="100000" kx="0" ky="0" algn="bl" rotWithShape="0" blurRad="127000" dist="25400" dir="5400000">
-              <a:srgbClr val="14211e">
+              <a:srgbClr val="102a43">
                 <a:alpha val="10000"/>
               </a:srgbClr>
             </a:outerShdw>
@@ -2440,7 +2440,7 @@
             <a:r>
               <a:rPr lang="en-US" sz="4000" b="1" dirty="0">
                 <a:solidFill>
-                  <a:srgbClr val="0F5C4C"/>
+                  <a:srgbClr val="1B4F8A"/>
                 </a:solidFill>
                 <a:latin typeface="Cambria" pitchFamily="34" charset="0"/>
                 <a:ea typeface="Cambria" pitchFamily="34" charset="-122"/>
@@ -2479,7 +2479,7 @@
             <a:r>
               <a:rPr lang="en-US" sz="1500" b="1" dirty="0">
                 <a:solidFill>
-                  <a:srgbClr val="14211E"/>
+                  <a:srgbClr val="102A43"/>
                 </a:solidFill>
                 <a:latin typeface="Calibri" pitchFamily="34" charset="0"/>
                 <a:ea typeface="Calibri" pitchFamily="34" charset="-122"/>
@@ -2521,7 +2521,7 @@
             <a:r>
               <a:rPr lang="en-US" sz="1250" dirty="0">
                 <a:solidFill>
-                  <a:srgbClr val="3D524C"/>
+                  <a:srgbClr val="3D5270"/>
                 </a:solidFill>
                 <a:latin typeface="Calibri" pitchFamily="34" charset="0"/>
                 <a:ea typeface="Calibri" pitchFamily="34" charset="-122"/>
@@ -2554,13 +2554,13 @@
           </a:solidFill>
           <a:ln w="9525">
             <a:solidFill>
-              <a:srgbClr val="C5D4CF"/>
+              <a:srgbClr val="C5D0E0"/>
             </a:solidFill>
             <a:prstDash val="solid"/>
           </a:ln>
           <a:effectLst>
             <a:outerShdw sx="100000" sy="100000" kx="0" ky="0" algn="bl" rotWithShape="0" blurRad="127000" dist="25400" dir="5400000">
-              <a:srgbClr val="14211e">
+              <a:srgbClr val="102a43">
                 <a:alpha val="10000"/>
               </a:srgbClr>
             </a:outerShdw>
@@ -2594,7 +2594,7 @@
             <a:r>
               <a:rPr lang="en-US" sz="4000" b="1" dirty="0">
                 <a:solidFill>
-                  <a:srgbClr val="0F5C4C"/>
+                  <a:srgbClr val="1B4F8A"/>
                 </a:solidFill>
                 <a:latin typeface="Cambria" pitchFamily="34" charset="0"/>
                 <a:ea typeface="Cambria" pitchFamily="34" charset="-122"/>
@@ -2633,7 +2633,7 @@
             <a:r>
               <a:rPr lang="en-US" sz="1500" b="1" dirty="0">
                 <a:solidFill>
-                  <a:srgbClr val="14211E"/>
+                  <a:srgbClr val="102A43"/>
                 </a:solidFill>
                 <a:latin typeface="Calibri" pitchFamily="34" charset="0"/>
                 <a:ea typeface="Calibri" pitchFamily="34" charset="-122"/>
@@ -2675,7 +2675,7 @@
             <a:r>
               <a:rPr lang="en-US" sz="1250" dirty="0">
                 <a:solidFill>
-                  <a:srgbClr val="3D524C"/>
+                  <a:srgbClr val="3D5270"/>
                 </a:solidFill>
                 <a:latin typeface="Calibri" pitchFamily="34" charset="0"/>
                 <a:ea typeface="Calibri" pitchFamily="34" charset="-122"/>
@@ -2708,13 +2708,13 @@
           </a:solidFill>
           <a:ln w="9525">
             <a:solidFill>
-              <a:srgbClr val="C5D4CF"/>
+              <a:srgbClr val="C5D0E0"/>
             </a:solidFill>
             <a:prstDash val="solid"/>
           </a:ln>
           <a:effectLst>
             <a:outerShdw sx="100000" sy="100000" kx="0" ky="0" algn="bl" rotWithShape="0" blurRad="127000" dist="25400" dir="5400000">
-              <a:srgbClr val="14211e">
+              <a:srgbClr val="102a43">
                 <a:alpha val="10000"/>
               </a:srgbClr>
             </a:outerShdw>
@@ -2748,7 +2748,7 @@
             <a:r>
               <a:rPr lang="en-US" sz="4000" b="1" dirty="0">
                 <a:solidFill>
-                  <a:srgbClr val="0F5C4C"/>
+                  <a:srgbClr val="1B4F8A"/>
                 </a:solidFill>
                 <a:latin typeface="Cambria" pitchFamily="34" charset="0"/>
                 <a:ea typeface="Cambria" pitchFamily="34" charset="-122"/>
@@ -2787,7 +2787,7 @@
             <a:r>
               <a:rPr lang="en-US" sz="1500" b="1" dirty="0">
                 <a:solidFill>
-                  <a:srgbClr val="14211E"/>
+                  <a:srgbClr val="102A43"/>
                 </a:solidFill>
                 <a:latin typeface="Calibri" pitchFamily="34" charset="0"/>
                 <a:ea typeface="Calibri" pitchFamily="34" charset="-122"/>
@@ -2829,7 +2829,7 @@
             <a:r>
               <a:rPr lang="en-US" sz="1250" dirty="0">
                 <a:solidFill>
-                  <a:srgbClr val="3D524C"/>
+                  <a:srgbClr val="3D5270"/>
                 </a:solidFill>
                 <a:latin typeface="Calibri" pitchFamily="34" charset="0"/>
                 <a:ea typeface="Calibri" pitchFamily="34" charset="-122"/>
@@ -2862,13 +2862,13 @@
           </a:solidFill>
           <a:ln w="9525">
             <a:solidFill>
-              <a:srgbClr val="C5D4CF"/>
+              <a:srgbClr val="C5D0E0"/>
             </a:solidFill>
             <a:prstDash val="solid"/>
           </a:ln>
           <a:effectLst>
             <a:outerShdw sx="100000" sy="100000" kx="0" ky="0" algn="bl" rotWithShape="0" blurRad="127000" dist="25400" dir="5400000">
-              <a:srgbClr val="14211e">
+              <a:srgbClr val="102a43">
                 <a:alpha val="10000"/>
               </a:srgbClr>
             </a:outerShdw>
@@ -2902,7 +2902,7 @@
             <a:r>
               <a:rPr lang="en-US" sz="1150" b="1" spc="140" kern="0" dirty="0">
                 <a:solidFill>
-                  <a:srgbClr val="0F5C4C"/>
+                  <a:srgbClr val="1B4F8A"/>
                 </a:solidFill>
                 <a:latin typeface="Calibri" pitchFamily="34" charset="0"/>
                 <a:ea typeface="Calibri" pitchFamily="34" charset="-122"/>
@@ -2944,7 +2944,7 @@
             <a:r>
               <a:rPr lang="en-US" sz="1400" dirty="0">
                 <a:solidFill>
-                  <a:srgbClr val="14211E"/>
+                  <a:srgbClr val="102A43"/>
                 </a:solidFill>
                 <a:latin typeface="Calibri" pitchFamily="34" charset="0"/>
                 <a:ea typeface="Calibri" pitchFamily="34" charset="-122"/>
@@ -2973,12 +2973,12 @@
             </a:avLst>
           </a:prstGeom>
           <a:solidFill>
-            <a:srgbClr val="14211E"/>
+            <a:srgbClr val="102A43"/>
           </a:solidFill>
           <a:ln/>
           <a:effectLst>
             <a:outerShdw sx="100000" sy="100000" kx="0" ky="0" algn="bl" rotWithShape="0" blurRad="127000" dist="25400" dir="5400000">
-              <a:srgbClr val="14211e">
+              <a:srgbClr val="102a43">
                 <a:alpha val="10000"/>
               </a:srgbClr>
             </a:outerShdw>
@@ -3012,13 +3012,13 @@
             <a:r>
               <a:rPr lang="en-US" sz="1600" b="1" dirty="0">
                 <a:solidFill>
-                  <a:srgbClr val="F4F7F6"/>
-                </a:solidFill>
-                <a:latin typeface="Calibri" pitchFamily="34" charset="0"/>
-                <a:ea typeface="Calibri" pitchFamily="34" charset="-122"/>
-                <a:cs typeface="Calibri" pitchFamily="34" charset="-120"/>
-              </a:rPr>
-              <a:t>Out of scope this pass</a:t>
+                  <a:srgbClr val="F4F7FB"/>
+                </a:solidFill>
+                <a:latin typeface="Calibri" pitchFamily="34" charset="0"/>
+                <a:ea typeface="Calibri" pitchFamily="34" charset="-122"/>
+                <a:cs typeface="Calibri" pitchFamily="34" charset="-120"/>
+              </a:rPr>
+              <a:t>SHA deferred</a:t>
             </a:r>
             <a:endParaRPr lang="en-US" sz="1600" dirty="0"/>
           </a:p>
@@ -3054,13 +3054,13 @@
             <a:r>
               <a:rPr lang="en-US" sz="1250" dirty="0">
                 <a:solidFill>
-                  <a:srgbClr val="C5D4CF"/>
-                </a:solidFill>
-                <a:latin typeface="Calibri" pitchFamily="34" charset="0"/>
-                <a:ea typeface="Calibri" pitchFamily="34" charset="-122"/>
-                <a:cs typeface="Calibri" pitchFamily="34" charset="-120"/>
-              </a:rPr>
-              <a:t>National insurance rails, claims and reimbursement integration. Deferred on purpose — the wedge is shifting load before the door, not moving money after it.</a:t>
+                  <a:srgbClr val="C5D0E0"/>
+                </a:solidFill>
+                <a:latin typeface="Calibri" pitchFamily="34" charset="0"/>
+                <a:ea typeface="Calibri" pitchFamily="34" charset="-122"/>
+                <a:cs typeface="Calibri" pitchFamily="34" charset="-120"/>
+              </a:rPr>
+              <a:t>SHA claims, AfyaKE and HIE stay out of this pass. The wedge is shifting load before the door, not moving money after it.</a:t>
             </a:r>
             <a:endParaRPr lang="en-US" sz="1250" dirty="0"/>
           </a:p>
@@ -3093,7 +3093,7 @@
             <a:r>
               <a:rPr lang="en-US" sz="1050" dirty="0">
                 <a:solidFill>
-                  <a:srgbClr val="3D524C"/>
+                  <a:srgbClr val="3D5270"/>
                 </a:solidFill>
                 <a:latin typeface="Calibri" pitchFamily="34" charset="0"/>
                 <a:ea typeface="Calibri" pitchFamily="34" charset="-122"/>
@@ -3119,7 +3119,7 @@
     <p:bg>
       <p:bgPr>
         <a:solidFill>
-          <a:srgbClr val="14211E"/>
+          <a:srgbClr val="102A43"/>
         </a:solidFill>
       </p:bgPr>
     </p:bg>
@@ -3167,7 +3167,7 @@
             <a:r>
               <a:rPr lang="en-US" sz="5600" b="1" dirty="0">
                 <a:solidFill>
-                  <a:srgbClr val="F4F7F6"/>
+                  <a:srgbClr val="F4F7FB"/>
                 </a:solidFill>
                 <a:latin typeface="Cambria" pitchFamily="34" charset="0"/>
                 <a:ea typeface="Cambria" pitchFamily="34" charset="-122"/>
@@ -3206,7 +3206,7 @@
             <a:r>
               <a:rPr lang="en-US" sz="2200" dirty="0">
                 <a:solidFill>
-                  <a:srgbClr val="C5D4CF"/>
+                  <a:srgbClr val="B8C7DB"/>
                 </a:solidFill>
                 <a:latin typeface="Calibri" pitchFamily="34" charset="0"/>
                 <a:ea typeface="Calibri" pitchFamily="34" charset="-122"/>
@@ -3245,7 +3245,7 @@
             <a:r>
               <a:rPr lang="en-US" sz="1250" spc="140" kern="0" dirty="0">
                 <a:solidFill>
-                  <a:srgbClr val="C5D4CF"/>
+                  <a:srgbClr val="B8C7DB"/>
                 </a:solidFill>
                 <a:latin typeface="Calibri" pitchFamily="34" charset="0"/>
                 <a:ea typeface="Calibri" pitchFamily="34" charset="-122"/>
@@ -3274,12 +3274,12 @@
             </a:avLst>
           </a:prstGeom>
           <a:solidFill>
-            <a:srgbClr val="0F5C4C"/>
+            <a:srgbClr val="1B4F8A"/>
           </a:solidFill>
           <a:ln/>
           <a:effectLst>
             <a:outerShdw sx="100000" sy="100000" kx="0" ky="0" algn="bl" rotWithShape="0" blurRad="127000" dist="25400" dir="5400000">
-              <a:srgbClr val="14211e">
+              <a:srgbClr val="102a43">
                 <a:alpha val="10000"/>
               </a:srgbClr>
             </a:outerShdw>
@@ -3313,7 +3313,7 @@
             <a:r>
               <a:rPr lang="en-US" sz="1700" b="1" dirty="0">
                 <a:solidFill>
-                  <a:srgbClr val="F4F7F6"/>
+                  <a:srgbClr val="F4F7FB"/>
                 </a:solidFill>
                 <a:latin typeface="Calibri" pitchFamily="34" charset="0"/>
                 <a:ea typeface="Calibri" pitchFamily="34" charset="-122"/>
@@ -3355,7 +3355,7 @@
             <a:r>
               <a:rPr lang="en-US" sz="1150" dirty="0">
                 <a:solidFill>
-                  <a:srgbClr val="C5D4CF"/>
+                  <a:srgbClr val="C5D0E0"/>
                 </a:solidFill>
                 <a:latin typeface="Calibri" pitchFamily="34" charset="0"/>
                 <a:ea typeface="Calibri" pitchFamily="34" charset="-122"/>
@@ -3384,12 +3384,12 @@
             </a:avLst>
           </a:prstGeom>
           <a:solidFill>
-            <a:srgbClr val="0F5C4C"/>
+            <a:srgbClr val="1B4F8A"/>
           </a:solidFill>
           <a:ln/>
           <a:effectLst>
             <a:outerShdw sx="100000" sy="100000" kx="0" ky="0" algn="bl" rotWithShape="0" blurRad="127000" dist="25400" dir="5400000">
-              <a:srgbClr val="14211e">
+              <a:srgbClr val="102a43">
                 <a:alpha val="10000"/>
               </a:srgbClr>
             </a:outerShdw>
@@ -3423,7 +3423,7 @@
             <a:r>
               <a:rPr lang="en-US" sz="1700" b="1" dirty="0">
                 <a:solidFill>
-                  <a:srgbClr val="F4F7F6"/>
+                  <a:srgbClr val="F4F7FB"/>
                 </a:solidFill>
                 <a:latin typeface="Calibri" pitchFamily="34" charset="0"/>
                 <a:ea typeface="Calibri" pitchFamily="34" charset="-122"/>
@@ -3465,7 +3465,7 @@
             <a:r>
               <a:rPr lang="en-US" sz="1150" dirty="0">
                 <a:solidFill>
-                  <a:srgbClr val="C5D4CF"/>
+                  <a:srgbClr val="C5D0E0"/>
                 </a:solidFill>
                 <a:latin typeface="Calibri" pitchFamily="34" charset="0"/>
                 <a:ea typeface="Calibri" pitchFamily="34" charset="-122"/>
@@ -3491,7 +3491,7 @@
     <p:bg>
       <p:bgPr>
         <a:solidFill>
-          <a:srgbClr val="F4F7F6"/>
+          <a:srgbClr val="F4F7FB"/>
         </a:solidFill>
       </p:bgPr>
     </p:bg>
@@ -3536,7 +3536,7 @@
             <a:r>
               <a:rPr lang="en-US" sz="1150" b="1" spc="160" kern="0" dirty="0">
                 <a:solidFill>
-                  <a:srgbClr val="0F5C4C"/>
+                  <a:srgbClr val="1B4F8A"/>
                 </a:solidFill>
                 <a:latin typeface="Calibri" pitchFamily="34" charset="0"/>
                 <a:ea typeface="Calibri" pitchFamily="34" charset="-122"/>
@@ -3575,7 +3575,7 @@
             <a:r>
               <a:rPr lang="en-US" sz="3800" b="1" dirty="0">
                 <a:solidFill>
-                  <a:srgbClr val="14211E"/>
+                  <a:srgbClr val="102A43"/>
                 </a:solidFill>
                 <a:latin typeface="Cambria" pitchFamily="34" charset="0"/>
                 <a:ea typeface="Cambria" pitchFamily="34" charset="-122"/>
@@ -3614,7 +3614,7 @@
             <a:r>
               <a:rPr lang="en-US" sz="7200" b="1" dirty="0">
                 <a:solidFill>
-                  <a:srgbClr val="0F5C4C"/>
+                  <a:srgbClr val="1B4F8A"/>
                 </a:solidFill>
                 <a:latin typeface="Cambria" pitchFamily="34" charset="0"/>
                 <a:ea typeface="Cambria" pitchFamily="34" charset="-122"/>
@@ -3653,7 +3653,7 @@
             <a:r>
               <a:rPr lang="en-US" sz="1800" b="1" dirty="0">
                 <a:solidFill>
-                  <a:srgbClr val="14211E"/>
+                  <a:srgbClr val="102A43"/>
                 </a:solidFill>
                 <a:latin typeface="Calibri" pitchFamily="34" charset="0"/>
                 <a:ea typeface="Calibri" pitchFamily="34" charset="-122"/>
@@ -3695,7 +3695,7 @@
             <a:r>
               <a:rPr lang="en-US" sz="1500" dirty="0">
                 <a:solidFill>
-                  <a:srgbClr val="3D524C"/>
+                  <a:srgbClr val="3D5270"/>
                 </a:solidFill>
                 <a:latin typeface="Calibri" pitchFamily="34" charset="0"/>
                 <a:ea typeface="Calibri" pitchFamily="34" charset="-122"/>
@@ -3728,13 +3728,13 @@
           </a:solidFill>
           <a:ln w="9525">
             <a:solidFill>
-              <a:srgbClr val="C5D4CF"/>
+              <a:srgbClr val="C5D0E0"/>
             </a:solidFill>
             <a:prstDash val="solid"/>
           </a:ln>
           <a:effectLst>
             <a:outerShdw sx="100000" sy="100000" kx="0" ky="0" algn="bl" rotWithShape="0" blurRad="127000" dist="25400" dir="5400000">
-              <a:srgbClr val="14211e">
+              <a:srgbClr val="102a43">
                 <a:alpha val="10000"/>
               </a:srgbClr>
             </a:outerShdw>
@@ -3768,7 +3768,7 @@
             <a:r>
               <a:rPr lang="en-US" sz="1150" b="1" spc="140" kern="0" dirty="0">
                 <a:solidFill>
-                  <a:srgbClr val="0F5C4C"/>
+                  <a:srgbClr val="1B4F8A"/>
                 </a:solidFill>
                 <a:latin typeface="Calibri" pitchFamily="34" charset="0"/>
                 <a:ea typeface="Calibri" pitchFamily="34" charset="-122"/>
@@ -3797,17 +3797,17 @@
             </a:avLst>
           </a:prstGeom>
           <a:solidFill>
-            <a:srgbClr val="F4F7F6"/>
+            <a:srgbClr val="F4F7FB"/>
           </a:solidFill>
           <a:ln w="9525">
             <a:solidFill>
-              <a:srgbClr val="C5D4CF"/>
+              <a:srgbClr val="C5D0E0"/>
             </a:solidFill>
             <a:prstDash val="solid"/>
           </a:ln>
           <a:effectLst>
             <a:outerShdw sx="100000" sy="100000" kx="0" ky="0" algn="bl" rotWithShape="0" blurRad="127000" dist="25400" dir="5400000">
-              <a:srgbClr val="14211e">
+              <a:srgbClr val="102a43">
                 <a:alpha val="10000"/>
               </a:srgbClr>
             </a:outerShdw>
@@ -3841,7 +3841,7 @@
             <a:r>
               <a:rPr lang="en-US" sz="1350" b="1" dirty="0">
                 <a:solidFill>
-                  <a:srgbClr val="14211E"/>
+                  <a:srgbClr val="102A43"/>
                 </a:solidFill>
                 <a:latin typeface="Calibri" pitchFamily="34" charset="0"/>
                 <a:ea typeface="Calibri" pitchFamily="34" charset="-122"/>
@@ -3880,7 +3880,7 @@
             <a:r>
               <a:rPr lang="en-US" sz="1100" dirty="0">
                 <a:solidFill>
-                  <a:srgbClr val="3D524C"/>
+                  <a:srgbClr val="3D5270"/>
                 </a:solidFill>
                 <a:latin typeface="Calibri" pitchFamily="34" charset="0"/>
                 <a:ea typeface="Calibri" pitchFamily="34" charset="-122"/>
@@ -3909,17 +3909,17 @@
             </a:avLst>
           </a:prstGeom>
           <a:solidFill>
-            <a:srgbClr val="F4F7F6"/>
+            <a:srgbClr val="F4F7FB"/>
           </a:solidFill>
           <a:ln w="9525">
             <a:solidFill>
-              <a:srgbClr val="C5D4CF"/>
+              <a:srgbClr val="C5D0E0"/>
             </a:solidFill>
             <a:prstDash val="solid"/>
           </a:ln>
           <a:effectLst>
             <a:outerShdw sx="100000" sy="100000" kx="0" ky="0" algn="bl" rotWithShape="0" blurRad="127000" dist="25400" dir="5400000">
-              <a:srgbClr val="14211e">
+              <a:srgbClr val="102a43">
                 <a:alpha val="10000"/>
               </a:srgbClr>
             </a:outerShdw>
@@ -3953,7 +3953,7 @@
             <a:r>
               <a:rPr lang="en-US" sz="1350" b="1" dirty="0">
                 <a:solidFill>
-                  <a:srgbClr val="14211E"/>
+                  <a:srgbClr val="102A43"/>
                 </a:solidFill>
                 <a:latin typeface="Calibri" pitchFamily="34" charset="0"/>
                 <a:ea typeface="Calibri" pitchFamily="34" charset="-122"/>
@@ -3992,7 +3992,7 @@
             <a:r>
               <a:rPr lang="en-US" sz="1100" dirty="0">
                 <a:solidFill>
-                  <a:srgbClr val="3D524C"/>
+                  <a:srgbClr val="3D5270"/>
                 </a:solidFill>
                 <a:latin typeface="Calibri" pitchFamily="34" charset="0"/>
                 <a:ea typeface="Calibri" pitchFamily="34" charset="-122"/>
@@ -4021,12 +4021,12 @@
             </a:avLst>
           </a:prstGeom>
           <a:solidFill>
-            <a:srgbClr val="0F5C4C"/>
+            <a:srgbClr val="1B4F8A"/>
           </a:solidFill>
           <a:ln/>
           <a:effectLst>
             <a:outerShdw sx="100000" sy="100000" kx="0" ky="0" algn="bl" rotWithShape="0" blurRad="127000" dist="25400" dir="5400000">
-              <a:srgbClr val="14211e">
+              <a:srgbClr val="102a43">
                 <a:alpha val="10000"/>
               </a:srgbClr>
             </a:outerShdw>
@@ -4060,7 +4060,7 @@
             <a:r>
               <a:rPr lang="en-US" sz="1350" b="1" dirty="0">
                 <a:solidFill>
-                  <a:srgbClr val="F4F7F6"/>
+                  <a:srgbClr val="F4F7FB"/>
                 </a:solidFill>
                 <a:latin typeface="Calibri" pitchFamily="34" charset="0"/>
                 <a:ea typeface="Calibri" pitchFamily="34" charset="-122"/>
@@ -4099,7 +4099,7 @@
             <a:r>
               <a:rPr lang="en-US" sz="1100" dirty="0">
                 <a:solidFill>
-                  <a:srgbClr val="C5D4CF"/>
+                  <a:srgbClr val="C5D0E0"/>
                 </a:solidFill>
                 <a:latin typeface="Calibri" pitchFamily="34" charset="0"/>
                 <a:ea typeface="Calibri" pitchFamily="34" charset="-122"/>
@@ -4162,7 +4162,7 @@
             <a:r>
               <a:rPr lang="en-US" sz="1050" dirty="0">
                 <a:solidFill>
-                  <a:srgbClr val="3D524C"/>
+                  <a:srgbClr val="3D5270"/>
                 </a:solidFill>
                 <a:latin typeface="Calibri" pitchFamily="34" charset="0"/>
                 <a:ea typeface="Calibri" pitchFamily="34" charset="-122"/>
@@ -4188,7 +4188,7 @@
     <p:bg>
       <p:bgPr>
         <a:solidFill>
-          <a:srgbClr val="F4F7F6"/>
+          <a:srgbClr val="F4F7FB"/>
         </a:solidFill>
       </p:bgPr>
     </p:bg>
@@ -4233,7 +4233,7 @@
             <a:r>
               <a:rPr lang="en-US" sz="1150" b="1" spc="160" kern="0" dirty="0">
                 <a:solidFill>
-                  <a:srgbClr val="0F5C4C"/>
+                  <a:srgbClr val="1B4F8A"/>
                 </a:solidFill>
                 <a:latin typeface="Calibri" pitchFamily="34" charset="0"/>
                 <a:ea typeface="Calibri" pitchFamily="34" charset="-122"/>
@@ -4272,7 +4272,7 @@
             <a:r>
               <a:rPr lang="en-US" sz="3800" b="1" dirty="0">
                 <a:solidFill>
-                  <a:srgbClr val="14211E"/>
+                  <a:srgbClr val="102A43"/>
                 </a:solidFill>
                 <a:latin typeface="Cambria" pitchFamily="34" charset="0"/>
                 <a:ea typeface="Cambria" pitchFamily="34" charset="-122"/>
@@ -4293,11 +4293,11 @@
         <p:spPr>
           <a:xfrm>
             <a:off x="548640" y="1874520"/>
-            <a:ext cx="3447288" cy="2651760"/>
+            <a:ext cx="3447288" cy="2377440"/>
           </a:xfrm>
           <a:prstGeom prst="roundRect">
             <a:avLst>
-              <a:gd name="adj" fmla="val 4828"/>
+              <a:gd name="adj" fmla="val 5385"/>
             </a:avLst>
           </a:prstGeom>
           <a:solidFill>
@@ -4305,13 +4305,13 @@
           </a:solidFill>
           <a:ln w="9525">
             <a:solidFill>
-              <a:srgbClr val="C5D4CF"/>
+              <a:srgbClr val="C5D0E0"/>
             </a:solidFill>
             <a:prstDash val="solid"/>
           </a:ln>
           <a:effectLst>
             <a:outerShdw sx="100000" sy="100000" kx="0" ky="0" algn="bl" rotWithShape="0" blurRad="127000" dist="25400" dir="5400000">
-              <a:srgbClr val="14211e">
+              <a:srgbClr val="102a43">
                 <a:alpha val="10000"/>
               </a:srgbClr>
             </a:outerShdw>
@@ -4345,7 +4345,7 @@
             <a:r>
               <a:rPr lang="en-US" sz="5400" b="1" dirty="0">
                 <a:solidFill>
-                  <a:srgbClr val="0F5C4C"/>
+                  <a:srgbClr val="1B4F8A"/>
                 </a:solidFill>
                 <a:latin typeface="Cambria" pitchFamily="34" charset="0"/>
                 <a:ea typeface="Cambria" pitchFamily="34" charset="-122"/>
@@ -4384,7 +4384,7 @@
             <a:r>
               <a:rPr lang="en-US" sz="1500" b="1" dirty="0">
                 <a:solidFill>
-                  <a:srgbClr val="14211E"/>
+                  <a:srgbClr val="102A43"/>
                 </a:solidFill>
                 <a:latin typeface="Calibri" pitchFamily="34" charset="0"/>
                 <a:ea typeface="Calibri" pitchFamily="34" charset="-122"/>
@@ -4405,7 +4405,7 @@
         <p:spPr>
           <a:xfrm>
             <a:off x="841248" y="3593592"/>
-            <a:ext cx="2862072" cy="749808"/>
+            <a:ext cx="2862072" cy="475488"/>
           </a:xfrm>
           <a:prstGeom prst="rect">
             <a:avLst/>
@@ -4426,7 +4426,7 @@
             <a:r>
               <a:rPr lang="en-US" sz="1250" dirty="0">
                 <a:solidFill>
-                  <a:srgbClr val="3D524C"/>
+                  <a:srgbClr val="3D5270"/>
                 </a:solidFill>
                 <a:latin typeface="Calibri" pitchFamily="34" charset="0"/>
                 <a:ea typeface="Calibri" pitchFamily="34" charset="-122"/>
@@ -4447,11 +4447,11 @@
         <p:spPr>
           <a:xfrm>
             <a:off x="4361688" y="1874520"/>
-            <a:ext cx="3447288" cy="2651760"/>
+            <a:ext cx="3447288" cy="2377440"/>
           </a:xfrm>
           <a:prstGeom prst="roundRect">
             <a:avLst>
-              <a:gd name="adj" fmla="val 4828"/>
+              <a:gd name="adj" fmla="val 5385"/>
             </a:avLst>
           </a:prstGeom>
           <a:solidFill>
@@ -4459,13 +4459,13 @@
           </a:solidFill>
           <a:ln w="9525">
             <a:solidFill>
-              <a:srgbClr val="C5D4CF"/>
+              <a:srgbClr val="C5D0E0"/>
             </a:solidFill>
             <a:prstDash val="solid"/>
           </a:ln>
           <a:effectLst>
             <a:outerShdw sx="100000" sy="100000" kx="0" ky="0" algn="bl" rotWithShape="0" blurRad="127000" dist="25400" dir="5400000">
-              <a:srgbClr val="14211e">
+              <a:srgbClr val="102a43">
                 <a:alpha val="10000"/>
               </a:srgbClr>
             </a:outerShdw>
@@ -4499,7 +4499,7 @@
             <a:r>
               <a:rPr lang="en-US" sz="5400" b="1" dirty="0">
                 <a:solidFill>
-                  <a:srgbClr val="0F5C4C"/>
+                  <a:srgbClr val="1B4F8A"/>
                 </a:solidFill>
                 <a:latin typeface="Cambria" pitchFamily="34" charset="0"/>
                 <a:ea typeface="Cambria" pitchFamily="34" charset="-122"/>
@@ -4538,7 +4538,7 @@
             <a:r>
               <a:rPr lang="en-US" sz="1500" b="1" dirty="0">
                 <a:solidFill>
-                  <a:srgbClr val="14211E"/>
+                  <a:srgbClr val="102A43"/>
                 </a:solidFill>
                 <a:latin typeface="Calibri" pitchFamily="34" charset="0"/>
                 <a:ea typeface="Calibri" pitchFamily="34" charset="-122"/>
@@ -4559,7 +4559,7 @@
         <p:spPr>
           <a:xfrm>
             <a:off x="4654296" y="3593592"/>
-            <a:ext cx="2862072" cy="749808"/>
+            <a:ext cx="2862072" cy="475488"/>
           </a:xfrm>
           <a:prstGeom prst="rect">
             <a:avLst/>
@@ -4580,7 +4580,7 @@
             <a:r>
               <a:rPr lang="en-US" sz="1250" dirty="0">
                 <a:solidFill>
-                  <a:srgbClr val="3D524C"/>
+                  <a:srgbClr val="3D5270"/>
                 </a:solidFill>
                 <a:latin typeface="Calibri" pitchFamily="34" charset="0"/>
                 <a:ea typeface="Calibri" pitchFamily="34" charset="-122"/>
@@ -4601,11 +4601,11 @@
         <p:spPr>
           <a:xfrm>
             <a:off x="8174736" y="1874520"/>
-            <a:ext cx="3447288" cy="2651760"/>
+            <a:ext cx="3447288" cy="2377440"/>
           </a:xfrm>
           <a:prstGeom prst="roundRect">
             <a:avLst>
-              <a:gd name="adj" fmla="val 4828"/>
+              <a:gd name="adj" fmla="val 5385"/>
             </a:avLst>
           </a:prstGeom>
           <a:solidFill>
@@ -4613,13 +4613,13 @@
           </a:solidFill>
           <a:ln w="9525">
             <a:solidFill>
-              <a:srgbClr val="C5D4CF"/>
+              <a:srgbClr val="C5D0E0"/>
             </a:solidFill>
             <a:prstDash val="solid"/>
           </a:ln>
           <a:effectLst>
             <a:outerShdw sx="100000" sy="100000" kx="0" ky="0" algn="bl" rotWithShape="0" blurRad="127000" dist="25400" dir="5400000">
-              <a:srgbClr val="14211e">
+              <a:srgbClr val="102a43">
                 <a:alpha val="10000"/>
               </a:srgbClr>
             </a:outerShdw>
@@ -4653,7 +4653,7 @@
             <a:r>
               <a:rPr lang="en-US" sz="5400" b="1" dirty="0">
                 <a:solidFill>
-                  <a:srgbClr val="0F5C4C"/>
+                  <a:srgbClr val="1B4F8A"/>
                 </a:solidFill>
                 <a:latin typeface="Cambria" pitchFamily="34" charset="0"/>
                 <a:ea typeface="Cambria" pitchFamily="34" charset="-122"/>
@@ -4692,7 +4692,7 @@
             <a:r>
               <a:rPr lang="en-US" sz="1500" b="1" dirty="0">
                 <a:solidFill>
-                  <a:srgbClr val="14211E"/>
+                  <a:srgbClr val="102A43"/>
                 </a:solidFill>
                 <a:latin typeface="Calibri" pitchFamily="34" charset="0"/>
                 <a:ea typeface="Calibri" pitchFamily="34" charset="-122"/>
@@ -4713,7 +4713,7 @@
         <p:spPr>
           <a:xfrm>
             <a:off x="8467344" y="3593592"/>
-            <a:ext cx="2862072" cy="749808"/>
+            <a:ext cx="2862072" cy="475488"/>
           </a:xfrm>
           <a:prstGeom prst="rect">
             <a:avLst/>
@@ -4734,13 +4734,13 @@
             <a:r>
               <a:rPr lang="en-US" sz="1250" dirty="0">
                 <a:solidFill>
-                  <a:srgbClr val="3D524C"/>
-                </a:solidFill>
-                <a:latin typeface="Calibri" pitchFamily="34" charset="0"/>
-                <a:ea typeface="Calibri" pitchFamily="34" charset="-122"/>
-                <a:cs typeface="Calibri" pitchFamily="34" charset="-120"/>
-              </a:rPr>
-              <a:t>About 1,000 outpatients through the door every day.</a:t>
+                  <a:srgbClr val="3D5270"/>
+                </a:solidFill>
+                <a:latin typeface="Calibri" pitchFamily="34" charset="0"/>
+                <a:ea typeface="Calibri" pitchFamily="34" charset="-122"/>
+                <a:cs typeface="Calibri" pitchFamily="34" charset="-120"/>
+              </a:rPr>
+              <a:t>~1,000 outpatients through the door every day.</a:t>
             </a:r>
             <a:endParaRPr lang="en-US" sz="1250" dirty="0"/>
           </a:p>
@@ -4754,7 +4754,7 @@
         </p:nvSpPr>
         <p:spPr>
           <a:xfrm>
-            <a:off x="548640" y="4754880"/>
+            <a:off x="548640" y="4572000"/>
             <a:ext cx="10607040" cy="822960"/>
           </a:xfrm>
           <a:prstGeom prst="rect">
@@ -4776,7 +4776,7 @@
             <a:r>
               <a:rPr lang="en-US" sz="1600" dirty="0">
                 <a:solidFill>
-                  <a:srgbClr val="14211E"/>
+                  <a:srgbClr val="102A43"/>
                 </a:solidFill>
                 <a:latin typeface="Calibri" pitchFamily="34" charset="0"/>
                 <a:ea typeface="Calibri" pitchFamily="34" charset="-122"/>
@@ -4815,7 +4815,7 @@
             <a:r>
               <a:rPr lang="en-US" sz="1050" dirty="0">
                 <a:solidFill>
-                  <a:srgbClr val="3D524C"/>
+                  <a:srgbClr val="3D5270"/>
                 </a:solidFill>
                 <a:latin typeface="Calibri" pitchFamily="34" charset="0"/>
                 <a:ea typeface="Calibri" pitchFamily="34" charset="-122"/>
@@ -4841,7 +4841,7 @@
     <p:bg>
       <p:bgPr>
         <a:solidFill>
-          <a:srgbClr val="F4F7F6"/>
+          <a:srgbClr val="F4F7FB"/>
         </a:solidFill>
       </p:bgPr>
     </p:bg>
@@ -4886,7 +4886,7 @@
             <a:r>
               <a:rPr lang="en-US" sz="1150" b="1" spc="160" kern="0" dirty="0">
                 <a:solidFill>
-                  <a:srgbClr val="0F5C4C"/>
+                  <a:srgbClr val="1B4F8A"/>
                 </a:solidFill>
                 <a:latin typeface="Calibri" pitchFamily="34" charset="0"/>
                 <a:ea typeface="Calibri" pitchFamily="34" charset="-122"/>
@@ -4925,7 +4925,7 @@
             <a:r>
               <a:rPr lang="en-US" sz="3800" b="1" dirty="0">
                 <a:solidFill>
-                  <a:srgbClr val="14211E"/>
+                  <a:srgbClr val="102A43"/>
                 </a:solidFill>
                 <a:latin typeface="Cambria" pitchFamily="34" charset="0"/>
                 <a:ea typeface="Cambria" pitchFamily="34" charset="-122"/>
@@ -4946,11 +4946,11 @@
         <p:spPr>
           <a:xfrm>
             <a:off x="548640" y="1828800"/>
-            <a:ext cx="2039112" cy="2103120"/>
+            <a:ext cx="2039112" cy="1874520"/>
           </a:xfrm>
           <a:prstGeom prst="roundRect">
             <a:avLst>
-              <a:gd name="adj" fmla="val 6278"/>
+              <a:gd name="adj" fmla="val 6829"/>
             </a:avLst>
           </a:prstGeom>
           <a:solidFill>
@@ -4958,13 +4958,13 @@
           </a:solidFill>
           <a:ln w="9525">
             <a:solidFill>
-              <a:srgbClr val="C5D4CF"/>
+              <a:srgbClr val="C5D0E0"/>
             </a:solidFill>
             <a:prstDash val="solid"/>
           </a:ln>
           <a:effectLst>
             <a:outerShdw sx="100000" sy="100000" kx="0" ky="0" algn="bl" rotWithShape="0" blurRad="127000" dist="25400" dir="5400000">
-              <a:srgbClr val="14211e">
+              <a:srgbClr val="102a43">
                 <a:alpha val="10000"/>
               </a:srgbClr>
             </a:outerShdw>
@@ -4998,7 +4998,7 @@
             <a:r>
               <a:rPr lang="en-US" sz="4400" b="1" dirty="0">
                 <a:solidFill>
-                  <a:srgbClr val="0F5C4C"/>
+                  <a:srgbClr val="1B4F8A"/>
                 </a:solidFill>
                 <a:latin typeface="Cambria" pitchFamily="34" charset="0"/>
                 <a:ea typeface="Cambria" pitchFamily="34" charset="-122"/>
@@ -5037,7 +5037,7 @@
             <a:r>
               <a:rPr lang="en-US" sz="1500" b="1" dirty="0">
                 <a:solidFill>
-                  <a:srgbClr val="14211E"/>
+                  <a:srgbClr val="102A43"/>
                 </a:solidFill>
                 <a:latin typeface="Calibri" pitchFamily="34" charset="0"/>
                 <a:ea typeface="Calibri" pitchFamily="34" charset="-122"/>
@@ -5076,7 +5076,7 @@
             <a:r>
               <a:rPr lang="en-US" sz="1200" dirty="0">
                 <a:solidFill>
-                  <a:srgbClr val="3D524C"/>
+                  <a:srgbClr val="3D5270"/>
                 </a:solidFill>
                 <a:latin typeface="Calibri" pitchFamily="34" charset="0"/>
                 <a:ea typeface="Calibri" pitchFamily="34" charset="-122"/>
@@ -5097,11 +5097,11 @@
         <p:spPr>
           <a:xfrm>
             <a:off x="2862072" y="1828800"/>
-            <a:ext cx="2039112" cy="2103120"/>
+            <a:ext cx="2039112" cy="1874520"/>
           </a:xfrm>
           <a:prstGeom prst="roundRect">
             <a:avLst>
-              <a:gd name="adj" fmla="val 6278"/>
+              <a:gd name="adj" fmla="val 6829"/>
             </a:avLst>
           </a:prstGeom>
           <a:solidFill>
@@ -5109,13 +5109,13 @@
           </a:solidFill>
           <a:ln w="9525">
             <a:solidFill>
-              <a:srgbClr val="C5D4CF"/>
+              <a:srgbClr val="C5D0E0"/>
             </a:solidFill>
             <a:prstDash val="solid"/>
           </a:ln>
           <a:effectLst>
             <a:outerShdw sx="100000" sy="100000" kx="0" ky="0" algn="bl" rotWithShape="0" blurRad="127000" dist="25400" dir="5400000">
-              <a:srgbClr val="14211e">
+              <a:srgbClr val="102a43">
                 <a:alpha val="10000"/>
               </a:srgbClr>
             </a:outerShdw>
@@ -5149,7 +5149,7 @@
             <a:r>
               <a:rPr lang="en-US" sz="4400" b="1" dirty="0">
                 <a:solidFill>
-                  <a:srgbClr val="0F5C4C"/>
+                  <a:srgbClr val="1B4F8A"/>
                 </a:solidFill>
                 <a:latin typeface="Cambria" pitchFamily="34" charset="0"/>
                 <a:ea typeface="Cambria" pitchFamily="34" charset="-122"/>
@@ -5188,7 +5188,7 @@
             <a:r>
               <a:rPr lang="en-US" sz="1500" b="1" dirty="0">
                 <a:solidFill>
-                  <a:srgbClr val="14211E"/>
+                  <a:srgbClr val="102A43"/>
                 </a:solidFill>
                 <a:latin typeface="Calibri" pitchFamily="34" charset="0"/>
                 <a:ea typeface="Calibri" pitchFamily="34" charset="-122"/>
@@ -5227,7 +5227,7 @@
             <a:r>
               <a:rPr lang="en-US" sz="1200" dirty="0">
                 <a:solidFill>
-                  <a:srgbClr val="3D524C"/>
+                  <a:srgbClr val="3D5270"/>
                 </a:solidFill>
                 <a:latin typeface="Calibri" pitchFamily="34" charset="0"/>
                 <a:ea typeface="Calibri" pitchFamily="34" charset="-122"/>
@@ -5248,11 +5248,11 @@
         <p:spPr>
           <a:xfrm>
             <a:off x="5175504" y="1828800"/>
-            <a:ext cx="2039112" cy="2103120"/>
+            <a:ext cx="2039112" cy="1874520"/>
           </a:xfrm>
           <a:prstGeom prst="roundRect">
             <a:avLst>
-              <a:gd name="adj" fmla="val 6278"/>
+              <a:gd name="adj" fmla="val 6829"/>
             </a:avLst>
           </a:prstGeom>
           <a:solidFill>
@@ -5260,13 +5260,13 @@
           </a:solidFill>
           <a:ln w="9525">
             <a:solidFill>
-              <a:srgbClr val="C5D4CF"/>
+              <a:srgbClr val="C5D0E0"/>
             </a:solidFill>
             <a:prstDash val="solid"/>
           </a:ln>
           <a:effectLst>
             <a:outerShdw sx="100000" sy="100000" kx="0" ky="0" algn="bl" rotWithShape="0" blurRad="127000" dist="25400" dir="5400000">
-              <a:srgbClr val="14211e">
+              <a:srgbClr val="102a43">
                 <a:alpha val="10000"/>
               </a:srgbClr>
             </a:outerShdw>
@@ -5300,7 +5300,7 @@
             <a:r>
               <a:rPr lang="en-US" sz="4400" b="1" dirty="0">
                 <a:solidFill>
-                  <a:srgbClr val="0F5C4C"/>
+                  <a:srgbClr val="1B4F8A"/>
                 </a:solidFill>
                 <a:latin typeface="Cambria" pitchFamily="34" charset="0"/>
                 <a:ea typeface="Cambria" pitchFamily="34" charset="-122"/>
@@ -5339,7 +5339,7 @@
             <a:r>
               <a:rPr lang="en-US" sz="1500" b="1" dirty="0">
                 <a:solidFill>
-                  <a:srgbClr val="14211E"/>
+                  <a:srgbClr val="102A43"/>
                 </a:solidFill>
                 <a:latin typeface="Calibri" pitchFamily="34" charset="0"/>
                 <a:ea typeface="Calibri" pitchFamily="34" charset="-122"/>
@@ -5378,7 +5378,7 @@
             <a:r>
               <a:rPr lang="en-US" sz="1200" dirty="0">
                 <a:solidFill>
-                  <a:srgbClr val="3D524C"/>
+                  <a:srgbClr val="3D5270"/>
                 </a:solidFill>
                 <a:latin typeface="Calibri" pitchFamily="34" charset="0"/>
                 <a:ea typeface="Calibri" pitchFamily="34" charset="-122"/>
@@ -5398,7 +5398,7 @@
         </p:nvSpPr>
         <p:spPr>
           <a:xfrm>
-            <a:off x="548640" y="4160520"/>
+            <a:off x="548640" y="3977640"/>
             <a:ext cx="6675120" cy="1005840"/>
           </a:xfrm>
           <a:prstGeom prst="rect">
@@ -5420,7 +5420,7 @@
             <a:r>
               <a:rPr lang="en-US" sz="1600" dirty="0">
                 <a:solidFill>
-                  <a:srgbClr val="14211E"/>
+                  <a:srgbClr val="102A43"/>
                 </a:solidFill>
                 <a:latin typeface="Calibri" pitchFamily="34" charset="0"/>
                 <a:ea typeface="Calibri" pitchFamily="34" charset="-122"/>
@@ -5454,7 +5454,7 @@
           <a:ln/>
           <a:effectLst>
             <a:outerShdw sx="100000" sy="100000" kx="0" ky="0" algn="bl" rotWithShape="0" blurRad="127000" dist="25400" dir="5400000">
-              <a:srgbClr val="14211e">
+              <a:srgbClr val="102a43">
                 <a:alpha val="10000"/>
               </a:srgbClr>
             </a:outerShdw>
@@ -5566,7 +5566,7 @@
             <a:r>
               <a:rPr lang="en-US" sz="1400" b="1" dirty="0">
                 <a:solidFill>
-                  <a:srgbClr val="14211E"/>
+                  <a:srgbClr val="102A43"/>
                 </a:solidFill>
                 <a:latin typeface="Calibri" pitchFamily="34" charset="0"/>
                 <a:ea typeface="Calibri" pitchFamily="34" charset="-122"/>
@@ -5608,7 +5608,7 @@
             <a:r>
               <a:rPr lang="en-US" sz="1200" dirty="0">
                 <a:solidFill>
-                  <a:srgbClr val="3D524C"/>
+                  <a:srgbClr val="3D5270"/>
                 </a:solidFill>
                 <a:latin typeface="Calibri" pitchFamily="34" charset="0"/>
                 <a:ea typeface="Calibri" pitchFamily="34" charset="-122"/>
@@ -5647,7 +5647,7 @@
             <a:r>
               <a:rPr lang="en-US" sz="1050" dirty="0">
                 <a:solidFill>
-                  <a:srgbClr val="3D524C"/>
+                  <a:srgbClr val="3D5270"/>
                 </a:solidFill>
                 <a:latin typeface="Calibri" pitchFamily="34" charset="0"/>
                 <a:ea typeface="Calibri" pitchFamily="34" charset="-122"/>
@@ -5673,7 +5673,7 @@
     <p:bg>
       <p:bgPr>
         <a:solidFill>
-          <a:srgbClr val="F4F7F6"/>
+          <a:srgbClr val="F4F7FB"/>
         </a:solidFill>
       </p:bgPr>
     </p:bg>
@@ -5718,7 +5718,7 @@
             <a:r>
               <a:rPr lang="en-US" sz="1150" b="1" spc="160" kern="0" dirty="0">
                 <a:solidFill>
-                  <a:srgbClr val="0F5C4C"/>
+                  <a:srgbClr val="1B4F8A"/>
                 </a:solidFill>
                 <a:latin typeface="Calibri" pitchFamily="34" charset="0"/>
                 <a:ea typeface="Calibri" pitchFamily="34" charset="-122"/>
@@ -5757,7 +5757,7 @@
             <a:r>
               <a:rPr lang="en-US" sz="3800" b="1" dirty="0">
                 <a:solidFill>
-                  <a:srgbClr val="14211E"/>
+                  <a:srgbClr val="102A43"/>
                 </a:solidFill>
                 <a:latin typeface="Cambria" pitchFamily="34" charset="0"/>
                 <a:ea typeface="Cambria" pitchFamily="34" charset="-122"/>
@@ -5790,13 +5790,13 @@
           </a:solidFill>
           <a:ln w="9525">
             <a:solidFill>
-              <a:srgbClr val="C5D4CF"/>
+              <a:srgbClr val="C5D0E0"/>
             </a:solidFill>
             <a:prstDash val="solid"/>
           </a:ln>
           <a:effectLst>
             <a:outerShdw sx="100000" sy="100000" kx="0" ky="0" algn="bl" rotWithShape="0" blurRad="127000" dist="25400" dir="5400000">
-              <a:srgbClr val="14211e">
+              <a:srgbClr val="102a43">
                 <a:alpha val="10000"/>
               </a:srgbClr>
             </a:outerShdw>
@@ -5830,7 +5830,7 @@
             <a:r>
               <a:rPr lang="en-US" sz="1500" b="1" dirty="0">
                 <a:solidFill>
-                  <a:srgbClr val="14211E"/>
+                  <a:srgbClr val="102A43"/>
                 </a:solidFill>
                 <a:latin typeface="Calibri" pitchFamily="34" charset="0"/>
                 <a:ea typeface="Calibri" pitchFamily="34" charset="-122"/>
@@ -5869,7 +5869,7 @@
             <a:r>
               <a:rPr lang="en-US" sz="1300" b="1" dirty="0">
                 <a:solidFill>
-                  <a:srgbClr val="0F5C4C"/>
+                  <a:srgbClr val="1B4F8A"/>
                 </a:solidFill>
                 <a:latin typeface="Calibri" pitchFamily="34" charset="0"/>
                 <a:ea typeface="Calibri" pitchFamily="34" charset="-122"/>
@@ -5911,7 +5911,7 @@
             <a:r>
               <a:rPr lang="en-US" sz="1200" dirty="0">
                 <a:solidFill>
-                  <a:srgbClr val="3D524C"/>
+                  <a:srgbClr val="3D5270"/>
                 </a:solidFill>
                 <a:latin typeface="Calibri" pitchFamily="34" charset="0"/>
                 <a:ea typeface="Calibri" pitchFamily="34" charset="-122"/>
@@ -5944,13 +5944,13 @@
           </a:solidFill>
           <a:ln w="9525">
             <a:solidFill>
-              <a:srgbClr val="C5D4CF"/>
+              <a:srgbClr val="C5D0E0"/>
             </a:solidFill>
             <a:prstDash val="solid"/>
           </a:ln>
           <a:effectLst>
             <a:outerShdw sx="100000" sy="100000" kx="0" ky="0" algn="bl" rotWithShape="0" blurRad="127000" dist="25400" dir="5400000">
-              <a:srgbClr val="14211e">
+              <a:srgbClr val="102a43">
                 <a:alpha val="10000"/>
               </a:srgbClr>
             </a:outerShdw>
@@ -5984,7 +5984,7 @@
             <a:r>
               <a:rPr lang="en-US" sz="1500" b="1" dirty="0">
                 <a:solidFill>
-                  <a:srgbClr val="14211E"/>
+                  <a:srgbClr val="102A43"/>
                 </a:solidFill>
                 <a:latin typeface="Calibri" pitchFamily="34" charset="0"/>
                 <a:ea typeface="Calibri" pitchFamily="34" charset="-122"/>
@@ -6023,7 +6023,7 @@
             <a:r>
               <a:rPr lang="en-US" sz="1300" b="1" dirty="0">
                 <a:solidFill>
-                  <a:srgbClr val="0F5C4C"/>
+                  <a:srgbClr val="1B4F8A"/>
                 </a:solidFill>
                 <a:latin typeface="Calibri" pitchFamily="34" charset="0"/>
                 <a:ea typeface="Calibri" pitchFamily="34" charset="-122"/>
@@ -6065,7 +6065,7 @@
             <a:r>
               <a:rPr lang="en-US" sz="1200" dirty="0">
                 <a:solidFill>
-                  <a:srgbClr val="3D524C"/>
+                  <a:srgbClr val="3D5270"/>
                 </a:solidFill>
                 <a:latin typeface="Calibri" pitchFamily="34" charset="0"/>
                 <a:ea typeface="Calibri" pitchFamily="34" charset="-122"/>
@@ -6094,12 +6094,12 @@
             </a:avLst>
           </a:prstGeom>
           <a:solidFill>
-            <a:srgbClr val="0F5C4C"/>
+            <a:srgbClr val="1B4F8A"/>
           </a:solidFill>
           <a:ln/>
           <a:effectLst>
             <a:outerShdw sx="100000" sy="100000" kx="0" ky="0" algn="bl" rotWithShape="0" blurRad="127000" dist="25400" dir="5400000">
-              <a:srgbClr val="14211e">
+              <a:srgbClr val="102a43">
                 <a:alpha val="10000"/>
               </a:srgbClr>
             </a:outerShdw>
@@ -6133,7 +6133,7 @@
             <a:r>
               <a:rPr lang="en-US" sz="1500" b="1" dirty="0">
                 <a:solidFill>
-                  <a:srgbClr val="F4F7F6"/>
+                  <a:srgbClr val="F4F7FB"/>
                 </a:solidFill>
                 <a:latin typeface="Calibri" pitchFamily="34" charset="0"/>
                 <a:ea typeface="Calibri" pitchFamily="34" charset="-122"/>
@@ -6172,7 +6172,7 @@
             <a:r>
               <a:rPr lang="en-US" sz="1300" b="1" dirty="0">
                 <a:solidFill>
-                  <a:srgbClr val="C5D4CF"/>
+                  <a:srgbClr val="C5D0E0"/>
                 </a:solidFill>
                 <a:latin typeface="Calibri" pitchFamily="34" charset="0"/>
                 <a:ea typeface="Calibri" pitchFamily="34" charset="-122"/>
@@ -6214,7 +6214,7 @@
             <a:r>
               <a:rPr lang="en-US" sz="1200" dirty="0">
                 <a:solidFill>
-                  <a:srgbClr val="C5D4CF"/>
+                  <a:srgbClr val="C5D0E0"/>
                 </a:solidFill>
                 <a:latin typeface="Calibri" pitchFamily="34" charset="0"/>
                 <a:ea typeface="Calibri" pitchFamily="34" charset="-122"/>
@@ -6256,13 +6256,13 @@
             <a:r>
               <a:rPr lang="en-US" sz="1150" dirty="0">
                 <a:solidFill>
-                  <a:srgbClr val="3D524C"/>
-                </a:solidFill>
-                <a:latin typeface="Calibri" pitchFamily="34" charset="0"/>
-                <a:ea typeface="Calibri" pitchFamily="34" charset="-122"/>
-                <a:cs typeface="Calibri" pitchFamily="34" charset="-120"/>
-              </a:rPr>
-              <a:t>Adjacent, but not the wedge: national digital-health rails, private booking marketplaces, teleconsult apps. None of them sits before the door with KEPH level, wait, booking and arrived/no-show in one loop. [Likely]</a:t>
+                  <a:srgbClr val="3D5270"/>
+                </a:solidFill>
+                <a:latin typeface="Calibri" pitchFamily="34" charset="0"/>
+                <a:ea typeface="Calibri" pitchFamily="34" charset="-122"/>
+                <a:cs typeface="Calibri" pitchFamily="34" charset="-120"/>
+              </a:rPr>
+              <a:t>Adjacent, but not the wedge: AfyaKE/AfyaLink, Vezeeta/Ponea, teleconsult apps. None of them sits before the door with KEPH level, wait, booking and arrived/no-show in one loop. [Likely]</a:t>
             </a:r>
             <a:endParaRPr lang="en-US" sz="1150" dirty="0"/>
           </a:p>
@@ -6285,12 +6285,12 @@
             </a:avLst>
           </a:prstGeom>
           <a:solidFill>
-            <a:srgbClr val="14211E"/>
+            <a:srgbClr val="102A43"/>
           </a:solidFill>
           <a:ln/>
           <a:effectLst>
             <a:outerShdw sx="100000" sy="100000" kx="0" ky="0" algn="bl" rotWithShape="0" blurRad="127000" dist="25400" dir="5400000">
-              <a:srgbClr val="14211e">
+              <a:srgbClr val="102a43">
                 <a:alpha val="10000"/>
               </a:srgbClr>
             </a:outerShdw>
@@ -6324,7 +6324,7 @@
             <a:r>
               <a:rPr lang="en-US" sz="1100" b="1" spc="120" kern="0" dirty="0">
                 <a:solidFill>
-                  <a:srgbClr val="C5D4CF"/>
+                  <a:srgbClr val="B8C7DB"/>
                 </a:solidFill>
                 <a:latin typeface="Calibri" pitchFamily="34" charset="0"/>
                 <a:ea typeface="Calibri" pitchFamily="34" charset="-122"/>
@@ -6363,7 +6363,7 @@
             <a:r>
               <a:rPr lang="en-US" sz="4800" b="1" dirty="0">
                 <a:solidFill>
-                  <a:srgbClr val="F4F7F6"/>
+                  <a:srgbClr val="F4F7FB"/>
                 </a:solidFill>
                 <a:latin typeface="Cambria" pitchFamily="34" charset="0"/>
                 <a:ea typeface="Cambria" pitchFamily="34" charset="-122"/>
@@ -6402,7 +6402,7 @@
             <a:r>
               <a:rPr lang="en-US" sz="1250" dirty="0">
                 <a:solidFill>
-                  <a:srgbClr val="C5D4CF"/>
+                  <a:srgbClr val="B8C7DB"/>
                 </a:solidFill>
                 <a:latin typeface="Calibri" pitchFamily="34" charset="0"/>
                 <a:ea typeface="Calibri" pitchFamily="34" charset="-122"/>
@@ -6441,7 +6441,7 @@
             <a:r>
               <a:rPr lang="en-US" sz="1600" b="1" dirty="0">
                 <a:solidFill>
-                  <a:srgbClr val="F4F7F6"/>
+                  <a:srgbClr val="F4F7FB"/>
                 </a:solidFill>
                 <a:latin typeface="Calibri" pitchFamily="34" charset="0"/>
                 <a:ea typeface="Calibri" pitchFamily="34" charset="-122"/>
@@ -6483,7 +6483,7 @@
             <a:r>
               <a:rPr lang="en-US" sz="1100" dirty="0">
                 <a:solidFill>
-                  <a:srgbClr val="C5D4CF"/>
+                  <a:srgbClr val="C5D0E0"/>
                 </a:solidFill>
                 <a:latin typeface="Calibri" pitchFamily="34" charset="0"/>
                 <a:ea typeface="Calibri" pitchFamily="34" charset="-122"/>
@@ -6522,7 +6522,7 @@
             <a:r>
               <a:rPr lang="en-US" sz="1050" dirty="0">
                 <a:solidFill>
-                  <a:srgbClr val="3D524C"/>
+                  <a:srgbClr val="3D5270"/>
                 </a:solidFill>
                 <a:latin typeface="Calibri" pitchFamily="34" charset="0"/>
                 <a:ea typeface="Calibri" pitchFamily="34" charset="-122"/>
@@ -6548,7 +6548,7 @@
     <p:bg>
       <p:bgPr>
         <a:solidFill>
-          <a:srgbClr val="F4F7F6"/>
+          <a:srgbClr val="F4F7FB"/>
         </a:solidFill>
       </p:bgPr>
     </p:bg>
@@ -6593,7 +6593,7 @@
             <a:r>
               <a:rPr lang="en-US" sz="1150" b="1" spc="160" kern="0" dirty="0">
                 <a:solidFill>
-                  <a:srgbClr val="0F5C4C"/>
+                  <a:srgbClr val="1B4F8A"/>
                 </a:solidFill>
                 <a:latin typeface="Calibri" pitchFamily="34" charset="0"/>
                 <a:ea typeface="Calibri" pitchFamily="34" charset="-122"/>
@@ -6632,7 +6632,7 @@
             <a:r>
               <a:rPr lang="en-US" sz="3800" b="1" dirty="0">
                 <a:solidFill>
-                  <a:srgbClr val="14211E"/>
+                  <a:srgbClr val="102A43"/>
                 </a:solidFill>
                 <a:latin typeface="Cambria" pitchFamily="34" charset="0"/>
                 <a:ea typeface="Cambria" pitchFamily="34" charset="-122"/>
@@ -6665,13 +6665,13 @@
           </a:solidFill>
           <a:ln w="9525">
             <a:solidFill>
-              <a:srgbClr val="C5D4CF"/>
+              <a:srgbClr val="C5D0E0"/>
             </a:solidFill>
             <a:prstDash val="solid"/>
           </a:ln>
           <a:effectLst>
             <a:outerShdw sx="100000" sy="100000" kx="0" ky="0" algn="bl" rotWithShape="0" blurRad="127000" dist="25400" dir="5400000">
-              <a:srgbClr val="14211e">
+              <a:srgbClr val="102a43">
                 <a:alpha val="10000"/>
               </a:srgbClr>
             </a:outerShdw>
@@ -6705,7 +6705,7 @@
             <a:r>
               <a:rPr lang="en-US" sz="1400" b="1" dirty="0">
                 <a:solidFill>
-                  <a:srgbClr val="0F5C4C"/>
+                  <a:srgbClr val="1B4F8A"/>
                 </a:solidFill>
                 <a:latin typeface="Cambria" pitchFamily="34" charset="0"/>
                 <a:ea typeface="Cambria" pitchFamily="34" charset="-122"/>
@@ -6744,7 +6744,7 @@
             <a:r>
               <a:rPr lang="en-US" sz="1350" b="1" dirty="0">
                 <a:solidFill>
-                  <a:srgbClr val="14211E"/>
+                  <a:srgbClr val="102A43"/>
                 </a:solidFill>
                 <a:latin typeface="Calibri" pitchFamily="34" charset="0"/>
                 <a:ea typeface="Calibri" pitchFamily="34" charset="-122"/>
@@ -6786,7 +6786,7 @@
             <a:r>
               <a:rPr lang="en-US" sz="1050" dirty="0">
                 <a:solidFill>
-                  <a:srgbClr val="3D524C"/>
+                  <a:srgbClr val="3D5270"/>
                 </a:solidFill>
                 <a:latin typeface="Calibri" pitchFamily="34" charset="0"/>
                 <a:ea typeface="Calibri" pitchFamily="34" charset="-122"/>
@@ -6815,7 +6815,7 @@
           <a:noFill/>
           <a:ln w="25400">
             <a:solidFill>
-              <a:srgbClr val="0F5C4C"/>
+              <a:srgbClr val="1B4F8A"/>
             </a:solidFill>
             <a:prstDash val="solid"/>
             <a:tailEnd type="triangle"/>
@@ -6843,13 +6843,13 @@
           </a:solidFill>
           <a:ln w="9525">
             <a:solidFill>
-              <a:srgbClr val="C5D4CF"/>
+              <a:srgbClr val="C5D0E0"/>
             </a:solidFill>
             <a:prstDash val="solid"/>
           </a:ln>
           <a:effectLst>
             <a:outerShdw sx="100000" sy="100000" kx="0" ky="0" algn="bl" rotWithShape="0" blurRad="127000" dist="25400" dir="5400000">
-              <a:srgbClr val="14211e">
+              <a:srgbClr val="102a43">
                 <a:alpha val="10000"/>
               </a:srgbClr>
             </a:outerShdw>
@@ -6883,7 +6883,7 @@
             <a:r>
               <a:rPr lang="en-US" sz="1400" b="1" dirty="0">
                 <a:solidFill>
-                  <a:srgbClr val="0F5C4C"/>
+                  <a:srgbClr val="1B4F8A"/>
                 </a:solidFill>
                 <a:latin typeface="Cambria" pitchFamily="34" charset="0"/>
                 <a:ea typeface="Cambria" pitchFamily="34" charset="-122"/>
@@ -6922,7 +6922,7 @@
             <a:r>
               <a:rPr lang="en-US" sz="1350" b="1" dirty="0">
                 <a:solidFill>
-                  <a:srgbClr val="14211E"/>
+                  <a:srgbClr val="102A43"/>
                 </a:solidFill>
                 <a:latin typeface="Calibri" pitchFamily="34" charset="0"/>
                 <a:ea typeface="Calibri" pitchFamily="34" charset="-122"/>
@@ -6964,7 +6964,7 @@
             <a:r>
               <a:rPr lang="en-US" sz="1050" dirty="0">
                 <a:solidFill>
-                  <a:srgbClr val="3D524C"/>
+                  <a:srgbClr val="3D5270"/>
                 </a:solidFill>
                 <a:latin typeface="Calibri" pitchFamily="34" charset="0"/>
                 <a:ea typeface="Calibri" pitchFamily="34" charset="-122"/>
@@ -6993,7 +6993,7 @@
           <a:noFill/>
           <a:ln w="25400">
             <a:solidFill>
-              <a:srgbClr val="0F5C4C"/>
+              <a:srgbClr val="1B4F8A"/>
             </a:solidFill>
             <a:prstDash val="solid"/>
             <a:tailEnd type="triangle"/>
@@ -7021,13 +7021,13 @@
           </a:solidFill>
           <a:ln w="9525">
             <a:solidFill>
-              <a:srgbClr val="C5D4CF"/>
+              <a:srgbClr val="C5D0E0"/>
             </a:solidFill>
             <a:prstDash val="solid"/>
           </a:ln>
           <a:effectLst>
             <a:outerShdw sx="100000" sy="100000" kx="0" ky="0" algn="bl" rotWithShape="0" blurRad="127000" dist="25400" dir="5400000">
-              <a:srgbClr val="14211e">
+              <a:srgbClr val="102a43">
                 <a:alpha val="10000"/>
               </a:srgbClr>
             </a:outerShdw>
@@ -7061,7 +7061,7 @@
             <a:r>
               <a:rPr lang="en-US" sz="1400" b="1" dirty="0">
                 <a:solidFill>
-                  <a:srgbClr val="0F5C4C"/>
+                  <a:srgbClr val="1B4F8A"/>
                 </a:solidFill>
                 <a:latin typeface="Cambria" pitchFamily="34" charset="0"/>
                 <a:ea typeface="Cambria" pitchFamily="34" charset="-122"/>
@@ -7100,7 +7100,7 @@
             <a:r>
               <a:rPr lang="en-US" sz="1350" b="1" dirty="0">
                 <a:solidFill>
-                  <a:srgbClr val="14211E"/>
+                  <a:srgbClr val="102A43"/>
                 </a:solidFill>
                 <a:latin typeface="Calibri" pitchFamily="34" charset="0"/>
                 <a:ea typeface="Calibri" pitchFamily="34" charset="-122"/>
@@ -7142,7 +7142,7 @@
             <a:r>
               <a:rPr lang="en-US" sz="1050" dirty="0">
                 <a:solidFill>
-                  <a:srgbClr val="3D524C"/>
+                  <a:srgbClr val="3D5270"/>
                 </a:solidFill>
                 <a:latin typeface="Calibri" pitchFamily="34" charset="0"/>
                 <a:ea typeface="Calibri" pitchFamily="34" charset="-122"/>
@@ -7171,7 +7171,7 @@
           <a:noFill/>
           <a:ln w="25400">
             <a:solidFill>
-              <a:srgbClr val="0F5C4C"/>
+              <a:srgbClr val="1B4F8A"/>
             </a:solidFill>
             <a:prstDash val="solid"/>
             <a:tailEnd type="triangle"/>
@@ -7199,13 +7199,13 @@
           </a:solidFill>
           <a:ln w="9525">
             <a:solidFill>
-              <a:srgbClr val="C5D4CF"/>
+              <a:srgbClr val="C5D0E0"/>
             </a:solidFill>
             <a:prstDash val="solid"/>
           </a:ln>
           <a:effectLst>
             <a:outerShdw sx="100000" sy="100000" kx="0" ky="0" algn="bl" rotWithShape="0" blurRad="127000" dist="25400" dir="5400000">
-              <a:srgbClr val="14211e">
+              <a:srgbClr val="102a43">
                 <a:alpha val="10000"/>
               </a:srgbClr>
             </a:outerShdw>
@@ -7239,7 +7239,7 @@
             <a:r>
               <a:rPr lang="en-US" sz="1400" b="1" dirty="0">
                 <a:solidFill>
-                  <a:srgbClr val="0F5C4C"/>
+                  <a:srgbClr val="1B4F8A"/>
                 </a:solidFill>
                 <a:latin typeface="Cambria" pitchFamily="34" charset="0"/>
                 <a:ea typeface="Cambria" pitchFamily="34" charset="-122"/>
@@ -7278,7 +7278,7 @@
             <a:r>
               <a:rPr lang="en-US" sz="1350" b="1" dirty="0">
                 <a:solidFill>
-                  <a:srgbClr val="14211E"/>
+                  <a:srgbClr val="102A43"/>
                 </a:solidFill>
                 <a:latin typeface="Calibri" pitchFamily="34" charset="0"/>
                 <a:ea typeface="Calibri" pitchFamily="34" charset="-122"/>
@@ -7320,7 +7320,7 @@
             <a:r>
               <a:rPr lang="en-US" sz="1050" dirty="0">
                 <a:solidFill>
-                  <a:srgbClr val="3D524C"/>
+                  <a:srgbClr val="3D5270"/>
                 </a:solidFill>
                 <a:latin typeface="Calibri" pitchFamily="34" charset="0"/>
                 <a:ea typeface="Calibri" pitchFamily="34" charset="-122"/>
@@ -7353,13 +7353,13 @@
           </a:solidFill>
           <a:ln w="9525">
             <a:solidFill>
-              <a:srgbClr val="C5D4CF"/>
+              <a:srgbClr val="C5D0E0"/>
             </a:solidFill>
             <a:prstDash val="solid"/>
           </a:ln>
           <a:effectLst>
             <a:outerShdw sx="100000" sy="100000" kx="0" ky="0" algn="bl" rotWithShape="0" blurRad="127000" dist="25400" dir="5400000">
-              <a:srgbClr val="14211e">
+              <a:srgbClr val="102a43">
                 <a:alpha val="10000"/>
               </a:srgbClr>
             </a:outerShdw>
@@ -7393,7 +7393,7 @@
             <a:r>
               <a:rPr lang="en-US" sz="1400" b="1" dirty="0">
                 <a:solidFill>
-                  <a:srgbClr val="0F5C4C"/>
+                  <a:srgbClr val="1B4F8A"/>
                 </a:solidFill>
                 <a:latin typeface="Cambria" pitchFamily="34" charset="0"/>
                 <a:ea typeface="Cambria" pitchFamily="34" charset="-122"/>
@@ -7432,7 +7432,7 @@
             <a:r>
               <a:rPr lang="en-US" sz="1350" b="1" dirty="0">
                 <a:solidFill>
-                  <a:srgbClr val="14211E"/>
+                  <a:srgbClr val="102A43"/>
                 </a:solidFill>
                 <a:latin typeface="Calibri" pitchFamily="34" charset="0"/>
                 <a:ea typeface="Calibri" pitchFamily="34" charset="-122"/>
@@ -7474,7 +7474,7 @@
             <a:r>
               <a:rPr lang="en-US" sz="1050" dirty="0">
                 <a:solidFill>
-                  <a:srgbClr val="3D524C"/>
+                  <a:srgbClr val="3D5270"/>
                 </a:solidFill>
                 <a:latin typeface="Calibri" pitchFamily="34" charset="0"/>
                 <a:ea typeface="Calibri" pitchFamily="34" charset="-122"/>
@@ -7503,7 +7503,7 @@
           <a:noFill/>
           <a:ln w="25400">
             <a:solidFill>
-              <a:srgbClr val="0F5C4C"/>
+              <a:srgbClr val="1B4F8A"/>
             </a:solidFill>
             <a:prstDash val="solid"/>
             <a:tailEnd type="triangle"/>
@@ -7531,13 +7531,13 @@
           </a:solidFill>
           <a:ln w="9525">
             <a:solidFill>
-              <a:srgbClr val="C5D4CF"/>
+              <a:srgbClr val="C5D0E0"/>
             </a:solidFill>
             <a:prstDash val="solid"/>
           </a:ln>
           <a:effectLst>
             <a:outerShdw sx="100000" sy="100000" kx="0" ky="0" algn="bl" rotWithShape="0" blurRad="127000" dist="25400" dir="5400000">
-              <a:srgbClr val="14211e">
+              <a:srgbClr val="102a43">
                 <a:alpha val="10000"/>
               </a:srgbClr>
             </a:outerShdw>
@@ -7571,7 +7571,7 @@
             <a:r>
               <a:rPr lang="en-US" sz="1400" b="1" dirty="0">
                 <a:solidFill>
-                  <a:srgbClr val="0F5C4C"/>
+                  <a:srgbClr val="1B4F8A"/>
                 </a:solidFill>
                 <a:latin typeface="Cambria" pitchFamily="34" charset="0"/>
                 <a:ea typeface="Cambria" pitchFamily="34" charset="-122"/>
@@ -7610,7 +7610,7 @@
             <a:r>
               <a:rPr lang="en-US" sz="1350" b="1" dirty="0">
                 <a:solidFill>
-                  <a:srgbClr val="14211E"/>
+                  <a:srgbClr val="102A43"/>
                 </a:solidFill>
                 <a:latin typeface="Calibri" pitchFamily="34" charset="0"/>
                 <a:ea typeface="Calibri" pitchFamily="34" charset="-122"/>
@@ -7652,7 +7652,7 @@
             <a:r>
               <a:rPr lang="en-US" sz="1050" dirty="0">
                 <a:solidFill>
-                  <a:srgbClr val="3D524C"/>
+                  <a:srgbClr val="3D5270"/>
                 </a:solidFill>
                 <a:latin typeface="Calibri" pitchFamily="34" charset="0"/>
                 <a:ea typeface="Calibri" pitchFamily="34" charset="-122"/>
@@ -7681,7 +7681,7 @@
           <a:noFill/>
           <a:ln w="25400">
             <a:solidFill>
-              <a:srgbClr val="0F5C4C"/>
+              <a:srgbClr val="1B4F8A"/>
             </a:solidFill>
             <a:prstDash val="solid"/>
             <a:tailEnd type="triangle"/>
@@ -7709,13 +7709,13 @@
           </a:solidFill>
           <a:ln w="9525">
             <a:solidFill>
-              <a:srgbClr val="C5D4CF"/>
+              <a:srgbClr val="C5D0E0"/>
             </a:solidFill>
             <a:prstDash val="solid"/>
           </a:ln>
           <a:effectLst>
             <a:outerShdw sx="100000" sy="100000" kx="0" ky="0" algn="bl" rotWithShape="0" blurRad="127000" dist="25400" dir="5400000">
-              <a:srgbClr val="14211e">
+              <a:srgbClr val="102a43">
                 <a:alpha val="10000"/>
               </a:srgbClr>
             </a:outerShdw>
@@ -7749,7 +7749,7 @@
             <a:r>
               <a:rPr lang="en-US" sz="1400" b="1" dirty="0">
                 <a:solidFill>
-                  <a:srgbClr val="0F5C4C"/>
+                  <a:srgbClr val="1B4F8A"/>
                 </a:solidFill>
                 <a:latin typeface="Cambria" pitchFamily="34" charset="0"/>
                 <a:ea typeface="Cambria" pitchFamily="34" charset="-122"/>
@@ -7788,7 +7788,7 @@
             <a:r>
               <a:rPr lang="en-US" sz="1350" b="1" dirty="0">
                 <a:solidFill>
-                  <a:srgbClr val="14211E"/>
+                  <a:srgbClr val="102A43"/>
                 </a:solidFill>
                 <a:latin typeface="Calibri" pitchFamily="34" charset="0"/>
                 <a:ea typeface="Calibri" pitchFamily="34" charset="-122"/>
@@ -7830,7 +7830,7 @@
             <a:r>
               <a:rPr lang="en-US" sz="1050" dirty="0">
                 <a:solidFill>
-                  <a:srgbClr val="3D524C"/>
+                  <a:srgbClr val="3D5270"/>
                 </a:solidFill>
                 <a:latin typeface="Calibri" pitchFamily="34" charset="0"/>
                 <a:ea typeface="Calibri" pitchFamily="34" charset="-122"/>
@@ -7859,7 +7859,7 @@
           <a:noFill/>
           <a:ln w="25400">
             <a:solidFill>
-              <a:srgbClr val="0F5C4C"/>
+              <a:srgbClr val="1B4F8A"/>
             </a:solidFill>
             <a:prstDash val="solid"/>
             <a:tailEnd type="triangle"/>
@@ -7887,13 +7887,13 @@
           </a:solidFill>
           <a:ln w="9525">
             <a:solidFill>
-              <a:srgbClr val="C5D4CF"/>
+              <a:srgbClr val="C5D0E0"/>
             </a:solidFill>
             <a:prstDash val="solid"/>
           </a:ln>
           <a:effectLst>
             <a:outerShdw sx="100000" sy="100000" kx="0" ky="0" algn="bl" rotWithShape="0" blurRad="127000" dist="25400" dir="5400000">
-              <a:srgbClr val="14211e">
+              <a:srgbClr val="102a43">
                 <a:alpha val="10000"/>
               </a:srgbClr>
             </a:outerShdw>
@@ -7927,7 +7927,7 @@
             <a:r>
               <a:rPr lang="en-US" sz="1400" b="1" dirty="0">
                 <a:solidFill>
-                  <a:srgbClr val="0F5C4C"/>
+                  <a:srgbClr val="1B4F8A"/>
                 </a:solidFill>
                 <a:latin typeface="Cambria" pitchFamily="34" charset="0"/>
                 <a:ea typeface="Cambria" pitchFamily="34" charset="-122"/>
@@ -7966,7 +7966,7 @@
             <a:r>
               <a:rPr lang="en-US" sz="1350" b="1" dirty="0">
                 <a:solidFill>
-                  <a:srgbClr val="14211E"/>
+                  <a:srgbClr val="102A43"/>
                 </a:solidFill>
                 <a:latin typeface="Calibri" pitchFamily="34" charset="0"/>
                 <a:ea typeface="Calibri" pitchFamily="34" charset="-122"/>
@@ -8008,7 +8008,7 @@
             <a:r>
               <a:rPr lang="en-US" sz="1050" dirty="0">
                 <a:solidFill>
-                  <a:srgbClr val="3D524C"/>
+                  <a:srgbClr val="3D5270"/>
                 </a:solidFill>
                 <a:latin typeface="Calibri" pitchFamily="34" charset="0"/>
                 <a:ea typeface="Calibri" pitchFamily="34" charset="-122"/>
@@ -8023,30 +8023,6 @@
       <p:sp>
         <p:nvSpPr>
           <p:cNvPr id="42" name="Shape 40"/>
-          <p:cNvSpPr/>
-          <p:nvPr/>
-        </p:nvSpPr>
-        <p:spPr>
-          <a:xfrm>
-            <a:off x="11292840" y="2743200"/>
-            <a:ext cx="0" cy="256032"/>
-          </a:xfrm>
-          <a:prstGeom prst="line">
-            <a:avLst/>
-          </a:prstGeom>
-          <a:noFill/>
-          <a:ln w="25400">
-            <a:solidFill>
-              <a:srgbClr val="0F5C4C"/>
-            </a:solidFill>
-            <a:prstDash val="solid"/>
-            <a:tailEnd type="triangle"/>
-          </a:ln>
-        </p:spPr>
-      </p:sp>
-      <p:sp>
-        <p:nvSpPr>
-          <p:cNvPr id="43" name="Shape 41"/>
           <p:cNvSpPr/>
           <p:nvPr/>
         </p:nvSpPr>
@@ -8065,13 +8041,13 @@
           </a:solidFill>
           <a:ln w="9525">
             <a:solidFill>
-              <a:srgbClr val="C5D4CF"/>
+              <a:srgbClr val="C5D0E0"/>
             </a:solidFill>
             <a:prstDash val="solid"/>
           </a:ln>
           <a:effectLst>
             <a:outerShdw sx="100000" sy="100000" kx="0" ky="0" algn="bl" rotWithShape="0" blurRad="127000" dist="25400" dir="5400000">
-              <a:srgbClr val="14211e">
+              <a:srgbClr val="102a43">
                 <a:alpha val="10000"/>
               </a:srgbClr>
             </a:outerShdw>
@@ -8080,7 +8056,7 @@
       </p:sp>
       <p:sp>
         <p:nvSpPr>
-          <p:cNvPr id="44" name="Text 42"/>
+          <p:cNvPr id="43" name="Text 41"/>
           <p:cNvSpPr/>
           <p:nvPr/>
         </p:nvSpPr>
@@ -8105,7 +8081,7 @@
             <a:r>
               <a:rPr lang="en-US" sz="1150" b="1" spc="140" kern="0" dirty="0">
                 <a:solidFill>
-                  <a:srgbClr val="0F5C4C"/>
+                  <a:srgbClr val="1B4F8A"/>
                 </a:solidFill>
                 <a:latin typeface="Calibri" pitchFamily="34" charset="0"/>
                 <a:ea typeface="Calibri" pitchFamily="34" charset="-122"/>
@@ -8119,7 +8095,7 @@
       </p:sp>
       <p:sp>
         <p:nvSpPr>
-          <p:cNvPr id="45" name="Text 43"/>
+          <p:cNvPr id="44" name="Text 42"/>
           <p:cNvSpPr/>
           <p:nvPr/>
         </p:nvSpPr>
@@ -8144,7 +8120,7 @@
             <a:r>
               <a:rPr lang="en-US" sz="1200" b="1" dirty="0">
                 <a:solidFill>
-                  <a:srgbClr val="14211E"/>
+                  <a:srgbClr val="102A43"/>
                 </a:solidFill>
                 <a:latin typeface="Courier New" pitchFamily="34" charset="0"/>
                 <a:ea typeface="Courier New" pitchFamily="34" charset="-122"/>
@@ -8158,7 +8134,7 @@
       </p:sp>
       <p:sp>
         <p:nvSpPr>
-          <p:cNvPr id="46" name="Text 44"/>
+          <p:cNvPr id="45" name="Text 43"/>
           <p:cNvSpPr/>
           <p:nvPr/>
         </p:nvSpPr>
@@ -8183,7 +8159,7 @@
             <a:r>
               <a:rPr lang="en-US" sz="1200" dirty="0">
                 <a:solidFill>
-                  <a:srgbClr val="3D524C"/>
+                  <a:srgbClr val="3D5270"/>
                 </a:solidFill>
                 <a:latin typeface="Calibri" pitchFamily="34" charset="0"/>
                 <a:ea typeface="Calibri" pitchFamily="34" charset="-122"/>
@@ -8197,7 +8173,7 @@
       </p:sp>
       <p:sp>
         <p:nvSpPr>
-          <p:cNvPr id="47" name="Shape 45"/>
+          <p:cNvPr id="46" name="Shape 44"/>
           <p:cNvSpPr/>
           <p:nvPr/>
         </p:nvSpPr>
@@ -8217,7 +8193,7 @@
           <a:ln/>
           <a:effectLst>
             <a:outerShdw sx="100000" sy="100000" kx="0" ky="0" algn="bl" rotWithShape="0" blurRad="127000" dist="25400" dir="5400000">
-              <a:srgbClr val="14211e">
+              <a:srgbClr val="102a43">
                 <a:alpha val="10000"/>
               </a:srgbClr>
             </a:outerShdw>
@@ -8226,7 +8202,7 @@
       </p:sp>
       <p:sp>
         <p:nvSpPr>
-          <p:cNvPr id="48" name="Text 46"/>
+          <p:cNvPr id="47" name="Text 45"/>
           <p:cNvSpPr/>
           <p:nvPr/>
         </p:nvSpPr>
@@ -8265,7 +8241,7 @@
       </p:sp>
       <p:sp>
         <p:nvSpPr>
-          <p:cNvPr id="49" name="Text 47"/>
+          <p:cNvPr id="48" name="Text 46"/>
           <p:cNvSpPr/>
           <p:nvPr/>
         </p:nvSpPr>
@@ -8290,7 +8266,7 @@
             <a:r>
               <a:rPr lang="en-US" sz="1500" b="1" dirty="0">
                 <a:solidFill>
-                  <a:srgbClr val="14211E"/>
+                  <a:srgbClr val="102A43"/>
                 </a:solidFill>
                 <a:latin typeface="Calibri" pitchFamily="34" charset="0"/>
                 <a:ea typeface="Calibri" pitchFamily="34" charset="-122"/>
@@ -8304,7 +8280,7 @@
       </p:sp>
       <p:sp>
         <p:nvSpPr>
-          <p:cNvPr id="50" name="Text 48"/>
+          <p:cNvPr id="49" name="Text 47"/>
           <p:cNvSpPr/>
           <p:nvPr/>
         </p:nvSpPr>
@@ -8329,7 +8305,7 @@
             <a:r>
               <a:rPr lang="en-US" sz="1150" dirty="0">
                 <a:solidFill>
-                  <a:srgbClr val="3D524C"/>
+                  <a:srgbClr val="3D5270"/>
                 </a:solidFill>
                 <a:latin typeface="Calibri" pitchFamily="34" charset="0"/>
                 <a:ea typeface="Calibri" pitchFamily="34" charset="-122"/>
@@ -8343,7 +8319,7 @@
       </p:sp>
       <p:sp>
         <p:nvSpPr>
-          <p:cNvPr id="51" name="Text 49"/>
+          <p:cNvPr id="50" name="Text 48"/>
           <p:cNvSpPr/>
           <p:nvPr/>
         </p:nvSpPr>
@@ -8368,7 +8344,7 @@
             <a:r>
               <a:rPr lang="en-US" sz="1050" dirty="0">
                 <a:solidFill>
-                  <a:srgbClr val="3D524C"/>
+                  <a:srgbClr val="3D5270"/>
                 </a:solidFill>
                 <a:latin typeface="Calibri" pitchFamily="34" charset="0"/>
                 <a:ea typeface="Calibri" pitchFamily="34" charset="-122"/>
@@ -8394,7 +8370,7 @@
     <p:bg>
       <p:bgPr>
         <a:solidFill>
-          <a:srgbClr val="F4F7F6"/>
+          <a:srgbClr val="F4F7FB"/>
         </a:solidFill>
       </p:bgPr>
     </p:bg>
@@ -8439,7 +8415,7 @@
             <a:r>
               <a:rPr lang="en-US" sz="1150" b="1" spc="160" kern="0" dirty="0">
                 <a:solidFill>
-                  <a:srgbClr val="0F5C4C"/>
+                  <a:srgbClr val="1B4F8A"/>
                 </a:solidFill>
                 <a:latin typeface="Calibri" pitchFamily="34" charset="0"/>
                 <a:ea typeface="Calibri" pitchFamily="34" charset="-122"/>
@@ -8478,7 +8454,7 @@
             <a:r>
               <a:rPr lang="en-US" sz="3800" b="1" dirty="0">
                 <a:solidFill>
-                  <a:srgbClr val="14211E"/>
+                  <a:srgbClr val="102A43"/>
                 </a:solidFill>
                 <a:latin typeface="Cambria" pitchFamily="34" charset="0"/>
                 <a:ea typeface="Cambria" pitchFamily="34" charset="-122"/>
@@ -8512,7 +8488,7 @@
           <a:ln/>
           <a:effectLst>
             <a:outerShdw sx="100000" sy="100000" kx="0" ky="0" algn="bl" rotWithShape="0" blurRad="127000" dist="25400" dir="5400000">
-              <a:srgbClr val="14211e">
+              <a:srgbClr val="102a43">
                 <a:alpha val="10000"/>
               </a:srgbClr>
             </a:outerShdw>
@@ -8585,7 +8561,7 @@
             <a:r>
               <a:rPr lang="en-US" sz="1400" b="1" dirty="0">
                 <a:solidFill>
-                  <a:srgbClr val="14211E"/>
+                  <a:srgbClr val="102A43"/>
                 </a:solidFill>
                 <a:latin typeface="Calibri" pitchFamily="34" charset="0"/>
                 <a:ea typeface="Calibri" pitchFamily="34" charset="-122"/>
@@ -8627,7 +8603,7 @@
             <a:r>
               <a:rPr lang="en-US" sz="1150" dirty="0">
                 <a:solidFill>
-                  <a:srgbClr val="3D524C"/>
+                  <a:srgbClr val="3D5270"/>
                 </a:solidFill>
                 <a:latin typeface="Calibri" pitchFamily="34" charset="0"/>
                 <a:ea typeface="Calibri" pitchFamily="34" charset="-122"/>
@@ -8656,7 +8632,7 @@
           <a:noFill/>
           <a:ln w="25400">
             <a:solidFill>
-              <a:srgbClr val="0F5C4C"/>
+              <a:srgbClr val="1B4F8A"/>
             </a:solidFill>
             <a:prstDash val="solid"/>
             <a:tailEnd type="triangle"/>
@@ -8685,7 +8661,7 @@
           <a:ln/>
           <a:effectLst>
             <a:outerShdw sx="100000" sy="100000" kx="0" ky="0" algn="bl" rotWithShape="0" blurRad="127000" dist="25400" dir="5400000">
-              <a:srgbClr val="14211e">
+              <a:srgbClr val="102a43">
                 <a:alpha val="10000"/>
               </a:srgbClr>
             </a:outerShdw>
@@ -8719,7 +8695,7 @@
             <a:r>
               <a:rPr lang="en-US" sz="1400" b="1" dirty="0">
                 <a:solidFill>
-                  <a:srgbClr val="0F5C4C"/>
+                  <a:srgbClr val="1B4F8A"/>
                 </a:solidFill>
                 <a:latin typeface="Cambria" pitchFamily="34" charset="0"/>
                 <a:ea typeface="Cambria" pitchFamily="34" charset="-122"/>
@@ -8758,7 +8734,7 @@
             <a:r>
               <a:rPr lang="en-US" sz="1400" b="1" dirty="0">
                 <a:solidFill>
-                  <a:srgbClr val="14211E"/>
+                  <a:srgbClr val="102A43"/>
                 </a:solidFill>
                 <a:latin typeface="Calibri" pitchFamily="34" charset="0"/>
                 <a:ea typeface="Calibri" pitchFamily="34" charset="-122"/>
@@ -8800,7 +8776,7 @@
             <a:r>
               <a:rPr lang="en-US" sz="1150" dirty="0">
                 <a:solidFill>
-                  <a:srgbClr val="3D524C"/>
+                  <a:srgbClr val="3D5270"/>
                 </a:solidFill>
                 <a:latin typeface="Calibri" pitchFamily="34" charset="0"/>
                 <a:ea typeface="Calibri" pitchFamily="34" charset="-122"/>
@@ -8829,7 +8805,7 @@
           <a:noFill/>
           <a:ln w="25400">
             <a:solidFill>
-              <a:srgbClr val="0F5C4C"/>
+              <a:srgbClr val="1B4F8A"/>
             </a:solidFill>
             <a:prstDash val="solid"/>
             <a:tailEnd type="triangle"/>
@@ -8858,7 +8834,7 @@
           <a:ln/>
           <a:effectLst>
             <a:outerShdw sx="100000" sy="100000" kx="0" ky="0" algn="bl" rotWithShape="0" blurRad="127000" dist="25400" dir="5400000">
-              <a:srgbClr val="14211e">
+              <a:srgbClr val="102a43">
                 <a:alpha val="10000"/>
               </a:srgbClr>
             </a:outerShdw>
@@ -8892,7 +8868,7 @@
             <a:r>
               <a:rPr lang="en-US" sz="1400" b="1" dirty="0">
                 <a:solidFill>
-                  <a:srgbClr val="0F5C4C"/>
+                  <a:srgbClr val="1B4F8A"/>
                 </a:solidFill>
                 <a:latin typeface="Cambria" pitchFamily="34" charset="0"/>
                 <a:ea typeface="Cambria" pitchFamily="34" charset="-122"/>
@@ -8931,7 +8907,7 @@
             <a:r>
               <a:rPr lang="en-US" sz="1400" b="1" dirty="0">
                 <a:solidFill>
-                  <a:srgbClr val="14211E"/>
+                  <a:srgbClr val="102A43"/>
                 </a:solidFill>
                 <a:latin typeface="Calibri" pitchFamily="34" charset="0"/>
                 <a:ea typeface="Calibri" pitchFamily="34" charset="-122"/>
@@ -8973,7 +8949,7 @@
             <a:r>
               <a:rPr lang="en-US" sz="1150" dirty="0">
                 <a:solidFill>
-                  <a:srgbClr val="3D524C"/>
+                  <a:srgbClr val="3D5270"/>
                 </a:solidFill>
                 <a:latin typeface="Calibri" pitchFamily="34" charset="0"/>
                 <a:ea typeface="Calibri" pitchFamily="34" charset="-122"/>
@@ -9002,7 +8978,7 @@
           <a:noFill/>
           <a:ln w="25400">
             <a:solidFill>
-              <a:srgbClr val="0F5C4C"/>
+              <a:srgbClr val="1B4F8A"/>
             </a:solidFill>
             <a:prstDash val="solid"/>
             <a:tailEnd type="triangle"/>
@@ -9031,7 +9007,7 @@
           <a:ln/>
           <a:effectLst>
             <a:outerShdw sx="100000" sy="100000" kx="0" ky="0" algn="bl" rotWithShape="0" blurRad="127000" dist="25400" dir="5400000">
-              <a:srgbClr val="14211e">
+              <a:srgbClr val="102a43">
                 <a:alpha val="10000"/>
               </a:srgbClr>
             </a:outerShdw>
@@ -9065,7 +9041,7 @@
             <a:r>
               <a:rPr lang="en-US" sz="1400" b="1" dirty="0">
                 <a:solidFill>
-                  <a:srgbClr val="0F5C4C"/>
+                  <a:srgbClr val="1B4F8A"/>
                 </a:solidFill>
                 <a:latin typeface="Cambria" pitchFamily="34" charset="0"/>
                 <a:ea typeface="Cambria" pitchFamily="34" charset="-122"/>
@@ -9104,7 +9080,7 @@
             <a:r>
               <a:rPr lang="en-US" sz="1400" b="1" dirty="0">
                 <a:solidFill>
-                  <a:srgbClr val="14211E"/>
+                  <a:srgbClr val="102A43"/>
                 </a:solidFill>
                 <a:latin typeface="Calibri" pitchFamily="34" charset="0"/>
                 <a:ea typeface="Calibri" pitchFamily="34" charset="-122"/>
@@ -9146,7 +9122,7 @@
             <a:r>
               <a:rPr lang="en-US" sz="1150" dirty="0">
                 <a:solidFill>
-                  <a:srgbClr val="3D524C"/>
+                  <a:srgbClr val="3D5270"/>
                 </a:solidFill>
                 <a:latin typeface="Calibri" pitchFamily="34" charset="0"/>
                 <a:ea typeface="Calibri" pitchFamily="34" charset="-122"/>
@@ -9175,7 +9151,7 @@
           <a:noFill/>
           <a:ln w="25400">
             <a:solidFill>
-              <a:srgbClr val="0F5C4C"/>
+              <a:srgbClr val="1B4F8A"/>
             </a:solidFill>
             <a:prstDash val="solid"/>
             <a:tailEnd type="triangle"/>
@@ -9204,7 +9180,7 @@
           <a:ln/>
           <a:effectLst>
             <a:outerShdw sx="100000" sy="100000" kx="0" ky="0" algn="bl" rotWithShape="0" blurRad="127000" dist="25400" dir="5400000">
-              <a:srgbClr val="14211e">
+              <a:srgbClr val="102a43">
                 <a:alpha val="10000"/>
               </a:srgbClr>
             </a:outerShdw>
@@ -9238,7 +9214,7 @@
             <a:r>
               <a:rPr lang="en-US" sz="1400" b="1" dirty="0">
                 <a:solidFill>
-                  <a:srgbClr val="0F5C4C"/>
+                  <a:srgbClr val="1B4F8A"/>
                 </a:solidFill>
                 <a:latin typeface="Cambria" pitchFamily="34" charset="0"/>
                 <a:ea typeface="Cambria" pitchFamily="34" charset="-122"/>
@@ -9277,7 +9253,7 @@
             <a:r>
               <a:rPr lang="en-US" sz="1400" b="1" dirty="0">
                 <a:solidFill>
-                  <a:srgbClr val="14211E"/>
+                  <a:srgbClr val="102A43"/>
                 </a:solidFill>
                 <a:latin typeface="Calibri" pitchFamily="34" charset="0"/>
                 <a:ea typeface="Calibri" pitchFamily="34" charset="-122"/>
@@ -9319,7 +9295,7 @@
             <a:r>
               <a:rPr lang="en-US" sz="1150" dirty="0">
                 <a:solidFill>
-                  <a:srgbClr val="3D524C"/>
+                  <a:srgbClr val="3D5270"/>
                 </a:solidFill>
                 <a:latin typeface="Calibri" pitchFamily="34" charset="0"/>
                 <a:ea typeface="Calibri" pitchFamily="34" charset="-122"/>
@@ -9352,13 +9328,13 @@
           </a:solidFill>
           <a:ln w="9525">
             <a:solidFill>
-              <a:srgbClr val="C5D4CF"/>
+              <a:srgbClr val="C5D0E0"/>
             </a:solidFill>
             <a:prstDash val="solid"/>
           </a:ln>
           <a:effectLst>
             <a:outerShdw sx="100000" sy="100000" kx="0" ky="0" algn="bl" rotWithShape="0" blurRad="127000" dist="25400" dir="5400000">
-              <a:srgbClr val="14211e">
+              <a:srgbClr val="102a43">
                 <a:alpha val="10000"/>
               </a:srgbClr>
             </a:outerShdw>
@@ -9392,7 +9368,7 @@
             <a:r>
               <a:rPr lang="en-US" sz="1600" b="1" dirty="0">
                 <a:solidFill>
-                  <a:srgbClr val="14211E"/>
+                  <a:srgbClr val="102A43"/>
                 </a:solidFill>
                 <a:latin typeface="Calibri" pitchFamily="34" charset="0"/>
                 <a:ea typeface="Calibri" pitchFamily="34" charset="-122"/>
@@ -9434,7 +9410,7 @@
             <a:r>
               <a:rPr lang="en-US" sz="1300" dirty="0">
                 <a:solidFill>
-                  <a:srgbClr val="3D524C"/>
+                  <a:srgbClr val="3D5270"/>
                 </a:solidFill>
                 <a:latin typeface="Calibri" pitchFamily="34" charset="0"/>
                 <a:ea typeface="Calibri" pitchFamily="34" charset="-122"/>
@@ -9463,12 +9439,12 @@
             </a:avLst>
           </a:prstGeom>
           <a:solidFill>
-            <a:srgbClr val="0F5C4C"/>
+            <a:srgbClr val="1B4F8A"/>
           </a:solidFill>
           <a:ln/>
           <a:effectLst>
             <a:outerShdw sx="100000" sy="100000" kx="0" ky="0" algn="bl" rotWithShape="0" blurRad="127000" dist="25400" dir="5400000">
-              <a:srgbClr val="14211e">
+              <a:srgbClr val="102a43">
                 <a:alpha val="10000"/>
               </a:srgbClr>
             </a:outerShdw>
@@ -9502,7 +9478,7 @@
             <a:r>
               <a:rPr lang="en-US" sz="1600" b="1" dirty="0">
                 <a:solidFill>
-                  <a:srgbClr val="F4F7F6"/>
+                  <a:srgbClr val="F4F7FB"/>
                 </a:solidFill>
                 <a:latin typeface="Calibri" pitchFamily="34" charset="0"/>
                 <a:ea typeface="Calibri" pitchFamily="34" charset="-122"/>
@@ -9544,7 +9520,7 @@
             <a:r>
               <a:rPr lang="en-US" sz="1300" dirty="0">
                 <a:solidFill>
-                  <a:srgbClr val="C5D4CF"/>
+                  <a:srgbClr val="C5D0E0"/>
                 </a:solidFill>
                 <a:latin typeface="Calibri" pitchFamily="34" charset="0"/>
                 <a:ea typeface="Calibri" pitchFamily="34" charset="-122"/>
@@ -9583,7 +9559,7 @@
             <a:r>
               <a:rPr lang="en-US" sz="1050" dirty="0">
                 <a:solidFill>
-                  <a:srgbClr val="3D524C"/>
+                  <a:srgbClr val="3D5270"/>
                 </a:solidFill>
                 <a:latin typeface="Calibri" pitchFamily="34" charset="0"/>
                 <a:ea typeface="Calibri" pitchFamily="34" charset="-122"/>
@@ -9609,7 +9585,7 @@
     <p:bg>
       <p:bgPr>
         <a:solidFill>
-          <a:srgbClr val="F4F7F6"/>
+          <a:srgbClr val="F4F7FB"/>
         </a:solidFill>
       </p:bgPr>
     </p:bg>
@@ -9654,7 +9630,7 @@
             <a:r>
               <a:rPr lang="en-US" sz="1150" b="1" spc="160" kern="0" dirty="0">
                 <a:solidFill>
-                  <a:srgbClr val="0F5C4C"/>
+                  <a:srgbClr val="1B4F8A"/>
                 </a:solidFill>
                 <a:latin typeface="Calibri" pitchFamily="34" charset="0"/>
                 <a:ea typeface="Calibri" pitchFamily="34" charset="-122"/>
@@ -9693,7 +9669,7 @@
             <a:r>
               <a:rPr lang="en-US" sz="3800" b="1" dirty="0">
                 <a:solidFill>
-                  <a:srgbClr val="14211E"/>
+                  <a:srgbClr val="102A43"/>
                 </a:solidFill>
                 <a:latin typeface="Cambria" pitchFamily="34" charset="0"/>
                 <a:ea typeface="Cambria" pitchFamily="34" charset="-122"/>
@@ -9714,11 +9690,11 @@
         <p:spPr>
           <a:xfrm>
             <a:off x="548640" y="1783080"/>
-            <a:ext cx="3931920" cy="2606040"/>
+            <a:ext cx="3931920" cy="2468880"/>
           </a:xfrm>
           <a:prstGeom prst="roundRect">
             <a:avLst>
-              <a:gd name="adj" fmla="val 4912"/>
+              <a:gd name="adj" fmla="val 5185"/>
             </a:avLst>
           </a:prstGeom>
           <a:solidFill>
@@ -9726,13 +9702,13 @@
           </a:solidFill>
           <a:ln w="9525">
             <a:solidFill>
-              <a:srgbClr val="C5D4CF"/>
+              <a:srgbClr val="C5D0E0"/>
             </a:solidFill>
             <a:prstDash val="solid"/>
           </a:ln>
           <a:effectLst>
             <a:outerShdw sx="100000" sy="100000" kx="0" ky="0" algn="bl" rotWithShape="0" blurRad="127000" dist="25400" dir="5400000">
-              <a:srgbClr val="14211e">
+              <a:srgbClr val="102a43">
                 <a:alpha val="10000"/>
               </a:srgbClr>
             </a:outerShdw>
@@ -9766,7 +9742,7 @@
             <a:r>
               <a:rPr lang="en-US" sz="1800" b="1" dirty="0">
                 <a:solidFill>
-                  <a:srgbClr val="14211E"/>
+                  <a:srgbClr val="102A43"/>
                 </a:solidFill>
                 <a:latin typeface="Calibri" pitchFamily="34" charset="0"/>
                 <a:ea typeface="Calibri" pitchFamily="34" charset="-122"/>
@@ -9786,22 +9762,22 @@
         </p:nvSpPr>
         <p:spPr>
           <a:xfrm>
-            <a:off x="841248" y="2487168"/>
-            <a:ext cx="3346704" cy="1645920"/>
-          </a:xfrm>
-          <a:prstGeom prst="rect">
-            <a:avLst/>
-          </a:prstGeom>
-          <a:noFill/>
-          <a:ln/>
-        </p:spPr>
-        <p:txBody>
-          <a:bodyPr wrap="square" lIns="0" tIns="0" rIns="0" bIns="0" rtlCol="0" anchor="t"/>
-          <a:lstStyle/>
-          <a:p>
-            <a:pPr algn="l" marL="342900" indent="-342900">
+            <a:off x="841248" y="2450592"/>
+            <a:ext cx="3346704" cy="1280160"/>
+          </a:xfrm>
+          <a:prstGeom prst="rect">
+            <a:avLst/>
+          </a:prstGeom>
+          <a:noFill/>
+          <a:ln/>
+        </p:spPr>
+        <p:txBody>
+          <a:bodyPr wrap="square" lIns="0" tIns="0" rIns="0" bIns="0" rtlCol="0" anchor="t"/>
+          <a:lstStyle/>
+          <a:p>
+            <a:pPr algn="l" marL="203200" indent="-203200">
               <a:spcAft>
-                <a:spcPts val="800"/>
+                <a:spcPts val="1200"/>
               </a:spcAft>
               <a:buSzPct val="100000"/>
               <a:buChar char="•"/>
@@ -9809,7 +9785,7 @@
             <a:r>
               <a:rPr lang="en-US" sz="1350" dirty="0">
                 <a:solidFill>
-                  <a:srgbClr val="3D524C"/>
+                  <a:srgbClr val="3D5270"/>
                 </a:solidFill>
                 <a:latin typeface="Calibri" pitchFamily="34" charset="0"/>
                 <a:ea typeface="Calibri" pitchFamily="34" charset="-122"/>
@@ -9820,9 +9796,9 @@
             <a:endParaRPr lang="en-US" sz="1350" dirty="0"/>
           </a:p>
           <a:p>
-            <a:pPr algn="l" marL="342900" indent="-342900">
+            <a:pPr algn="l" marL="203200" indent="-203200">
               <a:spcAft>
-                <a:spcPts val="800"/>
+                <a:spcPts val="1200"/>
               </a:spcAft>
               <a:buSzPct val="100000"/>
               <a:buChar char="•"/>
@@ -9830,7 +9806,7 @@
             <a:r>
               <a:rPr lang="en-US" sz="1350" dirty="0">
                 <a:solidFill>
-                  <a:srgbClr val="3D524C"/>
+                  <a:srgbClr val="3D5270"/>
                 </a:solidFill>
                 <a:latin typeface="Calibri" pitchFamily="34" charset="0"/>
                 <a:ea typeface="Calibri" pitchFamily="34" charset="-122"/>
@@ -9841,9 +9817,9 @@
             <a:endParaRPr lang="en-US" sz="1350" dirty="0"/>
           </a:p>
           <a:p>
-            <a:pPr algn="l" marL="342900" indent="-342900">
+            <a:pPr algn="l" marL="203200" indent="-203200">
               <a:spcAft>
-                <a:spcPts val="800"/>
+                <a:spcPts val="1200"/>
               </a:spcAft>
               <a:buSzPct val="100000"/>
               <a:buChar char="•"/>
@@ -9851,7 +9827,7 @@
             <a:r>
               <a:rPr lang="en-US" sz="1350" dirty="0">
                 <a:solidFill>
-                  <a:srgbClr val="3D524C"/>
+                  <a:srgbClr val="3D5270"/>
                 </a:solidFill>
                 <a:latin typeface="Calibri" pitchFamily="34" charset="0"/>
                 <a:ea typeface="Calibri" pitchFamily="34" charset="-122"/>
@@ -9871,21 +9847,21 @@
         </p:nvSpPr>
         <p:spPr>
           <a:xfrm>
-            <a:off x="4892040" y="2377440"/>
-            <a:ext cx="2377440" cy="1417320"/>
+            <a:off x="4892040" y="2331720"/>
+            <a:ext cx="2377440" cy="1371600"/>
           </a:xfrm>
           <a:prstGeom prst="roundRect">
             <a:avLst>
-              <a:gd name="adj" fmla="val 9032"/>
+              <a:gd name="adj" fmla="val 9333"/>
             </a:avLst>
           </a:prstGeom>
           <a:solidFill>
-            <a:srgbClr val="0F5C4C"/>
+            <a:srgbClr val="1B4F8A"/>
           </a:solidFill>
           <a:ln/>
           <a:effectLst>
             <a:outerShdw sx="100000" sy="100000" kx="0" ky="0" algn="bl" rotWithShape="0" blurRad="127000" dist="25400" dir="5400000">
-              <a:srgbClr val="14211e">
+              <a:srgbClr val="102a43">
                 <a:alpha val="10000"/>
               </a:srgbClr>
             </a:outerShdw>
@@ -9900,7 +9876,7 @@
         </p:nvSpPr>
         <p:spPr>
           <a:xfrm>
-            <a:off x="5120640" y="2578608"/>
+            <a:off x="5120640" y="2532888"/>
             <a:ext cx="1920240" cy="274320"/>
           </a:xfrm>
           <a:prstGeom prst="rect">
@@ -9919,7 +9895,7 @@
             <a:r>
               <a:rPr lang="en-US" sz="1150" b="1" spc="140" kern="0" dirty="0">
                 <a:solidFill>
-                  <a:srgbClr val="C5D4CF"/>
+                  <a:srgbClr val="C5D0E0"/>
                 </a:solidFill>
                 <a:latin typeface="Calibri" pitchFamily="34" charset="0"/>
                 <a:ea typeface="Calibri" pitchFamily="34" charset="-122"/>
@@ -9939,7 +9915,7 @@
         </p:nvSpPr>
         <p:spPr>
           <a:xfrm>
-            <a:off x="5120640" y="2889504"/>
+            <a:off x="5120640" y="2843784"/>
             <a:ext cx="1920240" cy="310896"/>
           </a:xfrm>
           <a:prstGeom prst="rect">
@@ -9958,7 +9934,7 @@
             <a:r>
               <a:rPr lang="en-US" sz="1800" b="1" dirty="0">
                 <a:solidFill>
-                  <a:srgbClr val="F4F7F6"/>
+                  <a:srgbClr val="F4F7FB"/>
                 </a:solidFill>
                 <a:latin typeface="Calibri" pitchFamily="34" charset="0"/>
                 <a:ea typeface="Calibri" pitchFamily="34" charset="-122"/>
@@ -9978,7 +9954,7 @@
         </p:nvSpPr>
         <p:spPr>
           <a:xfrm>
-            <a:off x="5120640" y="3236976"/>
+            <a:off x="5120640" y="3191256"/>
             <a:ext cx="1920240" cy="457200"/>
           </a:xfrm>
           <a:prstGeom prst="rect">
@@ -10000,7 +9976,7 @@
             <a:r>
               <a:rPr lang="en-US" sz="1100" dirty="0">
                 <a:solidFill>
-                  <a:srgbClr val="C5D4CF"/>
+                  <a:srgbClr val="C5D0E0"/>
                 </a:solidFill>
                 <a:latin typeface="Calibri" pitchFamily="34" charset="0"/>
                 <a:ea typeface="Calibri" pitchFamily="34" charset="-122"/>
@@ -10020,7 +9996,7 @@
         </p:nvSpPr>
         <p:spPr>
           <a:xfrm>
-            <a:off x="4553712" y="3081528"/>
+            <a:off x="4553712" y="3017520"/>
             <a:ext cx="274320" cy="0"/>
           </a:xfrm>
           <a:prstGeom prst="line">
@@ -10029,7 +10005,7 @@
           <a:noFill/>
           <a:ln w="25400">
             <a:solidFill>
-              <a:srgbClr val="0F5C4C"/>
+              <a:srgbClr val="1B4F8A"/>
             </a:solidFill>
             <a:prstDash val="solid"/>
             <a:tailEnd type="triangle"/>
@@ -10044,7 +10020,7 @@
         </p:nvSpPr>
         <p:spPr>
           <a:xfrm>
-            <a:off x="7342632" y="3081528"/>
+            <a:off x="7342632" y="3017520"/>
             <a:ext cx="274320" cy="0"/>
           </a:xfrm>
           <a:prstGeom prst="line">
@@ -10053,7 +10029,7 @@
           <a:noFill/>
           <a:ln w="25400">
             <a:solidFill>
-              <a:srgbClr val="0F5C4C"/>
+              <a:srgbClr val="1B4F8A"/>
             </a:solidFill>
             <a:prstDash val="solid"/>
             <a:tailEnd type="triangle"/>
@@ -10069,11 +10045,11 @@
         <p:spPr>
           <a:xfrm>
             <a:off x="7680960" y="1783080"/>
-            <a:ext cx="3931920" cy="2606040"/>
+            <a:ext cx="3931920" cy="2468880"/>
           </a:xfrm>
           <a:prstGeom prst="roundRect">
             <a:avLst>
-              <a:gd name="adj" fmla="val 4912"/>
+              <a:gd name="adj" fmla="val 5185"/>
             </a:avLst>
           </a:prstGeom>
           <a:solidFill>
@@ -10081,13 +10057,13 @@
           </a:solidFill>
           <a:ln w="9525">
             <a:solidFill>
-              <a:srgbClr val="C5D4CF"/>
+              <a:srgbClr val="C5D0E0"/>
             </a:solidFill>
             <a:prstDash val="solid"/>
           </a:ln>
           <a:effectLst>
             <a:outerShdw sx="100000" sy="100000" kx="0" ky="0" algn="bl" rotWithShape="0" blurRad="127000" dist="25400" dir="5400000">
-              <a:srgbClr val="14211e">
+              <a:srgbClr val="102a43">
                 <a:alpha val="10000"/>
               </a:srgbClr>
             </a:outerShdw>
@@ -10121,7 +10097,7 @@
             <a:r>
               <a:rPr lang="en-US" sz="1800" b="1" dirty="0">
                 <a:solidFill>
-                  <a:srgbClr val="14211E"/>
+                  <a:srgbClr val="102A43"/>
                 </a:solidFill>
                 <a:latin typeface="Calibri" pitchFamily="34" charset="0"/>
                 <a:ea typeface="Calibri" pitchFamily="34" charset="-122"/>
@@ -10141,22 +10117,22 @@
         </p:nvSpPr>
         <p:spPr>
           <a:xfrm>
-            <a:off x="7973568" y="2487168"/>
-            <a:ext cx="3346704" cy="1645920"/>
-          </a:xfrm>
-          <a:prstGeom prst="rect">
-            <a:avLst/>
-          </a:prstGeom>
-          <a:noFill/>
-          <a:ln/>
-        </p:spPr>
-        <p:txBody>
-          <a:bodyPr wrap="square" lIns="0" tIns="0" rIns="0" bIns="0" rtlCol="0" anchor="t"/>
-          <a:lstStyle/>
-          <a:p>
-            <a:pPr algn="l" marL="342900" indent="-342900">
+            <a:off x="7973568" y="2450592"/>
+            <a:ext cx="3346704" cy="1280160"/>
+          </a:xfrm>
+          <a:prstGeom prst="rect">
+            <a:avLst/>
+          </a:prstGeom>
+          <a:noFill/>
+          <a:ln/>
+        </p:spPr>
+        <p:txBody>
+          <a:bodyPr wrap="square" lIns="0" tIns="0" rIns="0" bIns="0" rtlCol="0" anchor="t"/>
+          <a:lstStyle/>
+          <a:p>
+            <a:pPr algn="l" marL="203200" indent="-203200">
               <a:spcAft>
-                <a:spcPts val="800"/>
+                <a:spcPts val="1200"/>
               </a:spcAft>
               <a:buSzPct val="100000"/>
               <a:buChar char="•"/>
@@ -10164,7 +10140,7 @@
             <a:r>
               <a:rPr lang="en-US" sz="1350" dirty="0">
                 <a:solidFill>
-                  <a:srgbClr val="3D524C"/>
+                  <a:srgbClr val="3D5270"/>
                 </a:solidFill>
                 <a:latin typeface="Calibri" pitchFamily="34" charset="0"/>
                 <a:ea typeface="Calibri" pitchFamily="34" charset="-122"/>
@@ -10175,9 +10151,9 @@
             <a:endParaRPr lang="en-US" sz="1350" dirty="0"/>
           </a:p>
           <a:p>
-            <a:pPr algn="l" marL="342900" indent="-342900">
+            <a:pPr algn="l" marL="203200" indent="-203200">
               <a:spcAft>
-                <a:spcPts val="800"/>
+                <a:spcPts val="1200"/>
               </a:spcAft>
               <a:buSzPct val="100000"/>
               <a:buChar char="•"/>
@@ -10185,7 +10161,7 @@
             <a:r>
               <a:rPr lang="en-US" sz="1350" dirty="0">
                 <a:solidFill>
-                  <a:srgbClr val="3D524C"/>
+                  <a:srgbClr val="3D5270"/>
                 </a:solidFill>
                 <a:latin typeface="Calibri" pitchFamily="34" charset="0"/>
                 <a:ea typeface="Calibri" pitchFamily="34" charset="-122"/>
@@ -10196,9 +10172,9 @@
             <a:endParaRPr lang="en-US" sz="1350" dirty="0"/>
           </a:p>
           <a:p>
-            <a:pPr algn="l" marL="342900" indent="-342900">
+            <a:pPr algn="l" marL="203200" indent="-203200">
               <a:spcAft>
-                <a:spcPts val="800"/>
+                <a:spcPts val="1200"/>
               </a:spcAft>
               <a:buSzPct val="100000"/>
               <a:buChar char="•"/>
@@ -10206,7 +10182,7 @@
             <a:r>
               <a:rPr lang="en-US" sz="1350" dirty="0">
                 <a:solidFill>
-                  <a:srgbClr val="3D524C"/>
+                  <a:srgbClr val="3D5270"/>
                 </a:solidFill>
                 <a:latin typeface="Calibri" pitchFamily="34" charset="0"/>
                 <a:ea typeface="Calibri" pitchFamily="34" charset="-122"/>
@@ -10226,7 +10202,7 @@
         </p:nvSpPr>
         <p:spPr>
           <a:xfrm>
-            <a:off x="7973568" y="3986784"/>
+            <a:off x="7973568" y="3840480"/>
             <a:ext cx="3346704" cy="310896"/>
           </a:xfrm>
           <a:prstGeom prst="rect">
@@ -10245,7 +10221,7 @@
             <a:r>
               <a:rPr lang="en-US" sz="1150" i="1" dirty="0">
                 <a:solidFill>
-                  <a:srgbClr val="0F5C4C"/>
+                  <a:srgbClr val="1B4F8A"/>
                 </a:solidFill>
                 <a:latin typeface="Calibri" pitchFamily="34" charset="0"/>
                 <a:ea typeface="Calibri" pitchFamily="34" charset="-122"/>
@@ -10265,7 +10241,7 @@
         </p:nvSpPr>
         <p:spPr>
           <a:xfrm>
-            <a:off x="548640" y="4663440"/>
+            <a:off x="548640" y="4572000"/>
             <a:ext cx="11064240" cy="1051560"/>
           </a:xfrm>
           <a:prstGeom prst="roundRect">
@@ -10274,12 +10250,12 @@
             </a:avLst>
           </a:prstGeom>
           <a:solidFill>
-            <a:srgbClr val="14211E"/>
+            <a:srgbClr val="102A43"/>
           </a:solidFill>
           <a:ln/>
           <a:effectLst>
             <a:outerShdw sx="100000" sy="100000" kx="0" ky="0" algn="bl" rotWithShape="0" blurRad="127000" dist="25400" dir="5400000">
-              <a:srgbClr val="14211e">
+              <a:srgbClr val="102a43">
                 <a:alpha val="10000"/>
               </a:srgbClr>
             </a:outerShdw>
@@ -10294,7 +10270,7 @@
         </p:nvSpPr>
         <p:spPr>
           <a:xfrm>
-            <a:off x="914400" y="4892040"/>
+            <a:off x="914400" y="4800600"/>
             <a:ext cx="10332720" cy="640080"/>
           </a:xfrm>
           <a:prstGeom prst="rect">
@@ -10316,7 +10292,7 @@
             <a:r>
               <a:rPr lang="en-US" sz="1550" b="1" dirty="0">
                 <a:solidFill>
-                  <a:srgbClr val="F4F7F6"/>
+                  <a:srgbClr val="F4F7FB"/>
                 </a:solidFill>
                 <a:latin typeface="Calibri" pitchFamily="34" charset="0"/>
                 <a:ea typeface="Calibri" pitchFamily="34" charset="-122"/>
@@ -10355,7 +10331,7 @@
             <a:r>
               <a:rPr lang="en-US" sz="1050" dirty="0">
                 <a:solidFill>
-                  <a:srgbClr val="3D524C"/>
+                  <a:srgbClr val="3D5270"/>
                 </a:solidFill>
                 <a:latin typeface="Calibri" pitchFamily="34" charset="0"/>
                 <a:ea typeface="Calibri" pitchFamily="34" charset="-122"/>
@@ -10381,7 +10357,7 @@
     <p:bg>
       <p:bgPr>
         <a:solidFill>
-          <a:srgbClr val="F4F7F6"/>
+          <a:srgbClr val="F4F7FB"/>
         </a:solidFill>
       </p:bgPr>
     </p:bg>
@@ -10426,7 +10402,7 @@
             <a:r>
               <a:rPr lang="en-US" sz="1150" b="1" spc="160" kern="0" dirty="0">
                 <a:solidFill>
-                  <a:srgbClr val="0F5C4C"/>
+                  <a:srgbClr val="1B4F8A"/>
                 </a:solidFill>
                 <a:latin typeface="Calibri" pitchFamily="34" charset="0"/>
                 <a:ea typeface="Calibri" pitchFamily="34" charset="-122"/>
@@ -10465,7 +10441,7 @@
             <a:r>
               <a:rPr lang="en-US" sz="3800" b="1" dirty="0">
                 <a:solidFill>
-                  <a:srgbClr val="14211E"/>
+                  <a:srgbClr val="102A43"/>
                 </a:solidFill>
                 <a:latin typeface="Cambria" pitchFamily="34" charset="0"/>
                 <a:ea typeface="Cambria" pitchFamily="34" charset="-122"/>
@@ -10499,7 +10475,7 @@
           <a:ln/>
           <a:effectLst>
             <a:outerShdw sx="100000" sy="100000" kx="0" ky="0" algn="bl" rotWithShape="0" blurRad="127000" dist="25400" dir="5400000">
-              <a:srgbClr val="14211e">
+              <a:srgbClr val="102a43">
                 <a:alpha val="10000"/>
               </a:srgbClr>
             </a:outerShdw>
@@ -10572,7 +10548,7 @@
             <a:r>
               <a:rPr lang="en-US" sz="2100" b="1" dirty="0">
                 <a:solidFill>
-                  <a:srgbClr val="14211E"/>
+                  <a:srgbClr val="102A43"/>
                 </a:solidFill>
                 <a:latin typeface="Cambria" pitchFamily="34" charset="0"/>
                 <a:ea typeface="Cambria" pitchFamily="34" charset="-122"/>
@@ -10614,7 +10590,7 @@
             <a:r>
               <a:rPr lang="en-US" sz="1300" dirty="0">
                 <a:solidFill>
-                  <a:srgbClr val="3D524C"/>
+                  <a:srgbClr val="3D5270"/>
                 </a:solidFill>
                 <a:latin typeface="Calibri" pitchFamily="34" charset="0"/>
                 <a:ea typeface="Calibri" pitchFamily="34" charset="-122"/>
@@ -10647,13 +10623,13 @@
           </a:solidFill>
           <a:ln w="9525">
             <a:solidFill>
-              <a:srgbClr val="C5D4CF"/>
+              <a:srgbClr val="C5D0E0"/>
             </a:solidFill>
             <a:prstDash val="solid"/>
           </a:ln>
           <a:effectLst>
             <a:outerShdw sx="100000" sy="100000" kx="0" ky="0" algn="bl" rotWithShape="0" blurRad="127000" dist="25400" dir="5400000">
-              <a:srgbClr val="14211e">
+              <a:srgbClr val="102a43">
                 <a:alpha val="10000"/>
               </a:srgbClr>
             </a:outerShdw>
@@ -10687,7 +10663,7 @@
             <a:r>
               <a:rPr lang="en-US" sz="5000" b="1" dirty="0">
                 <a:solidFill>
-                  <a:srgbClr val="3D524C"/>
+                  <a:srgbClr val="3D5270"/>
                 </a:solidFill>
                 <a:latin typeface="Cambria" pitchFamily="34" charset="0"/>
                 <a:ea typeface="Cambria" pitchFamily="34" charset="-122"/>
@@ -10726,7 +10702,7 @@
             <a:r>
               <a:rPr lang="en-US" sz="1350" b="1" dirty="0">
                 <a:solidFill>
-                  <a:srgbClr val="14211E"/>
+                  <a:srgbClr val="102A43"/>
                 </a:solidFill>
                 <a:latin typeface="Calibri" pitchFamily="34" charset="0"/>
                 <a:ea typeface="Calibri" pitchFamily="34" charset="-122"/>
@@ -10768,7 +10744,7 @@
             <a:r>
               <a:rPr lang="en-US" sz="1250" dirty="0">
                 <a:solidFill>
-                  <a:srgbClr val="3D524C"/>
+                  <a:srgbClr val="3D5270"/>
                 </a:solidFill>
                 <a:latin typeface="Calibri" pitchFamily="34" charset="0"/>
                 <a:ea typeface="Calibri" pitchFamily="34" charset="-122"/>
@@ -10801,13 +10777,13 @@
           </a:solidFill>
           <a:ln w="9525">
             <a:solidFill>
-              <a:srgbClr val="C5D4CF"/>
+              <a:srgbClr val="C5D0E0"/>
             </a:solidFill>
             <a:prstDash val="solid"/>
           </a:ln>
           <a:effectLst>
             <a:outerShdw sx="100000" sy="100000" kx="0" ky="0" algn="bl" rotWithShape="0" blurRad="127000" dist="25400" dir="5400000">
-              <a:srgbClr val="14211e">
+              <a:srgbClr val="102a43">
                 <a:alpha val="10000"/>
               </a:srgbClr>
             </a:outerShdw>
@@ -10841,7 +10817,7 @@
             <a:r>
               <a:rPr lang="en-US" sz="5000" b="1" dirty="0">
                 <a:solidFill>
-                  <a:srgbClr val="0F5C4C"/>
+                  <a:srgbClr val="1B4F8A"/>
                 </a:solidFill>
                 <a:latin typeface="Cambria" pitchFamily="34" charset="0"/>
                 <a:ea typeface="Cambria" pitchFamily="34" charset="-122"/>
@@ -10880,7 +10856,7 @@
             <a:r>
               <a:rPr lang="en-US" sz="1350" b="1" dirty="0">
                 <a:solidFill>
-                  <a:srgbClr val="14211E"/>
+                  <a:srgbClr val="102A43"/>
                 </a:solidFill>
                 <a:latin typeface="Calibri" pitchFamily="34" charset="0"/>
                 <a:ea typeface="Calibri" pitchFamily="34" charset="-122"/>
@@ -10922,7 +10898,7 @@
             <a:r>
               <a:rPr lang="en-US" sz="1250" dirty="0">
                 <a:solidFill>
-                  <a:srgbClr val="3D524C"/>
+                  <a:srgbClr val="3D5270"/>
                 </a:solidFill>
                 <a:latin typeface="Calibri" pitchFamily="34" charset="0"/>
                 <a:ea typeface="Calibri" pitchFamily="34" charset="-122"/>
@@ -10955,13 +10931,13 @@
           </a:solidFill>
           <a:ln w="9525">
             <a:solidFill>
-              <a:srgbClr val="C5D4CF"/>
+              <a:srgbClr val="C5D0E0"/>
             </a:solidFill>
             <a:prstDash val="solid"/>
           </a:ln>
           <a:effectLst>
             <a:outerShdw sx="100000" sy="100000" kx="0" ky="0" algn="bl" rotWithShape="0" blurRad="127000" dist="25400" dir="5400000">
-              <a:srgbClr val="14211e">
+              <a:srgbClr val="102a43">
                 <a:alpha val="10000"/>
               </a:srgbClr>
             </a:outerShdw>
@@ -10995,7 +10971,7 @@
             <a:r>
               <a:rPr lang="en-US" sz="1600" b="1" dirty="0">
                 <a:solidFill>
-                  <a:srgbClr val="14211E"/>
+                  <a:srgbClr val="102A43"/>
                 </a:solidFill>
                 <a:latin typeface="Calibri" pitchFamily="34" charset="0"/>
                 <a:ea typeface="Calibri" pitchFamily="34" charset="-122"/>
@@ -11037,7 +11013,7 @@
             <a:r>
               <a:rPr lang="en-US" sz="1300" dirty="0">
                 <a:solidFill>
-                  <a:srgbClr val="3D524C"/>
+                  <a:srgbClr val="3D5270"/>
                 </a:solidFill>
                 <a:latin typeface="Calibri" pitchFamily="34" charset="0"/>
                 <a:ea typeface="Calibri" pitchFamily="34" charset="-122"/>
@@ -11066,12 +11042,12 @@
             </a:avLst>
           </a:prstGeom>
           <a:solidFill>
-            <a:srgbClr val="0F5C4C"/>
+            <a:srgbClr val="1B4F8A"/>
           </a:solidFill>
           <a:ln/>
           <a:effectLst>
             <a:outerShdw sx="100000" sy="100000" kx="0" ky="0" algn="bl" rotWithShape="0" blurRad="127000" dist="25400" dir="5400000">
-              <a:srgbClr val="14211e">
+              <a:srgbClr val="102a43">
                 <a:alpha val="10000"/>
               </a:srgbClr>
             </a:outerShdw>
@@ -11105,7 +11081,7 @@
             <a:r>
               <a:rPr lang="en-US" sz="1600" b="1" dirty="0">
                 <a:solidFill>
-                  <a:srgbClr val="F4F7F6"/>
+                  <a:srgbClr val="F4F7FB"/>
                 </a:solidFill>
                 <a:latin typeface="Calibri" pitchFamily="34" charset="0"/>
                 <a:ea typeface="Calibri" pitchFamily="34" charset="-122"/>
@@ -11147,7 +11123,7 @@
             <a:r>
               <a:rPr lang="en-US" sz="1300" dirty="0">
                 <a:solidFill>
-                  <a:srgbClr val="C5D4CF"/>
+                  <a:srgbClr val="C5D0E0"/>
                 </a:solidFill>
                 <a:latin typeface="Calibri" pitchFamily="34" charset="0"/>
                 <a:ea typeface="Calibri" pitchFamily="34" charset="-122"/>
@@ -11186,7 +11162,7 @@
             <a:r>
               <a:rPr lang="en-US" sz="1050" dirty="0">
                 <a:solidFill>
-                  <a:srgbClr val="3D524C"/>
+                  <a:srgbClr val="3D5270"/>
                 </a:solidFill>
                 <a:latin typeface="Calibri" pitchFamily="34" charset="0"/>
                 <a:ea typeface="Calibri" pitchFamily="34" charset="-122"/>

</xml_diff>

<commit_message>
fix: bind API to Render PORT and document live staging (#10)
Render injects PORT at runtime, so the Docker entrypoint no longer hardcodes 8000. Record the applied Blueprint hosts, queue squash auto-merge with the Alex review SOP, and keep the investor deck output path portable.

Co-authored-by: Cursor <cursoragent@cursor.com>
</commit_message>
<xml_diff>
--- a/docs/careflow-investor-pitch.pptx
+++ b/docs/careflow-investor-pitch.pptx
@@ -603,7 +603,7 @@
             <a:r>
               <a:rPr lang="en-US" dirty="0"/>
               <a:t>Sources: peak demand on Monday, 08:00–12:00 — Mwaura et al., AKUHN, PLOS One 2025. One-way SMS reminders and appointment attendance in Africa, odds ratio 2.03 — PLOS One 2019 meta-analysis. Kenya antenatal care missed appointments 35–42% — Homabay and Kisumu studies plus systematic reviews.
-Objection: who actually pays for this? Answer: not national insurance in this pass — that is deliberately deferred. The first budget we test is county and facility, where the pain is measurable: low-acuity load arriving at the wrong level, a peak window that is predictable enough to shift, and an SMS channel with published evidence that it improves attendance. Monetisation stays labelled as a hypothesis until a pilot prices it. We are not presenting a market-size calculation.</a:t>
+Objection: who actually pays for this? Answer: SHA is deferred. The first budget we test is county and facility, where the pain is measurable: low-acuity load arriving at the wrong level, a peak window that is predictable enough to shift, and an SMS channel with published evidence that it improves attendance. Monetisation stays labelled as a hypothesis until a pilot prices it. We are not presenting a market-size calculation.</a:t>
             </a:r>
             <a:endParaRPr lang="en-US" dirty="0"/>
           </a:p>
@@ -1049,7 +1049,7 @@
             <a:r>
               <a:rPr lang="en-US" dirty="0"/>
               <a:t>Sources: Singapore virtual care centre — 69% avoidance of an emergency department visit within 72 hours and 4.9% undertriage, JMIR Formative Research 2026. Label it out loud as an analog, not a Kenya randomised controlled trial. In-ED comparators: ETAT and Smart Triage (see the safety slide). Referral enforcement at Kenyatta National Hospital reduced direct Level 2–3 referrals, but reactively, at the door.
-Landscape whitespace [Likely]: no public product we can find combines community-entered symptoms, a KEPH minimum level, wait plus distance ranking, a booking, and an arrived/no-show close. Adjacent products worth naming in the room if asked, each as not-the-wedge: national digital-health and insurance rails, private booking marketplaces such as Vezeeta and Ponea, and teleconsult apps.
+Landscape whitespace [Likely]: no public product we can find combines community-entered symptoms, a KEPH minimum level, wait plus distance ranking, a booking, and an arrived/no-show close. Adjacent products worth naming in the room if asked, each as not-the-wedge: AfyaKE/AfyaLink (national rails), KNH referral enforcement, Smart Triage and ETAT (in-ED), Vezeeta/Ponea (booking marketplaces), and teleconsult apps.
 Objection: health tech in Kenya is crowded. Answer: it is, and we are not claiming there are no competitors. We are claiming none of those products occupies the before-the-door position. Marketplaces book the facility the family already picked; teleconsult replaces the visit; the rails move claims and records. None of them changes which KEPH level the family walks into or closes the loop with the desk.</a:t>
             </a:r>
             <a:endParaRPr lang="en-US" dirty="0"/>
@@ -1762,7 +1762,7 @@
     <p:bg>
       <p:bgPr>
         <a:solidFill>
-          <a:srgbClr val="14211E"/>
+          <a:srgbClr val="102A43"/>
         </a:solidFill>
       </p:bgPr>
     </p:bg>
@@ -1807,7 +1807,7 @@
             <a:r>
               <a:rPr lang="en-US" sz="6800" b="1" dirty="0">
                 <a:solidFill>
-                  <a:srgbClr val="F4F7F6"/>
+                  <a:srgbClr val="F4F7FB"/>
                 </a:solidFill>
                 <a:latin typeface="Cambria" pitchFamily="34" charset="0"/>
                 <a:ea typeface="Cambria" pitchFamily="34" charset="-122"/>
@@ -1849,7 +1849,7 @@
             <a:r>
               <a:rPr lang="en-US" sz="2000" dirty="0">
                 <a:solidFill>
-                  <a:srgbClr val="C5D4CF"/>
+                  <a:srgbClr val="B8C7DB"/>
                 </a:solidFill>
                 <a:latin typeface="Calibri" pitchFamily="34" charset="0"/>
                 <a:ea typeface="Calibri" pitchFamily="34" charset="-122"/>
@@ -1888,7 +1888,7 @@
             <a:r>
               <a:rPr lang="en-US" sz="1300" b="1" spc="240" kern="0" dirty="0">
                 <a:solidFill>
-                  <a:srgbClr val="F4F7F6"/>
+                  <a:srgbClr val="F4F7FB"/>
                 </a:solidFill>
                 <a:latin typeface="Calibri" pitchFamily="34" charset="0"/>
                 <a:ea typeface="Calibri" pitchFamily="34" charset="-122"/>
@@ -1917,12 +1917,12 @@
             </a:avLst>
           </a:prstGeom>
           <a:solidFill>
-            <a:srgbClr val="0F5C4C"/>
+            <a:srgbClr val="1B4F8A"/>
           </a:solidFill>
           <a:ln/>
           <a:effectLst>
             <a:outerShdw sx="100000" sy="100000" kx="0" ky="0" algn="bl" rotWithShape="0" blurRad="127000" dist="25400" dir="5400000">
-              <a:srgbClr val="14211e">
+              <a:srgbClr val="102a43">
                 <a:alpha val="10000"/>
               </a:srgbClr>
             </a:outerShdw>
@@ -1956,7 +1956,7 @@
             <a:r>
               <a:rPr lang="en-US" sz="1500" b="1" dirty="0">
                 <a:solidFill>
-                  <a:srgbClr val="F4F7F6"/>
+                  <a:srgbClr val="F4F7FB"/>
                 </a:solidFill>
                 <a:latin typeface="Calibri" pitchFamily="34" charset="0"/>
                 <a:ea typeface="Calibri" pitchFamily="34" charset="-122"/>
@@ -1998,7 +1998,7 @@
             <a:r>
               <a:rPr lang="en-US" sz="1150" dirty="0">
                 <a:solidFill>
-                  <a:srgbClr val="C5D4CF"/>
+                  <a:srgbClr val="C5D0E0"/>
                 </a:solidFill>
                 <a:latin typeface="Calibri" pitchFamily="34" charset="0"/>
                 <a:ea typeface="Calibri" pitchFamily="34" charset="-122"/>
@@ -2027,12 +2027,12 @@
             </a:avLst>
           </a:prstGeom>
           <a:solidFill>
-            <a:srgbClr val="0F5C4C"/>
+            <a:srgbClr val="1B4F8A"/>
           </a:solidFill>
           <a:ln/>
           <a:effectLst>
             <a:outerShdw sx="100000" sy="100000" kx="0" ky="0" algn="bl" rotWithShape="0" blurRad="127000" dist="25400" dir="5400000">
-              <a:srgbClr val="14211e">
+              <a:srgbClr val="102a43">
                 <a:alpha val="10000"/>
               </a:srgbClr>
             </a:outerShdw>
@@ -2066,7 +2066,7 @@
             <a:r>
               <a:rPr lang="en-US" sz="1500" b="1" dirty="0">
                 <a:solidFill>
-                  <a:srgbClr val="F4F7F6"/>
+                  <a:srgbClr val="F4F7FB"/>
                 </a:solidFill>
                 <a:latin typeface="Calibri" pitchFamily="34" charset="0"/>
                 <a:ea typeface="Calibri" pitchFamily="34" charset="-122"/>
@@ -2108,7 +2108,7 @@
             <a:r>
               <a:rPr lang="en-US" sz="1150" dirty="0">
                 <a:solidFill>
-                  <a:srgbClr val="C5D4CF"/>
+                  <a:srgbClr val="C5D0E0"/>
                 </a:solidFill>
                 <a:latin typeface="Calibri" pitchFamily="34" charset="0"/>
                 <a:ea typeface="Calibri" pitchFamily="34" charset="-122"/>
@@ -2137,12 +2137,12 @@
             </a:avLst>
           </a:prstGeom>
           <a:solidFill>
-            <a:srgbClr val="0F5C4C"/>
+            <a:srgbClr val="1B4F8A"/>
           </a:solidFill>
           <a:ln/>
           <a:effectLst>
             <a:outerShdw sx="100000" sy="100000" kx="0" ky="0" algn="bl" rotWithShape="0" blurRad="127000" dist="25400" dir="5400000">
-              <a:srgbClr val="14211e">
+              <a:srgbClr val="102a43">
                 <a:alpha val="10000"/>
               </a:srgbClr>
             </a:outerShdw>
@@ -2176,7 +2176,7 @@
             <a:r>
               <a:rPr lang="en-US" sz="1500" b="1" dirty="0">
                 <a:solidFill>
-                  <a:srgbClr val="F4F7F6"/>
+                  <a:srgbClr val="F4F7FB"/>
                 </a:solidFill>
                 <a:latin typeface="Calibri" pitchFamily="34" charset="0"/>
                 <a:ea typeface="Calibri" pitchFamily="34" charset="-122"/>
@@ -2218,7 +2218,7 @@
             <a:r>
               <a:rPr lang="en-US" sz="1150" dirty="0">
                 <a:solidFill>
-                  <a:srgbClr val="C5D4CF"/>
+                  <a:srgbClr val="C5D0E0"/>
                 </a:solidFill>
                 <a:latin typeface="Calibri" pitchFamily="34" charset="0"/>
                 <a:ea typeface="Calibri" pitchFamily="34" charset="-122"/>
@@ -2257,7 +2257,7 @@
             <a:r>
               <a:rPr lang="en-US" sz="1300" i="1" dirty="0">
                 <a:solidFill>
-                  <a:srgbClr val="C5D4CF"/>
+                  <a:srgbClr val="B8C7DB"/>
                 </a:solidFill>
                 <a:latin typeface="Calibri" pitchFamily="34" charset="0"/>
                 <a:ea typeface="Calibri" pitchFamily="34" charset="-122"/>
@@ -2283,7 +2283,7 @@
     <p:bg>
       <p:bgPr>
         <a:solidFill>
-          <a:srgbClr val="F4F7F6"/>
+          <a:srgbClr val="F4F7FB"/>
         </a:solidFill>
       </p:bgPr>
     </p:bg>
@@ -2328,7 +2328,7 @@
             <a:r>
               <a:rPr lang="en-US" sz="1150" b="1" spc="160" kern="0" dirty="0">
                 <a:solidFill>
-                  <a:srgbClr val="0F5C4C"/>
+                  <a:srgbClr val="1B4F8A"/>
                 </a:solidFill>
                 <a:latin typeface="Calibri" pitchFamily="34" charset="0"/>
                 <a:ea typeface="Calibri" pitchFamily="34" charset="-122"/>
@@ -2367,7 +2367,7 @@
             <a:r>
               <a:rPr lang="en-US" sz="3800" b="1" dirty="0">
                 <a:solidFill>
-                  <a:srgbClr val="14211E"/>
+                  <a:srgbClr val="102A43"/>
                 </a:solidFill>
                 <a:latin typeface="Cambria" pitchFamily="34" charset="0"/>
                 <a:ea typeface="Cambria" pitchFamily="34" charset="-122"/>
@@ -2400,13 +2400,13 @@
           </a:solidFill>
           <a:ln w="9525">
             <a:solidFill>
-              <a:srgbClr val="C5D4CF"/>
+              <a:srgbClr val="C5D0E0"/>
             </a:solidFill>
             <a:prstDash val="solid"/>
           </a:ln>
           <a:effectLst>
             <a:outerShdw sx="100000" sy="100000" kx="0" ky="0" algn="bl" rotWithShape="0" blurRad="127000" dist="25400" dir="5400000">
-              <a:srgbClr val="14211e">
+              <a:srgbClr val="102a43">
                 <a:alpha val="10000"/>
               </a:srgbClr>
             </a:outerShdw>
@@ -2440,7 +2440,7 @@
             <a:r>
               <a:rPr lang="en-US" sz="4000" b="1" dirty="0">
                 <a:solidFill>
-                  <a:srgbClr val="0F5C4C"/>
+                  <a:srgbClr val="1B4F8A"/>
                 </a:solidFill>
                 <a:latin typeface="Cambria" pitchFamily="34" charset="0"/>
                 <a:ea typeface="Cambria" pitchFamily="34" charset="-122"/>
@@ -2479,7 +2479,7 @@
             <a:r>
               <a:rPr lang="en-US" sz="1500" b="1" dirty="0">
                 <a:solidFill>
-                  <a:srgbClr val="14211E"/>
+                  <a:srgbClr val="102A43"/>
                 </a:solidFill>
                 <a:latin typeface="Calibri" pitchFamily="34" charset="0"/>
                 <a:ea typeface="Calibri" pitchFamily="34" charset="-122"/>
@@ -2521,7 +2521,7 @@
             <a:r>
               <a:rPr lang="en-US" sz="1250" dirty="0">
                 <a:solidFill>
-                  <a:srgbClr val="3D524C"/>
+                  <a:srgbClr val="3D5270"/>
                 </a:solidFill>
                 <a:latin typeface="Calibri" pitchFamily="34" charset="0"/>
                 <a:ea typeface="Calibri" pitchFamily="34" charset="-122"/>
@@ -2554,13 +2554,13 @@
           </a:solidFill>
           <a:ln w="9525">
             <a:solidFill>
-              <a:srgbClr val="C5D4CF"/>
+              <a:srgbClr val="C5D0E0"/>
             </a:solidFill>
             <a:prstDash val="solid"/>
           </a:ln>
           <a:effectLst>
             <a:outerShdw sx="100000" sy="100000" kx="0" ky="0" algn="bl" rotWithShape="0" blurRad="127000" dist="25400" dir="5400000">
-              <a:srgbClr val="14211e">
+              <a:srgbClr val="102a43">
                 <a:alpha val="10000"/>
               </a:srgbClr>
             </a:outerShdw>
@@ -2594,7 +2594,7 @@
             <a:r>
               <a:rPr lang="en-US" sz="4000" b="1" dirty="0">
                 <a:solidFill>
-                  <a:srgbClr val="0F5C4C"/>
+                  <a:srgbClr val="1B4F8A"/>
                 </a:solidFill>
                 <a:latin typeface="Cambria" pitchFamily="34" charset="0"/>
                 <a:ea typeface="Cambria" pitchFamily="34" charset="-122"/>
@@ -2633,7 +2633,7 @@
             <a:r>
               <a:rPr lang="en-US" sz="1500" b="1" dirty="0">
                 <a:solidFill>
-                  <a:srgbClr val="14211E"/>
+                  <a:srgbClr val="102A43"/>
                 </a:solidFill>
                 <a:latin typeface="Calibri" pitchFamily="34" charset="0"/>
                 <a:ea typeface="Calibri" pitchFamily="34" charset="-122"/>
@@ -2675,7 +2675,7 @@
             <a:r>
               <a:rPr lang="en-US" sz="1250" dirty="0">
                 <a:solidFill>
-                  <a:srgbClr val="3D524C"/>
+                  <a:srgbClr val="3D5270"/>
                 </a:solidFill>
                 <a:latin typeface="Calibri" pitchFamily="34" charset="0"/>
                 <a:ea typeface="Calibri" pitchFamily="34" charset="-122"/>
@@ -2708,13 +2708,13 @@
           </a:solidFill>
           <a:ln w="9525">
             <a:solidFill>
-              <a:srgbClr val="C5D4CF"/>
+              <a:srgbClr val="C5D0E0"/>
             </a:solidFill>
             <a:prstDash val="solid"/>
           </a:ln>
           <a:effectLst>
             <a:outerShdw sx="100000" sy="100000" kx="0" ky="0" algn="bl" rotWithShape="0" blurRad="127000" dist="25400" dir="5400000">
-              <a:srgbClr val="14211e">
+              <a:srgbClr val="102a43">
                 <a:alpha val="10000"/>
               </a:srgbClr>
             </a:outerShdw>
@@ -2748,7 +2748,7 @@
             <a:r>
               <a:rPr lang="en-US" sz="4000" b="1" dirty="0">
                 <a:solidFill>
-                  <a:srgbClr val="0F5C4C"/>
+                  <a:srgbClr val="1B4F8A"/>
                 </a:solidFill>
                 <a:latin typeface="Cambria" pitchFamily="34" charset="0"/>
                 <a:ea typeface="Cambria" pitchFamily="34" charset="-122"/>
@@ -2787,7 +2787,7 @@
             <a:r>
               <a:rPr lang="en-US" sz="1500" b="1" dirty="0">
                 <a:solidFill>
-                  <a:srgbClr val="14211E"/>
+                  <a:srgbClr val="102A43"/>
                 </a:solidFill>
                 <a:latin typeface="Calibri" pitchFamily="34" charset="0"/>
                 <a:ea typeface="Calibri" pitchFamily="34" charset="-122"/>
@@ -2829,7 +2829,7 @@
             <a:r>
               <a:rPr lang="en-US" sz="1250" dirty="0">
                 <a:solidFill>
-                  <a:srgbClr val="3D524C"/>
+                  <a:srgbClr val="3D5270"/>
                 </a:solidFill>
                 <a:latin typeface="Calibri" pitchFamily="34" charset="0"/>
                 <a:ea typeface="Calibri" pitchFamily="34" charset="-122"/>
@@ -2862,13 +2862,13 @@
           </a:solidFill>
           <a:ln w="9525">
             <a:solidFill>
-              <a:srgbClr val="C5D4CF"/>
+              <a:srgbClr val="C5D0E0"/>
             </a:solidFill>
             <a:prstDash val="solid"/>
           </a:ln>
           <a:effectLst>
             <a:outerShdw sx="100000" sy="100000" kx="0" ky="0" algn="bl" rotWithShape="0" blurRad="127000" dist="25400" dir="5400000">
-              <a:srgbClr val="14211e">
+              <a:srgbClr val="102a43">
                 <a:alpha val="10000"/>
               </a:srgbClr>
             </a:outerShdw>
@@ -2902,7 +2902,7 @@
             <a:r>
               <a:rPr lang="en-US" sz="1150" b="1" spc="140" kern="0" dirty="0">
                 <a:solidFill>
-                  <a:srgbClr val="0F5C4C"/>
+                  <a:srgbClr val="1B4F8A"/>
                 </a:solidFill>
                 <a:latin typeface="Calibri" pitchFamily="34" charset="0"/>
                 <a:ea typeface="Calibri" pitchFamily="34" charset="-122"/>
@@ -2944,7 +2944,7 @@
             <a:r>
               <a:rPr lang="en-US" sz="1400" dirty="0">
                 <a:solidFill>
-                  <a:srgbClr val="14211E"/>
+                  <a:srgbClr val="102A43"/>
                 </a:solidFill>
                 <a:latin typeface="Calibri" pitchFamily="34" charset="0"/>
                 <a:ea typeface="Calibri" pitchFamily="34" charset="-122"/>
@@ -2973,12 +2973,12 @@
             </a:avLst>
           </a:prstGeom>
           <a:solidFill>
-            <a:srgbClr val="14211E"/>
+            <a:srgbClr val="102A43"/>
           </a:solidFill>
           <a:ln/>
           <a:effectLst>
             <a:outerShdw sx="100000" sy="100000" kx="0" ky="0" algn="bl" rotWithShape="0" blurRad="127000" dist="25400" dir="5400000">
-              <a:srgbClr val="14211e">
+              <a:srgbClr val="102a43">
                 <a:alpha val="10000"/>
               </a:srgbClr>
             </a:outerShdw>
@@ -3012,13 +3012,13 @@
             <a:r>
               <a:rPr lang="en-US" sz="1600" b="1" dirty="0">
                 <a:solidFill>
-                  <a:srgbClr val="F4F7F6"/>
-                </a:solidFill>
-                <a:latin typeface="Calibri" pitchFamily="34" charset="0"/>
-                <a:ea typeface="Calibri" pitchFamily="34" charset="-122"/>
-                <a:cs typeface="Calibri" pitchFamily="34" charset="-120"/>
-              </a:rPr>
-              <a:t>Out of scope this pass</a:t>
+                  <a:srgbClr val="F4F7FB"/>
+                </a:solidFill>
+                <a:latin typeface="Calibri" pitchFamily="34" charset="0"/>
+                <a:ea typeface="Calibri" pitchFamily="34" charset="-122"/>
+                <a:cs typeface="Calibri" pitchFamily="34" charset="-120"/>
+              </a:rPr>
+              <a:t>SHA deferred</a:t>
             </a:r>
             <a:endParaRPr lang="en-US" sz="1600" dirty="0"/>
           </a:p>
@@ -3054,13 +3054,13 @@
             <a:r>
               <a:rPr lang="en-US" sz="1250" dirty="0">
                 <a:solidFill>
-                  <a:srgbClr val="C5D4CF"/>
-                </a:solidFill>
-                <a:latin typeface="Calibri" pitchFamily="34" charset="0"/>
-                <a:ea typeface="Calibri" pitchFamily="34" charset="-122"/>
-                <a:cs typeface="Calibri" pitchFamily="34" charset="-120"/>
-              </a:rPr>
-              <a:t>National insurance rails, claims and reimbursement integration. Deferred on purpose — the wedge is shifting load before the door, not moving money after it.</a:t>
+                  <a:srgbClr val="C5D0E0"/>
+                </a:solidFill>
+                <a:latin typeface="Calibri" pitchFamily="34" charset="0"/>
+                <a:ea typeface="Calibri" pitchFamily="34" charset="-122"/>
+                <a:cs typeface="Calibri" pitchFamily="34" charset="-120"/>
+              </a:rPr>
+              <a:t>SHA claims, AfyaKE and HIE stay out of this pass. The wedge is shifting load before the door, not moving money after it.</a:t>
             </a:r>
             <a:endParaRPr lang="en-US" sz="1250" dirty="0"/>
           </a:p>
@@ -3093,7 +3093,7 @@
             <a:r>
               <a:rPr lang="en-US" sz="1050" dirty="0">
                 <a:solidFill>
-                  <a:srgbClr val="3D524C"/>
+                  <a:srgbClr val="3D5270"/>
                 </a:solidFill>
                 <a:latin typeface="Calibri" pitchFamily="34" charset="0"/>
                 <a:ea typeface="Calibri" pitchFamily="34" charset="-122"/>
@@ -3119,7 +3119,7 @@
     <p:bg>
       <p:bgPr>
         <a:solidFill>
-          <a:srgbClr val="14211E"/>
+          <a:srgbClr val="102A43"/>
         </a:solidFill>
       </p:bgPr>
     </p:bg>
@@ -3167,7 +3167,7 @@
             <a:r>
               <a:rPr lang="en-US" sz="5600" b="1" dirty="0">
                 <a:solidFill>
-                  <a:srgbClr val="F4F7F6"/>
+                  <a:srgbClr val="F4F7FB"/>
                 </a:solidFill>
                 <a:latin typeface="Cambria" pitchFamily="34" charset="0"/>
                 <a:ea typeface="Cambria" pitchFamily="34" charset="-122"/>
@@ -3206,7 +3206,7 @@
             <a:r>
               <a:rPr lang="en-US" sz="2200" dirty="0">
                 <a:solidFill>
-                  <a:srgbClr val="C5D4CF"/>
+                  <a:srgbClr val="B8C7DB"/>
                 </a:solidFill>
                 <a:latin typeface="Calibri" pitchFamily="34" charset="0"/>
                 <a:ea typeface="Calibri" pitchFamily="34" charset="-122"/>
@@ -3245,7 +3245,7 @@
             <a:r>
               <a:rPr lang="en-US" sz="1250" spc="140" kern="0" dirty="0">
                 <a:solidFill>
-                  <a:srgbClr val="C5D4CF"/>
+                  <a:srgbClr val="B8C7DB"/>
                 </a:solidFill>
                 <a:latin typeface="Calibri" pitchFamily="34" charset="0"/>
                 <a:ea typeface="Calibri" pitchFamily="34" charset="-122"/>
@@ -3274,12 +3274,12 @@
             </a:avLst>
           </a:prstGeom>
           <a:solidFill>
-            <a:srgbClr val="0F5C4C"/>
+            <a:srgbClr val="1B4F8A"/>
           </a:solidFill>
           <a:ln/>
           <a:effectLst>
             <a:outerShdw sx="100000" sy="100000" kx="0" ky="0" algn="bl" rotWithShape="0" blurRad="127000" dist="25400" dir="5400000">
-              <a:srgbClr val="14211e">
+              <a:srgbClr val="102a43">
                 <a:alpha val="10000"/>
               </a:srgbClr>
             </a:outerShdw>
@@ -3313,7 +3313,7 @@
             <a:r>
               <a:rPr lang="en-US" sz="1700" b="1" dirty="0">
                 <a:solidFill>
-                  <a:srgbClr val="F4F7F6"/>
+                  <a:srgbClr val="F4F7FB"/>
                 </a:solidFill>
                 <a:latin typeface="Calibri" pitchFamily="34" charset="0"/>
                 <a:ea typeface="Calibri" pitchFamily="34" charset="-122"/>
@@ -3355,7 +3355,7 @@
             <a:r>
               <a:rPr lang="en-US" sz="1150" dirty="0">
                 <a:solidFill>
-                  <a:srgbClr val="C5D4CF"/>
+                  <a:srgbClr val="C5D0E0"/>
                 </a:solidFill>
                 <a:latin typeface="Calibri" pitchFamily="34" charset="0"/>
                 <a:ea typeface="Calibri" pitchFamily="34" charset="-122"/>
@@ -3384,12 +3384,12 @@
             </a:avLst>
           </a:prstGeom>
           <a:solidFill>
-            <a:srgbClr val="0F5C4C"/>
+            <a:srgbClr val="1B4F8A"/>
           </a:solidFill>
           <a:ln/>
           <a:effectLst>
             <a:outerShdw sx="100000" sy="100000" kx="0" ky="0" algn="bl" rotWithShape="0" blurRad="127000" dist="25400" dir="5400000">
-              <a:srgbClr val="14211e">
+              <a:srgbClr val="102a43">
                 <a:alpha val="10000"/>
               </a:srgbClr>
             </a:outerShdw>
@@ -3423,7 +3423,7 @@
             <a:r>
               <a:rPr lang="en-US" sz="1700" b="1" dirty="0">
                 <a:solidFill>
-                  <a:srgbClr val="F4F7F6"/>
+                  <a:srgbClr val="F4F7FB"/>
                 </a:solidFill>
                 <a:latin typeface="Calibri" pitchFamily="34" charset="0"/>
                 <a:ea typeface="Calibri" pitchFamily="34" charset="-122"/>
@@ -3465,7 +3465,7 @@
             <a:r>
               <a:rPr lang="en-US" sz="1150" dirty="0">
                 <a:solidFill>
-                  <a:srgbClr val="C5D4CF"/>
+                  <a:srgbClr val="C5D0E0"/>
                 </a:solidFill>
                 <a:latin typeface="Calibri" pitchFamily="34" charset="0"/>
                 <a:ea typeface="Calibri" pitchFamily="34" charset="-122"/>
@@ -3491,7 +3491,7 @@
     <p:bg>
       <p:bgPr>
         <a:solidFill>
-          <a:srgbClr val="F4F7F6"/>
+          <a:srgbClr val="F4F7FB"/>
         </a:solidFill>
       </p:bgPr>
     </p:bg>
@@ -3536,7 +3536,7 @@
             <a:r>
               <a:rPr lang="en-US" sz="1150" b="1" spc="160" kern="0" dirty="0">
                 <a:solidFill>
-                  <a:srgbClr val="0F5C4C"/>
+                  <a:srgbClr val="1B4F8A"/>
                 </a:solidFill>
                 <a:latin typeface="Calibri" pitchFamily="34" charset="0"/>
                 <a:ea typeface="Calibri" pitchFamily="34" charset="-122"/>
@@ -3575,7 +3575,7 @@
             <a:r>
               <a:rPr lang="en-US" sz="3800" b="1" dirty="0">
                 <a:solidFill>
-                  <a:srgbClr val="14211E"/>
+                  <a:srgbClr val="102A43"/>
                 </a:solidFill>
                 <a:latin typeface="Cambria" pitchFamily="34" charset="0"/>
                 <a:ea typeface="Cambria" pitchFamily="34" charset="-122"/>
@@ -3614,7 +3614,7 @@
             <a:r>
               <a:rPr lang="en-US" sz="7200" b="1" dirty="0">
                 <a:solidFill>
-                  <a:srgbClr val="0F5C4C"/>
+                  <a:srgbClr val="1B4F8A"/>
                 </a:solidFill>
                 <a:latin typeface="Cambria" pitchFamily="34" charset="0"/>
                 <a:ea typeface="Cambria" pitchFamily="34" charset="-122"/>
@@ -3653,7 +3653,7 @@
             <a:r>
               <a:rPr lang="en-US" sz="1800" b="1" dirty="0">
                 <a:solidFill>
-                  <a:srgbClr val="14211E"/>
+                  <a:srgbClr val="102A43"/>
                 </a:solidFill>
                 <a:latin typeface="Calibri" pitchFamily="34" charset="0"/>
                 <a:ea typeface="Calibri" pitchFamily="34" charset="-122"/>
@@ -3695,7 +3695,7 @@
             <a:r>
               <a:rPr lang="en-US" sz="1500" dirty="0">
                 <a:solidFill>
-                  <a:srgbClr val="3D524C"/>
+                  <a:srgbClr val="3D5270"/>
                 </a:solidFill>
                 <a:latin typeface="Calibri" pitchFamily="34" charset="0"/>
                 <a:ea typeface="Calibri" pitchFamily="34" charset="-122"/>
@@ -3728,13 +3728,13 @@
           </a:solidFill>
           <a:ln w="9525">
             <a:solidFill>
-              <a:srgbClr val="C5D4CF"/>
+              <a:srgbClr val="C5D0E0"/>
             </a:solidFill>
             <a:prstDash val="solid"/>
           </a:ln>
           <a:effectLst>
             <a:outerShdw sx="100000" sy="100000" kx="0" ky="0" algn="bl" rotWithShape="0" blurRad="127000" dist="25400" dir="5400000">
-              <a:srgbClr val="14211e">
+              <a:srgbClr val="102a43">
                 <a:alpha val="10000"/>
               </a:srgbClr>
             </a:outerShdw>
@@ -3768,7 +3768,7 @@
             <a:r>
               <a:rPr lang="en-US" sz="1150" b="1" spc="140" kern="0" dirty="0">
                 <a:solidFill>
-                  <a:srgbClr val="0F5C4C"/>
+                  <a:srgbClr val="1B4F8A"/>
                 </a:solidFill>
                 <a:latin typeface="Calibri" pitchFamily="34" charset="0"/>
                 <a:ea typeface="Calibri" pitchFamily="34" charset="-122"/>
@@ -3797,17 +3797,17 @@
             </a:avLst>
           </a:prstGeom>
           <a:solidFill>
-            <a:srgbClr val="F4F7F6"/>
+            <a:srgbClr val="F4F7FB"/>
           </a:solidFill>
           <a:ln w="9525">
             <a:solidFill>
-              <a:srgbClr val="C5D4CF"/>
+              <a:srgbClr val="C5D0E0"/>
             </a:solidFill>
             <a:prstDash val="solid"/>
           </a:ln>
           <a:effectLst>
             <a:outerShdw sx="100000" sy="100000" kx="0" ky="0" algn="bl" rotWithShape="0" blurRad="127000" dist="25400" dir="5400000">
-              <a:srgbClr val="14211e">
+              <a:srgbClr val="102a43">
                 <a:alpha val="10000"/>
               </a:srgbClr>
             </a:outerShdw>
@@ -3841,7 +3841,7 @@
             <a:r>
               <a:rPr lang="en-US" sz="1350" b="1" dirty="0">
                 <a:solidFill>
-                  <a:srgbClr val="14211E"/>
+                  <a:srgbClr val="102A43"/>
                 </a:solidFill>
                 <a:latin typeface="Calibri" pitchFamily="34" charset="0"/>
                 <a:ea typeface="Calibri" pitchFamily="34" charset="-122"/>
@@ -3880,7 +3880,7 @@
             <a:r>
               <a:rPr lang="en-US" sz="1100" dirty="0">
                 <a:solidFill>
-                  <a:srgbClr val="3D524C"/>
+                  <a:srgbClr val="3D5270"/>
                 </a:solidFill>
                 <a:latin typeface="Calibri" pitchFamily="34" charset="0"/>
                 <a:ea typeface="Calibri" pitchFamily="34" charset="-122"/>
@@ -3909,17 +3909,17 @@
             </a:avLst>
           </a:prstGeom>
           <a:solidFill>
-            <a:srgbClr val="F4F7F6"/>
+            <a:srgbClr val="F4F7FB"/>
           </a:solidFill>
           <a:ln w="9525">
             <a:solidFill>
-              <a:srgbClr val="C5D4CF"/>
+              <a:srgbClr val="C5D0E0"/>
             </a:solidFill>
             <a:prstDash val="solid"/>
           </a:ln>
           <a:effectLst>
             <a:outerShdw sx="100000" sy="100000" kx="0" ky="0" algn="bl" rotWithShape="0" blurRad="127000" dist="25400" dir="5400000">
-              <a:srgbClr val="14211e">
+              <a:srgbClr val="102a43">
                 <a:alpha val="10000"/>
               </a:srgbClr>
             </a:outerShdw>
@@ -3953,7 +3953,7 @@
             <a:r>
               <a:rPr lang="en-US" sz="1350" b="1" dirty="0">
                 <a:solidFill>
-                  <a:srgbClr val="14211E"/>
+                  <a:srgbClr val="102A43"/>
                 </a:solidFill>
                 <a:latin typeface="Calibri" pitchFamily="34" charset="0"/>
                 <a:ea typeface="Calibri" pitchFamily="34" charset="-122"/>
@@ -3992,7 +3992,7 @@
             <a:r>
               <a:rPr lang="en-US" sz="1100" dirty="0">
                 <a:solidFill>
-                  <a:srgbClr val="3D524C"/>
+                  <a:srgbClr val="3D5270"/>
                 </a:solidFill>
                 <a:latin typeface="Calibri" pitchFamily="34" charset="0"/>
                 <a:ea typeface="Calibri" pitchFamily="34" charset="-122"/>
@@ -4021,12 +4021,12 @@
             </a:avLst>
           </a:prstGeom>
           <a:solidFill>
-            <a:srgbClr val="0F5C4C"/>
+            <a:srgbClr val="1B4F8A"/>
           </a:solidFill>
           <a:ln/>
           <a:effectLst>
             <a:outerShdw sx="100000" sy="100000" kx="0" ky="0" algn="bl" rotWithShape="0" blurRad="127000" dist="25400" dir="5400000">
-              <a:srgbClr val="14211e">
+              <a:srgbClr val="102a43">
                 <a:alpha val="10000"/>
               </a:srgbClr>
             </a:outerShdw>
@@ -4060,7 +4060,7 @@
             <a:r>
               <a:rPr lang="en-US" sz="1350" b="1" dirty="0">
                 <a:solidFill>
-                  <a:srgbClr val="F4F7F6"/>
+                  <a:srgbClr val="F4F7FB"/>
                 </a:solidFill>
                 <a:latin typeface="Calibri" pitchFamily="34" charset="0"/>
                 <a:ea typeface="Calibri" pitchFamily="34" charset="-122"/>
@@ -4099,7 +4099,7 @@
             <a:r>
               <a:rPr lang="en-US" sz="1100" dirty="0">
                 <a:solidFill>
-                  <a:srgbClr val="C5D4CF"/>
+                  <a:srgbClr val="C5D0E0"/>
                 </a:solidFill>
                 <a:latin typeface="Calibri" pitchFamily="34" charset="0"/>
                 <a:ea typeface="Calibri" pitchFamily="34" charset="-122"/>
@@ -4162,7 +4162,7 @@
             <a:r>
               <a:rPr lang="en-US" sz="1050" dirty="0">
                 <a:solidFill>
-                  <a:srgbClr val="3D524C"/>
+                  <a:srgbClr val="3D5270"/>
                 </a:solidFill>
                 <a:latin typeface="Calibri" pitchFamily="34" charset="0"/>
                 <a:ea typeface="Calibri" pitchFamily="34" charset="-122"/>
@@ -4188,7 +4188,7 @@
     <p:bg>
       <p:bgPr>
         <a:solidFill>
-          <a:srgbClr val="F4F7F6"/>
+          <a:srgbClr val="F4F7FB"/>
         </a:solidFill>
       </p:bgPr>
     </p:bg>
@@ -4233,7 +4233,7 @@
             <a:r>
               <a:rPr lang="en-US" sz="1150" b="1" spc="160" kern="0" dirty="0">
                 <a:solidFill>
-                  <a:srgbClr val="0F5C4C"/>
+                  <a:srgbClr val="1B4F8A"/>
                 </a:solidFill>
                 <a:latin typeface="Calibri" pitchFamily="34" charset="0"/>
                 <a:ea typeface="Calibri" pitchFamily="34" charset="-122"/>
@@ -4272,7 +4272,7 @@
             <a:r>
               <a:rPr lang="en-US" sz="3800" b="1" dirty="0">
                 <a:solidFill>
-                  <a:srgbClr val="14211E"/>
+                  <a:srgbClr val="102A43"/>
                 </a:solidFill>
                 <a:latin typeface="Cambria" pitchFamily="34" charset="0"/>
                 <a:ea typeface="Cambria" pitchFamily="34" charset="-122"/>
@@ -4293,11 +4293,11 @@
         <p:spPr>
           <a:xfrm>
             <a:off x="548640" y="1874520"/>
-            <a:ext cx="3447288" cy="2651760"/>
+            <a:ext cx="3447288" cy="2377440"/>
           </a:xfrm>
           <a:prstGeom prst="roundRect">
             <a:avLst>
-              <a:gd name="adj" fmla="val 4828"/>
+              <a:gd name="adj" fmla="val 5385"/>
             </a:avLst>
           </a:prstGeom>
           <a:solidFill>
@@ -4305,13 +4305,13 @@
           </a:solidFill>
           <a:ln w="9525">
             <a:solidFill>
-              <a:srgbClr val="C5D4CF"/>
+              <a:srgbClr val="C5D0E0"/>
             </a:solidFill>
             <a:prstDash val="solid"/>
           </a:ln>
           <a:effectLst>
             <a:outerShdw sx="100000" sy="100000" kx="0" ky="0" algn="bl" rotWithShape="0" blurRad="127000" dist="25400" dir="5400000">
-              <a:srgbClr val="14211e">
+              <a:srgbClr val="102a43">
                 <a:alpha val="10000"/>
               </a:srgbClr>
             </a:outerShdw>
@@ -4345,7 +4345,7 @@
             <a:r>
               <a:rPr lang="en-US" sz="5400" b="1" dirty="0">
                 <a:solidFill>
-                  <a:srgbClr val="0F5C4C"/>
+                  <a:srgbClr val="1B4F8A"/>
                 </a:solidFill>
                 <a:latin typeface="Cambria" pitchFamily="34" charset="0"/>
                 <a:ea typeface="Cambria" pitchFamily="34" charset="-122"/>
@@ -4384,7 +4384,7 @@
             <a:r>
               <a:rPr lang="en-US" sz="1500" b="1" dirty="0">
                 <a:solidFill>
-                  <a:srgbClr val="14211E"/>
+                  <a:srgbClr val="102A43"/>
                 </a:solidFill>
                 <a:latin typeface="Calibri" pitchFamily="34" charset="0"/>
                 <a:ea typeface="Calibri" pitchFamily="34" charset="-122"/>
@@ -4405,7 +4405,7 @@
         <p:spPr>
           <a:xfrm>
             <a:off x="841248" y="3593592"/>
-            <a:ext cx="2862072" cy="749808"/>
+            <a:ext cx="2862072" cy="475488"/>
           </a:xfrm>
           <a:prstGeom prst="rect">
             <a:avLst/>
@@ -4426,7 +4426,7 @@
             <a:r>
               <a:rPr lang="en-US" sz="1250" dirty="0">
                 <a:solidFill>
-                  <a:srgbClr val="3D524C"/>
+                  <a:srgbClr val="3D5270"/>
                 </a:solidFill>
                 <a:latin typeface="Calibri" pitchFamily="34" charset="0"/>
                 <a:ea typeface="Calibri" pitchFamily="34" charset="-122"/>
@@ -4447,11 +4447,11 @@
         <p:spPr>
           <a:xfrm>
             <a:off x="4361688" y="1874520"/>
-            <a:ext cx="3447288" cy="2651760"/>
+            <a:ext cx="3447288" cy="2377440"/>
           </a:xfrm>
           <a:prstGeom prst="roundRect">
             <a:avLst>
-              <a:gd name="adj" fmla="val 4828"/>
+              <a:gd name="adj" fmla="val 5385"/>
             </a:avLst>
           </a:prstGeom>
           <a:solidFill>
@@ -4459,13 +4459,13 @@
           </a:solidFill>
           <a:ln w="9525">
             <a:solidFill>
-              <a:srgbClr val="C5D4CF"/>
+              <a:srgbClr val="C5D0E0"/>
             </a:solidFill>
             <a:prstDash val="solid"/>
           </a:ln>
           <a:effectLst>
             <a:outerShdw sx="100000" sy="100000" kx="0" ky="0" algn="bl" rotWithShape="0" blurRad="127000" dist="25400" dir="5400000">
-              <a:srgbClr val="14211e">
+              <a:srgbClr val="102a43">
                 <a:alpha val="10000"/>
               </a:srgbClr>
             </a:outerShdw>
@@ -4499,7 +4499,7 @@
             <a:r>
               <a:rPr lang="en-US" sz="5400" b="1" dirty="0">
                 <a:solidFill>
-                  <a:srgbClr val="0F5C4C"/>
+                  <a:srgbClr val="1B4F8A"/>
                 </a:solidFill>
                 <a:latin typeface="Cambria" pitchFamily="34" charset="0"/>
                 <a:ea typeface="Cambria" pitchFamily="34" charset="-122"/>
@@ -4538,7 +4538,7 @@
             <a:r>
               <a:rPr lang="en-US" sz="1500" b="1" dirty="0">
                 <a:solidFill>
-                  <a:srgbClr val="14211E"/>
+                  <a:srgbClr val="102A43"/>
                 </a:solidFill>
                 <a:latin typeface="Calibri" pitchFamily="34" charset="0"/>
                 <a:ea typeface="Calibri" pitchFamily="34" charset="-122"/>
@@ -4559,7 +4559,7 @@
         <p:spPr>
           <a:xfrm>
             <a:off x="4654296" y="3593592"/>
-            <a:ext cx="2862072" cy="749808"/>
+            <a:ext cx="2862072" cy="475488"/>
           </a:xfrm>
           <a:prstGeom prst="rect">
             <a:avLst/>
@@ -4580,7 +4580,7 @@
             <a:r>
               <a:rPr lang="en-US" sz="1250" dirty="0">
                 <a:solidFill>
-                  <a:srgbClr val="3D524C"/>
+                  <a:srgbClr val="3D5270"/>
                 </a:solidFill>
                 <a:latin typeface="Calibri" pitchFamily="34" charset="0"/>
                 <a:ea typeface="Calibri" pitchFamily="34" charset="-122"/>
@@ -4601,11 +4601,11 @@
         <p:spPr>
           <a:xfrm>
             <a:off x="8174736" y="1874520"/>
-            <a:ext cx="3447288" cy="2651760"/>
+            <a:ext cx="3447288" cy="2377440"/>
           </a:xfrm>
           <a:prstGeom prst="roundRect">
             <a:avLst>
-              <a:gd name="adj" fmla="val 4828"/>
+              <a:gd name="adj" fmla="val 5385"/>
             </a:avLst>
           </a:prstGeom>
           <a:solidFill>
@@ -4613,13 +4613,13 @@
           </a:solidFill>
           <a:ln w="9525">
             <a:solidFill>
-              <a:srgbClr val="C5D4CF"/>
+              <a:srgbClr val="C5D0E0"/>
             </a:solidFill>
             <a:prstDash val="solid"/>
           </a:ln>
           <a:effectLst>
             <a:outerShdw sx="100000" sy="100000" kx="0" ky="0" algn="bl" rotWithShape="0" blurRad="127000" dist="25400" dir="5400000">
-              <a:srgbClr val="14211e">
+              <a:srgbClr val="102a43">
                 <a:alpha val="10000"/>
               </a:srgbClr>
             </a:outerShdw>
@@ -4653,7 +4653,7 @@
             <a:r>
               <a:rPr lang="en-US" sz="5400" b="1" dirty="0">
                 <a:solidFill>
-                  <a:srgbClr val="0F5C4C"/>
+                  <a:srgbClr val="1B4F8A"/>
                 </a:solidFill>
                 <a:latin typeface="Cambria" pitchFamily="34" charset="0"/>
                 <a:ea typeface="Cambria" pitchFamily="34" charset="-122"/>
@@ -4692,7 +4692,7 @@
             <a:r>
               <a:rPr lang="en-US" sz="1500" b="1" dirty="0">
                 <a:solidFill>
-                  <a:srgbClr val="14211E"/>
+                  <a:srgbClr val="102A43"/>
                 </a:solidFill>
                 <a:latin typeface="Calibri" pitchFamily="34" charset="0"/>
                 <a:ea typeface="Calibri" pitchFamily="34" charset="-122"/>
@@ -4713,7 +4713,7 @@
         <p:spPr>
           <a:xfrm>
             <a:off x="8467344" y="3593592"/>
-            <a:ext cx="2862072" cy="749808"/>
+            <a:ext cx="2862072" cy="475488"/>
           </a:xfrm>
           <a:prstGeom prst="rect">
             <a:avLst/>
@@ -4734,13 +4734,13 @@
             <a:r>
               <a:rPr lang="en-US" sz="1250" dirty="0">
                 <a:solidFill>
-                  <a:srgbClr val="3D524C"/>
-                </a:solidFill>
-                <a:latin typeface="Calibri" pitchFamily="34" charset="0"/>
-                <a:ea typeface="Calibri" pitchFamily="34" charset="-122"/>
-                <a:cs typeface="Calibri" pitchFamily="34" charset="-120"/>
-              </a:rPr>
-              <a:t>About 1,000 outpatients through the door every day.</a:t>
+                  <a:srgbClr val="3D5270"/>
+                </a:solidFill>
+                <a:latin typeface="Calibri" pitchFamily="34" charset="0"/>
+                <a:ea typeface="Calibri" pitchFamily="34" charset="-122"/>
+                <a:cs typeface="Calibri" pitchFamily="34" charset="-120"/>
+              </a:rPr>
+              <a:t>~1,000 outpatients through the door every day.</a:t>
             </a:r>
             <a:endParaRPr lang="en-US" sz="1250" dirty="0"/>
           </a:p>
@@ -4754,7 +4754,7 @@
         </p:nvSpPr>
         <p:spPr>
           <a:xfrm>
-            <a:off x="548640" y="4754880"/>
+            <a:off x="548640" y="4572000"/>
             <a:ext cx="10607040" cy="822960"/>
           </a:xfrm>
           <a:prstGeom prst="rect">
@@ -4776,7 +4776,7 @@
             <a:r>
               <a:rPr lang="en-US" sz="1600" dirty="0">
                 <a:solidFill>
-                  <a:srgbClr val="14211E"/>
+                  <a:srgbClr val="102A43"/>
                 </a:solidFill>
                 <a:latin typeface="Calibri" pitchFamily="34" charset="0"/>
                 <a:ea typeface="Calibri" pitchFamily="34" charset="-122"/>
@@ -4815,7 +4815,7 @@
             <a:r>
               <a:rPr lang="en-US" sz="1050" dirty="0">
                 <a:solidFill>
-                  <a:srgbClr val="3D524C"/>
+                  <a:srgbClr val="3D5270"/>
                 </a:solidFill>
                 <a:latin typeface="Calibri" pitchFamily="34" charset="0"/>
                 <a:ea typeface="Calibri" pitchFamily="34" charset="-122"/>
@@ -4841,7 +4841,7 @@
     <p:bg>
       <p:bgPr>
         <a:solidFill>
-          <a:srgbClr val="F4F7F6"/>
+          <a:srgbClr val="F4F7FB"/>
         </a:solidFill>
       </p:bgPr>
     </p:bg>
@@ -4886,7 +4886,7 @@
             <a:r>
               <a:rPr lang="en-US" sz="1150" b="1" spc="160" kern="0" dirty="0">
                 <a:solidFill>
-                  <a:srgbClr val="0F5C4C"/>
+                  <a:srgbClr val="1B4F8A"/>
                 </a:solidFill>
                 <a:latin typeface="Calibri" pitchFamily="34" charset="0"/>
                 <a:ea typeface="Calibri" pitchFamily="34" charset="-122"/>
@@ -4925,7 +4925,7 @@
             <a:r>
               <a:rPr lang="en-US" sz="3800" b="1" dirty="0">
                 <a:solidFill>
-                  <a:srgbClr val="14211E"/>
+                  <a:srgbClr val="102A43"/>
                 </a:solidFill>
                 <a:latin typeface="Cambria" pitchFamily="34" charset="0"/>
                 <a:ea typeface="Cambria" pitchFamily="34" charset="-122"/>
@@ -4946,11 +4946,11 @@
         <p:spPr>
           <a:xfrm>
             <a:off x="548640" y="1828800"/>
-            <a:ext cx="2039112" cy="2103120"/>
+            <a:ext cx="2039112" cy="1874520"/>
           </a:xfrm>
           <a:prstGeom prst="roundRect">
             <a:avLst>
-              <a:gd name="adj" fmla="val 6278"/>
+              <a:gd name="adj" fmla="val 6829"/>
             </a:avLst>
           </a:prstGeom>
           <a:solidFill>
@@ -4958,13 +4958,13 @@
           </a:solidFill>
           <a:ln w="9525">
             <a:solidFill>
-              <a:srgbClr val="C5D4CF"/>
+              <a:srgbClr val="C5D0E0"/>
             </a:solidFill>
             <a:prstDash val="solid"/>
           </a:ln>
           <a:effectLst>
             <a:outerShdw sx="100000" sy="100000" kx="0" ky="0" algn="bl" rotWithShape="0" blurRad="127000" dist="25400" dir="5400000">
-              <a:srgbClr val="14211e">
+              <a:srgbClr val="102a43">
                 <a:alpha val="10000"/>
               </a:srgbClr>
             </a:outerShdw>
@@ -4998,7 +4998,7 @@
             <a:r>
               <a:rPr lang="en-US" sz="4400" b="1" dirty="0">
                 <a:solidFill>
-                  <a:srgbClr val="0F5C4C"/>
+                  <a:srgbClr val="1B4F8A"/>
                 </a:solidFill>
                 <a:latin typeface="Cambria" pitchFamily="34" charset="0"/>
                 <a:ea typeface="Cambria" pitchFamily="34" charset="-122"/>
@@ -5037,7 +5037,7 @@
             <a:r>
               <a:rPr lang="en-US" sz="1500" b="1" dirty="0">
                 <a:solidFill>
-                  <a:srgbClr val="14211E"/>
+                  <a:srgbClr val="102A43"/>
                 </a:solidFill>
                 <a:latin typeface="Calibri" pitchFamily="34" charset="0"/>
                 <a:ea typeface="Calibri" pitchFamily="34" charset="-122"/>
@@ -5076,7 +5076,7 @@
             <a:r>
               <a:rPr lang="en-US" sz="1200" dirty="0">
                 <a:solidFill>
-                  <a:srgbClr val="3D524C"/>
+                  <a:srgbClr val="3D5270"/>
                 </a:solidFill>
                 <a:latin typeface="Calibri" pitchFamily="34" charset="0"/>
                 <a:ea typeface="Calibri" pitchFamily="34" charset="-122"/>
@@ -5097,11 +5097,11 @@
         <p:spPr>
           <a:xfrm>
             <a:off x="2862072" y="1828800"/>
-            <a:ext cx="2039112" cy="2103120"/>
+            <a:ext cx="2039112" cy="1874520"/>
           </a:xfrm>
           <a:prstGeom prst="roundRect">
             <a:avLst>
-              <a:gd name="adj" fmla="val 6278"/>
+              <a:gd name="adj" fmla="val 6829"/>
             </a:avLst>
           </a:prstGeom>
           <a:solidFill>
@@ -5109,13 +5109,13 @@
           </a:solidFill>
           <a:ln w="9525">
             <a:solidFill>
-              <a:srgbClr val="C5D4CF"/>
+              <a:srgbClr val="C5D0E0"/>
             </a:solidFill>
             <a:prstDash val="solid"/>
           </a:ln>
           <a:effectLst>
             <a:outerShdw sx="100000" sy="100000" kx="0" ky="0" algn="bl" rotWithShape="0" blurRad="127000" dist="25400" dir="5400000">
-              <a:srgbClr val="14211e">
+              <a:srgbClr val="102a43">
                 <a:alpha val="10000"/>
               </a:srgbClr>
             </a:outerShdw>
@@ -5149,7 +5149,7 @@
             <a:r>
               <a:rPr lang="en-US" sz="4400" b="1" dirty="0">
                 <a:solidFill>
-                  <a:srgbClr val="0F5C4C"/>
+                  <a:srgbClr val="1B4F8A"/>
                 </a:solidFill>
                 <a:latin typeface="Cambria" pitchFamily="34" charset="0"/>
                 <a:ea typeface="Cambria" pitchFamily="34" charset="-122"/>
@@ -5188,7 +5188,7 @@
             <a:r>
               <a:rPr lang="en-US" sz="1500" b="1" dirty="0">
                 <a:solidFill>
-                  <a:srgbClr val="14211E"/>
+                  <a:srgbClr val="102A43"/>
                 </a:solidFill>
                 <a:latin typeface="Calibri" pitchFamily="34" charset="0"/>
                 <a:ea typeface="Calibri" pitchFamily="34" charset="-122"/>
@@ -5227,7 +5227,7 @@
             <a:r>
               <a:rPr lang="en-US" sz="1200" dirty="0">
                 <a:solidFill>
-                  <a:srgbClr val="3D524C"/>
+                  <a:srgbClr val="3D5270"/>
                 </a:solidFill>
                 <a:latin typeface="Calibri" pitchFamily="34" charset="0"/>
                 <a:ea typeface="Calibri" pitchFamily="34" charset="-122"/>
@@ -5248,11 +5248,11 @@
         <p:spPr>
           <a:xfrm>
             <a:off x="5175504" y="1828800"/>
-            <a:ext cx="2039112" cy="2103120"/>
+            <a:ext cx="2039112" cy="1874520"/>
           </a:xfrm>
           <a:prstGeom prst="roundRect">
             <a:avLst>
-              <a:gd name="adj" fmla="val 6278"/>
+              <a:gd name="adj" fmla="val 6829"/>
             </a:avLst>
           </a:prstGeom>
           <a:solidFill>
@@ -5260,13 +5260,13 @@
           </a:solidFill>
           <a:ln w="9525">
             <a:solidFill>
-              <a:srgbClr val="C5D4CF"/>
+              <a:srgbClr val="C5D0E0"/>
             </a:solidFill>
             <a:prstDash val="solid"/>
           </a:ln>
           <a:effectLst>
             <a:outerShdw sx="100000" sy="100000" kx="0" ky="0" algn="bl" rotWithShape="0" blurRad="127000" dist="25400" dir="5400000">
-              <a:srgbClr val="14211e">
+              <a:srgbClr val="102a43">
                 <a:alpha val="10000"/>
               </a:srgbClr>
             </a:outerShdw>
@@ -5300,7 +5300,7 @@
             <a:r>
               <a:rPr lang="en-US" sz="4400" b="1" dirty="0">
                 <a:solidFill>
-                  <a:srgbClr val="0F5C4C"/>
+                  <a:srgbClr val="1B4F8A"/>
                 </a:solidFill>
                 <a:latin typeface="Cambria" pitchFamily="34" charset="0"/>
                 <a:ea typeface="Cambria" pitchFamily="34" charset="-122"/>
@@ -5339,7 +5339,7 @@
             <a:r>
               <a:rPr lang="en-US" sz="1500" b="1" dirty="0">
                 <a:solidFill>
-                  <a:srgbClr val="14211E"/>
+                  <a:srgbClr val="102A43"/>
                 </a:solidFill>
                 <a:latin typeface="Calibri" pitchFamily="34" charset="0"/>
                 <a:ea typeface="Calibri" pitchFamily="34" charset="-122"/>
@@ -5378,7 +5378,7 @@
             <a:r>
               <a:rPr lang="en-US" sz="1200" dirty="0">
                 <a:solidFill>
-                  <a:srgbClr val="3D524C"/>
+                  <a:srgbClr val="3D5270"/>
                 </a:solidFill>
                 <a:latin typeface="Calibri" pitchFamily="34" charset="0"/>
                 <a:ea typeface="Calibri" pitchFamily="34" charset="-122"/>
@@ -5398,7 +5398,7 @@
         </p:nvSpPr>
         <p:spPr>
           <a:xfrm>
-            <a:off x="548640" y="4160520"/>
+            <a:off x="548640" y="3977640"/>
             <a:ext cx="6675120" cy="1005840"/>
           </a:xfrm>
           <a:prstGeom prst="rect">
@@ -5420,7 +5420,7 @@
             <a:r>
               <a:rPr lang="en-US" sz="1600" dirty="0">
                 <a:solidFill>
-                  <a:srgbClr val="14211E"/>
+                  <a:srgbClr val="102A43"/>
                 </a:solidFill>
                 <a:latin typeface="Calibri" pitchFamily="34" charset="0"/>
                 <a:ea typeface="Calibri" pitchFamily="34" charset="-122"/>
@@ -5454,7 +5454,7 @@
           <a:ln/>
           <a:effectLst>
             <a:outerShdw sx="100000" sy="100000" kx="0" ky="0" algn="bl" rotWithShape="0" blurRad="127000" dist="25400" dir="5400000">
-              <a:srgbClr val="14211e">
+              <a:srgbClr val="102a43">
                 <a:alpha val="10000"/>
               </a:srgbClr>
             </a:outerShdw>
@@ -5566,7 +5566,7 @@
             <a:r>
               <a:rPr lang="en-US" sz="1400" b="1" dirty="0">
                 <a:solidFill>
-                  <a:srgbClr val="14211E"/>
+                  <a:srgbClr val="102A43"/>
                 </a:solidFill>
                 <a:latin typeface="Calibri" pitchFamily="34" charset="0"/>
                 <a:ea typeface="Calibri" pitchFamily="34" charset="-122"/>
@@ -5608,7 +5608,7 @@
             <a:r>
               <a:rPr lang="en-US" sz="1200" dirty="0">
                 <a:solidFill>
-                  <a:srgbClr val="3D524C"/>
+                  <a:srgbClr val="3D5270"/>
                 </a:solidFill>
                 <a:latin typeface="Calibri" pitchFamily="34" charset="0"/>
                 <a:ea typeface="Calibri" pitchFamily="34" charset="-122"/>
@@ -5647,7 +5647,7 @@
             <a:r>
               <a:rPr lang="en-US" sz="1050" dirty="0">
                 <a:solidFill>
-                  <a:srgbClr val="3D524C"/>
+                  <a:srgbClr val="3D5270"/>
                 </a:solidFill>
                 <a:latin typeface="Calibri" pitchFamily="34" charset="0"/>
                 <a:ea typeface="Calibri" pitchFamily="34" charset="-122"/>
@@ -5673,7 +5673,7 @@
     <p:bg>
       <p:bgPr>
         <a:solidFill>
-          <a:srgbClr val="F4F7F6"/>
+          <a:srgbClr val="F4F7FB"/>
         </a:solidFill>
       </p:bgPr>
     </p:bg>
@@ -5718,7 +5718,7 @@
             <a:r>
               <a:rPr lang="en-US" sz="1150" b="1" spc="160" kern="0" dirty="0">
                 <a:solidFill>
-                  <a:srgbClr val="0F5C4C"/>
+                  <a:srgbClr val="1B4F8A"/>
                 </a:solidFill>
                 <a:latin typeface="Calibri" pitchFamily="34" charset="0"/>
                 <a:ea typeface="Calibri" pitchFamily="34" charset="-122"/>
@@ -5757,7 +5757,7 @@
             <a:r>
               <a:rPr lang="en-US" sz="3800" b="1" dirty="0">
                 <a:solidFill>
-                  <a:srgbClr val="14211E"/>
+                  <a:srgbClr val="102A43"/>
                 </a:solidFill>
                 <a:latin typeface="Cambria" pitchFamily="34" charset="0"/>
                 <a:ea typeface="Cambria" pitchFamily="34" charset="-122"/>
@@ -5790,13 +5790,13 @@
           </a:solidFill>
           <a:ln w="9525">
             <a:solidFill>
-              <a:srgbClr val="C5D4CF"/>
+              <a:srgbClr val="C5D0E0"/>
             </a:solidFill>
             <a:prstDash val="solid"/>
           </a:ln>
           <a:effectLst>
             <a:outerShdw sx="100000" sy="100000" kx="0" ky="0" algn="bl" rotWithShape="0" blurRad="127000" dist="25400" dir="5400000">
-              <a:srgbClr val="14211e">
+              <a:srgbClr val="102a43">
                 <a:alpha val="10000"/>
               </a:srgbClr>
             </a:outerShdw>
@@ -5830,7 +5830,7 @@
             <a:r>
               <a:rPr lang="en-US" sz="1500" b="1" dirty="0">
                 <a:solidFill>
-                  <a:srgbClr val="14211E"/>
+                  <a:srgbClr val="102A43"/>
                 </a:solidFill>
                 <a:latin typeface="Calibri" pitchFamily="34" charset="0"/>
                 <a:ea typeface="Calibri" pitchFamily="34" charset="-122"/>
@@ -5869,7 +5869,7 @@
             <a:r>
               <a:rPr lang="en-US" sz="1300" b="1" dirty="0">
                 <a:solidFill>
-                  <a:srgbClr val="0F5C4C"/>
+                  <a:srgbClr val="1B4F8A"/>
                 </a:solidFill>
                 <a:latin typeface="Calibri" pitchFamily="34" charset="0"/>
                 <a:ea typeface="Calibri" pitchFamily="34" charset="-122"/>
@@ -5911,7 +5911,7 @@
             <a:r>
               <a:rPr lang="en-US" sz="1200" dirty="0">
                 <a:solidFill>
-                  <a:srgbClr val="3D524C"/>
+                  <a:srgbClr val="3D5270"/>
                 </a:solidFill>
                 <a:latin typeface="Calibri" pitchFamily="34" charset="0"/>
                 <a:ea typeface="Calibri" pitchFamily="34" charset="-122"/>
@@ -5944,13 +5944,13 @@
           </a:solidFill>
           <a:ln w="9525">
             <a:solidFill>
-              <a:srgbClr val="C5D4CF"/>
+              <a:srgbClr val="C5D0E0"/>
             </a:solidFill>
             <a:prstDash val="solid"/>
           </a:ln>
           <a:effectLst>
             <a:outerShdw sx="100000" sy="100000" kx="0" ky="0" algn="bl" rotWithShape="0" blurRad="127000" dist="25400" dir="5400000">
-              <a:srgbClr val="14211e">
+              <a:srgbClr val="102a43">
                 <a:alpha val="10000"/>
               </a:srgbClr>
             </a:outerShdw>
@@ -5984,7 +5984,7 @@
             <a:r>
               <a:rPr lang="en-US" sz="1500" b="1" dirty="0">
                 <a:solidFill>
-                  <a:srgbClr val="14211E"/>
+                  <a:srgbClr val="102A43"/>
                 </a:solidFill>
                 <a:latin typeface="Calibri" pitchFamily="34" charset="0"/>
                 <a:ea typeface="Calibri" pitchFamily="34" charset="-122"/>
@@ -6023,7 +6023,7 @@
             <a:r>
               <a:rPr lang="en-US" sz="1300" b="1" dirty="0">
                 <a:solidFill>
-                  <a:srgbClr val="0F5C4C"/>
+                  <a:srgbClr val="1B4F8A"/>
                 </a:solidFill>
                 <a:latin typeface="Calibri" pitchFamily="34" charset="0"/>
                 <a:ea typeface="Calibri" pitchFamily="34" charset="-122"/>
@@ -6065,7 +6065,7 @@
             <a:r>
               <a:rPr lang="en-US" sz="1200" dirty="0">
                 <a:solidFill>
-                  <a:srgbClr val="3D524C"/>
+                  <a:srgbClr val="3D5270"/>
                 </a:solidFill>
                 <a:latin typeface="Calibri" pitchFamily="34" charset="0"/>
                 <a:ea typeface="Calibri" pitchFamily="34" charset="-122"/>
@@ -6094,12 +6094,12 @@
             </a:avLst>
           </a:prstGeom>
           <a:solidFill>
-            <a:srgbClr val="0F5C4C"/>
+            <a:srgbClr val="1B4F8A"/>
           </a:solidFill>
           <a:ln/>
           <a:effectLst>
             <a:outerShdw sx="100000" sy="100000" kx="0" ky="0" algn="bl" rotWithShape="0" blurRad="127000" dist="25400" dir="5400000">
-              <a:srgbClr val="14211e">
+              <a:srgbClr val="102a43">
                 <a:alpha val="10000"/>
               </a:srgbClr>
             </a:outerShdw>
@@ -6133,7 +6133,7 @@
             <a:r>
               <a:rPr lang="en-US" sz="1500" b="1" dirty="0">
                 <a:solidFill>
-                  <a:srgbClr val="F4F7F6"/>
+                  <a:srgbClr val="F4F7FB"/>
                 </a:solidFill>
                 <a:latin typeface="Calibri" pitchFamily="34" charset="0"/>
                 <a:ea typeface="Calibri" pitchFamily="34" charset="-122"/>
@@ -6172,7 +6172,7 @@
             <a:r>
               <a:rPr lang="en-US" sz="1300" b="1" dirty="0">
                 <a:solidFill>
-                  <a:srgbClr val="C5D4CF"/>
+                  <a:srgbClr val="C5D0E0"/>
                 </a:solidFill>
                 <a:latin typeface="Calibri" pitchFamily="34" charset="0"/>
                 <a:ea typeface="Calibri" pitchFamily="34" charset="-122"/>
@@ -6214,7 +6214,7 @@
             <a:r>
               <a:rPr lang="en-US" sz="1200" dirty="0">
                 <a:solidFill>
-                  <a:srgbClr val="C5D4CF"/>
+                  <a:srgbClr val="C5D0E0"/>
                 </a:solidFill>
                 <a:latin typeface="Calibri" pitchFamily="34" charset="0"/>
                 <a:ea typeface="Calibri" pitchFamily="34" charset="-122"/>
@@ -6256,13 +6256,13 @@
             <a:r>
               <a:rPr lang="en-US" sz="1150" dirty="0">
                 <a:solidFill>
-                  <a:srgbClr val="3D524C"/>
-                </a:solidFill>
-                <a:latin typeface="Calibri" pitchFamily="34" charset="0"/>
-                <a:ea typeface="Calibri" pitchFamily="34" charset="-122"/>
-                <a:cs typeface="Calibri" pitchFamily="34" charset="-120"/>
-              </a:rPr>
-              <a:t>Adjacent, but not the wedge: national digital-health rails, private booking marketplaces, teleconsult apps. None of them sits before the door with KEPH level, wait, booking and arrived/no-show in one loop. [Likely]</a:t>
+                  <a:srgbClr val="3D5270"/>
+                </a:solidFill>
+                <a:latin typeface="Calibri" pitchFamily="34" charset="0"/>
+                <a:ea typeface="Calibri" pitchFamily="34" charset="-122"/>
+                <a:cs typeface="Calibri" pitchFamily="34" charset="-120"/>
+              </a:rPr>
+              <a:t>Adjacent, but not the wedge: AfyaKE/AfyaLink, Vezeeta/Ponea, teleconsult apps. None of them sits before the door with KEPH level, wait, booking and arrived/no-show in one loop. [Likely]</a:t>
             </a:r>
             <a:endParaRPr lang="en-US" sz="1150" dirty="0"/>
           </a:p>
@@ -6285,12 +6285,12 @@
             </a:avLst>
           </a:prstGeom>
           <a:solidFill>
-            <a:srgbClr val="14211E"/>
+            <a:srgbClr val="102A43"/>
           </a:solidFill>
           <a:ln/>
           <a:effectLst>
             <a:outerShdw sx="100000" sy="100000" kx="0" ky="0" algn="bl" rotWithShape="0" blurRad="127000" dist="25400" dir="5400000">
-              <a:srgbClr val="14211e">
+              <a:srgbClr val="102a43">
                 <a:alpha val="10000"/>
               </a:srgbClr>
             </a:outerShdw>
@@ -6324,7 +6324,7 @@
             <a:r>
               <a:rPr lang="en-US" sz="1100" b="1" spc="120" kern="0" dirty="0">
                 <a:solidFill>
-                  <a:srgbClr val="C5D4CF"/>
+                  <a:srgbClr val="B8C7DB"/>
                 </a:solidFill>
                 <a:latin typeface="Calibri" pitchFamily="34" charset="0"/>
                 <a:ea typeface="Calibri" pitchFamily="34" charset="-122"/>
@@ -6363,7 +6363,7 @@
             <a:r>
               <a:rPr lang="en-US" sz="4800" b="1" dirty="0">
                 <a:solidFill>
-                  <a:srgbClr val="F4F7F6"/>
+                  <a:srgbClr val="F4F7FB"/>
                 </a:solidFill>
                 <a:latin typeface="Cambria" pitchFamily="34" charset="0"/>
                 <a:ea typeface="Cambria" pitchFamily="34" charset="-122"/>
@@ -6402,7 +6402,7 @@
             <a:r>
               <a:rPr lang="en-US" sz="1250" dirty="0">
                 <a:solidFill>
-                  <a:srgbClr val="C5D4CF"/>
+                  <a:srgbClr val="B8C7DB"/>
                 </a:solidFill>
                 <a:latin typeface="Calibri" pitchFamily="34" charset="0"/>
                 <a:ea typeface="Calibri" pitchFamily="34" charset="-122"/>
@@ -6441,7 +6441,7 @@
             <a:r>
               <a:rPr lang="en-US" sz="1600" b="1" dirty="0">
                 <a:solidFill>
-                  <a:srgbClr val="F4F7F6"/>
+                  <a:srgbClr val="F4F7FB"/>
                 </a:solidFill>
                 <a:latin typeface="Calibri" pitchFamily="34" charset="0"/>
                 <a:ea typeface="Calibri" pitchFamily="34" charset="-122"/>
@@ -6483,7 +6483,7 @@
             <a:r>
               <a:rPr lang="en-US" sz="1100" dirty="0">
                 <a:solidFill>
-                  <a:srgbClr val="C5D4CF"/>
+                  <a:srgbClr val="C5D0E0"/>
                 </a:solidFill>
                 <a:latin typeface="Calibri" pitchFamily="34" charset="0"/>
                 <a:ea typeface="Calibri" pitchFamily="34" charset="-122"/>
@@ -6522,7 +6522,7 @@
             <a:r>
               <a:rPr lang="en-US" sz="1050" dirty="0">
                 <a:solidFill>
-                  <a:srgbClr val="3D524C"/>
+                  <a:srgbClr val="3D5270"/>
                 </a:solidFill>
                 <a:latin typeface="Calibri" pitchFamily="34" charset="0"/>
                 <a:ea typeface="Calibri" pitchFamily="34" charset="-122"/>
@@ -6548,7 +6548,7 @@
     <p:bg>
       <p:bgPr>
         <a:solidFill>
-          <a:srgbClr val="F4F7F6"/>
+          <a:srgbClr val="F4F7FB"/>
         </a:solidFill>
       </p:bgPr>
     </p:bg>
@@ -6593,7 +6593,7 @@
             <a:r>
               <a:rPr lang="en-US" sz="1150" b="1" spc="160" kern="0" dirty="0">
                 <a:solidFill>
-                  <a:srgbClr val="0F5C4C"/>
+                  <a:srgbClr val="1B4F8A"/>
                 </a:solidFill>
                 <a:latin typeface="Calibri" pitchFamily="34" charset="0"/>
                 <a:ea typeface="Calibri" pitchFamily="34" charset="-122"/>
@@ -6632,7 +6632,7 @@
             <a:r>
               <a:rPr lang="en-US" sz="3800" b="1" dirty="0">
                 <a:solidFill>
-                  <a:srgbClr val="14211E"/>
+                  <a:srgbClr val="102A43"/>
                 </a:solidFill>
                 <a:latin typeface="Cambria" pitchFamily="34" charset="0"/>
                 <a:ea typeface="Cambria" pitchFamily="34" charset="-122"/>
@@ -6665,13 +6665,13 @@
           </a:solidFill>
           <a:ln w="9525">
             <a:solidFill>
-              <a:srgbClr val="C5D4CF"/>
+              <a:srgbClr val="C5D0E0"/>
             </a:solidFill>
             <a:prstDash val="solid"/>
           </a:ln>
           <a:effectLst>
             <a:outerShdw sx="100000" sy="100000" kx="0" ky="0" algn="bl" rotWithShape="0" blurRad="127000" dist="25400" dir="5400000">
-              <a:srgbClr val="14211e">
+              <a:srgbClr val="102a43">
                 <a:alpha val="10000"/>
               </a:srgbClr>
             </a:outerShdw>
@@ -6705,7 +6705,7 @@
             <a:r>
               <a:rPr lang="en-US" sz="1400" b="1" dirty="0">
                 <a:solidFill>
-                  <a:srgbClr val="0F5C4C"/>
+                  <a:srgbClr val="1B4F8A"/>
                 </a:solidFill>
                 <a:latin typeface="Cambria" pitchFamily="34" charset="0"/>
                 <a:ea typeface="Cambria" pitchFamily="34" charset="-122"/>
@@ -6744,7 +6744,7 @@
             <a:r>
               <a:rPr lang="en-US" sz="1350" b="1" dirty="0">
                 <a:solidFill>
-                  <a:srgbClr val="14211E"/>
+                  <a:srgbClr val="102A43"/>
                 </a:solidFill>
                 <a:latin typeface="Calibri" pitchFamily="34" charset="0"/>
                 <a:ea typeface="Calibri" pitchFamily="34" charset="-122"/>
@@ -6786,7 +6786,7 @@
             <a:r>
               <a:rPr lang="en-US" sz="1050" dirty="0">
                 <a:solidFill>
-                  <a:srgbClr val="3D524C"/>
+                  <a:srgbClr val="3D5270"/>
                 </a:solidFill>
                 <a:latin typeface="Calibri" pitchFamily="34" charset="0"/>
                 <a:ea typeface="Calibri" pitchFamily="34" charset="-122"/>
@@ -6815,7 +6815,7 @@
           <a:noFill/>
           <a:ln w="25400">
             <a:solidFill>
-              <a:srgbClr val="0F5C4C"/>
+              <a:srgbClr val="1B4F8A"/>
             </a:solidFill>
             <a:prstDash val="solid"/>
             <a:tailEnd type="triangle"/>
@@ -6843,13 +6843,13 @@
           </a:solidFill>
           <a:ln w="9525">
             <a:solidFill>
-              <a:srgbClr val="C5D4CF"/>
+              <a:srgbClr val="C5D0E0"/>
             </a:solidFill>
             <a:prstDash val="solid"/>
           </a:ln>
           <a:effectLst>
             <a:outerShdw sx="100000" sy="100000" kx="0" ky="0" algn="bl" rotWithShape="0" blurRad="127000" dist="25400" dir="5400000">
-              <a:srgbClr val="14211e">
+              <a:srgbClr val="102a43">
                 <a:alpha val="10000"/>
               </a:srgbClr>
             </a:outerShdw>
@@ -6883,7 +6883,7 @@
             <a:r>
               <a:rPr lang="en-US" sz="1400" b="1" dirty="0">
                 <a:solidFill>
-                  <a:srgbClr val="0F5C4C"/>
+                  <a:srgbClr val="1B4F8A"/>
                 </a:solidFill>
                 <a:latin typeface="Cambria" pitchFamily="34" charset="0"/>
                 <a:ea typeface="Cambria" pitchFamily="34" charset="-122"/>
@@ -6922,7 +6922,7 @@
             <a:r>
               <a:rPr lang="en-US" sz="1350" b="1" dirty="0">
                 <a:solidFill>
-                  <a:srgbClr val="14211E"/>
+                  <a:srgbClr val="102A43"/>
                 </a:solidFill>
                 <a:latin typeface="Calibri" pitchFamily="34" charset="0"/>
                 <a:ea typeface="Calibri" pitchFamily="34" charset="-122"/>
@@ -6964,7 +6964,7 @@
             <a:r>
               <a:rPr lang="en-US" sz="1050" dirty="0">
                 <a:solidFill>
-                  <a:srgbClr val="3D524C"/>
+                  <a:srgbClr val="3D5270"/>
                 </a:solidFill>
                 <a:latin typeface="Calibri" pitchFamily="34" charset="0"/>
                 <a:ea typeface="Calibri" pitchFamily="34" charset="-122"/>
@@ -6993,7 +6993,7 @@
           <a:noFill/>
           <a:ln w="25400">
             <a:solidFill>
-              <a:srgbClr val="0F5C4C"/>
+              <a:srgbClr val="1B4F8A"/>
             </a:solidFill>
             <a:prstDash val="solid"/>
             <a:tailEnd type="triangle"/>
@@ -7021,13 +7021,13 @@
           </a:solidFill>
           <a:ln w="9525">
             <a:solidFill>
-              <a:srgbClr val="C5D4CF"/>
+              <a:srgbClr val="C5D0E0"/>
             </a:solidFill>
             <a:prstDash val="solid"/>
           </a:ln>
           <a:effectLst>
             <a:outerShdw sx="100000" sy="100000" kx="0" ky="0" algn="bl" rotWithShape="0" blurRad="127000" dist="25400" dir="5400000">
-              <a:srgbClr val="14211e">
+              <a:srgbClr val="102a43">
                 <a:alpha val="10000"/>
               </a:srgbClr>
             </a:outerShdw>
@@ -7061,7 +7061,7 @@
             <a:r>
               <a:rPr lang="en-US" sz="1400" b="1" dirty="0">
                 <a:solidFill>
-                  <a:srgbClr val="0F5C4C"/>
+                  <a:srgbClr val="1B4F8A"/>
                 </a:solidFill>
                 <a:latin typeface="Cambria" pitchFamily="34" charset="0"/>
                 <a:ea typeface="Cambria" pitchFamily="34" charset="-122"/>
@@ -7100,7 +7100,7 @@
             <a:r>
               <a:rPr lang="en-US" sz="1350" b="1" dirty="0">
                 <a:solidFill>
-                  <a:srgbClr val="14211E"/>
+                  <a:srgbClr val="102A43"/>
                 </a:solidFill>
                 <a:latin typeface="Calibri" pitchFamily="34" charset="0"/>
                 <a:ea typeface="Calibri" pitchFamily="34" charset="-122"/>
@@ -7142,7 +7142,7 @@
             <a:r>
               <a:rPr lang="en-US" sz="1050" dirty="0">
                 <a:solidFill>
-                  <a:srgbClr val="3D524C"/>
+                  <a:srgbClr val="3D5270"/>
                 </a:solidFill>
                 <a:latin typeface="Calibri" pitchFamily="34" charset="0"/>
                 <a:ea typeface="Calibri" pitchFamily="34" charset="-122"/>
@@ -7171,7 +7171,7 @@
           <a:noFill/>
           <a:ln w="25400">
             <a:solidFill>
-              <a:srgbClr val="0F5C4C"/>
+              <a:srgbClr val="1B4F8A"/>
             </a:solidFill>
             <a:prstDash val="solid"/>
             <a:tailEnd type="triangle"/>
@@ -7199,13 +7199,13 @@
           </a:solidFill>
           <a:ln w="9525">
             <a:solidFill>
-              <a:srgbClr val="C5D4CF"/>
+              <a:srgbClr val="C5D0E0"/>
             </a:solidFill>
             <a:prstDash val="solid"/>
           </a:ln>
           <a:effectLst>
             <a:outerShdw sx="100000" sy="100000" kx="0" ky="0" algn="bl" rotWithShape="0" blurRad="127000" dist="25400" dir="5400000">
-              <a:srgbClr val="14211e">
+              <a:srgbClr val="102a43">
                 <a:alpha val="10000"/>
               </a:srgbClr>
             </a:outerShdw>
@@ -7239,7 +7239,7 @@
             <a:r>
               <a:rPr lang="en-US" sz="1400" b="1" dirty="0">
                 <a:solidFill>
-                  <a:srgbClr val="0F5C4C"/>
+                  <a:srgbClr val="1B4F8A"/>
                 </a:solidFill>
                 <a:latin typeface="Cambria" pitchFamily="34" charset="0"/>
                 <a:ea typeface="Cambria" pitchFamily="34" charset="-122"/>
@@ -7278,7 +7278,7 @@
             <a:r>
               <a:rPr lang="en-US" sz="1350" b="1" dirty="0">
                 <a:solidFill>
-                  <a:srgbClr val="14211E"/>
+                  <a:srgbClr val="102A43"/>
                 </a:solidFill>
                 <a:latin typeface="Calibri" pitchFamily="34" charset="0"/>
                 <a:ea typeface="Calibri" pitchFamily="34" charset="-122"/>
@@ -7320,7 +7320,7 @@
             <a:r>
               <a:rPr lang="en-US" sz="1050" dirty="0">
                 <a:solidFill>
-                  <a:srgbClr val="3D524C"/>
+                  <a:srgbClr val="3D5270"/>
                 </a:solidFill>
                 <a:latin typeface="Calibri" pitchFamily="34" charset="0"/>
                 <a:ea typeface="Calibri" pitchFamily="34" charset="-122"/>
@@ -7353,13 +7353,13 @@
           </a:solidFill>
           <a:ln w="9525">
             <a:solidFill>
-              <a:srgbClr val="C5D4CF"/>
+              <a:srgbClr val="C5D0E0"/>
             </a:solidFill>
             <a:prstDash val="solid"/>
           </a:ln>
           <a:effectLst>
             <a:outerShdw sx="100000" sy="100000" kx="0" ky="0" algn="bl" rotWithShape="0" blurRad="127000" dist="25400" dir="5400000">
-              <a:srgbClr val="14211e">
+              <a:srgbClr val="102a43">
                 <a:alpha val="10000"/>
               </a:srgbClr>
             </a:outerShdw>
@@ -7393,7 +7393,7 @@
             <a:r>
               <a:rPr lang="en-US" sz="1400" b="1" dirty="0">
                 <a:solidFill>
-                  <a:srgbClr val="0F5C4C"/>
+                  <a:srgbClr val="1B4F8A"/>
                 </a:solidFill>
                 <a:latin typeface="Cambria" pitchFamily="34" charset="0"/>
                 <a:ea typeface="Cambria" pitchFamily="34" charset="-122"/>
@@ -7432,7 +7432,7 @@
             <a:r>
               <a:rPr lang="en-US" sz="1350" b="1" dirty="0">
                 <a:solidFill>
-                  <a:srgbClr val="14211E"/>
+                  <a:srgbClr val="102A43"/>
                 </a:solidFill>
                 <a:latin typeface="Calibri" pitchFamily="34" charset="0"/>
                 <a:ea typeface="Calibri" pitchFamily="34" charset="-122"/>
@@ -7474,7 +7474,7 @@
             <a:r>
               <a:rPr lang="en-US" sz="1050" dirty="0">
                 <a:solidFill>
-                  <a:srgbClr val="3D524C"/>
+                  <a:srgbClr val="3D5270"/>
                 </a:solidFill>
                 <a:latin typeface="Calibri" pitchFamily="34" charset="0"/>
                 <a:ea typeface="Calibri" pitchFamily="34" charset="-122"/>
@@ -7503,7 +7503,7 @@
           <a:noFill/>
           <a:ln w="25400">
             <a:solidFill>
-              <a:srgbClr val="0F5C4C"/>
+              <a:srgbClr val="1B4F8A"/>
             </a:solidFill>
             <a:prstDash val="solid"/>
             <a:tailEnd type="triangle"/>
@@ -7531,13 +7531,13 @@
           </a:solidFill>
           <a:ln w="9525">
             <a:solidFill>
-              <a:srgbClr val="C5D4CF"/>
+              <a:srgbClr val="C5D0E0"/>
             </a:solidFill>
             <a:prstDash val="solid"/>
           </a:ln>
           <a:effectLst>
             <a:outerShdw sx="100000" sy="100000" kx="0" ky="0" algn="bl" rotWithShape="0" blurRad="127000" dist="25400" dir="5400000">
-              <a:srgbClr val="14211e">
+              <a:srgbClr val="102a43">
                 <a:alpha val="10000"/>
               </a:srgbClr>
             </a:outerShdw>
@@ -7571,7 +7571,7 @@
             <a:r>
               <a:rPr lang="en-US" sz="1400" b="1" dirty="0">
                 <a:solidFill>
-                  <a:srgbClr val="0F5C4C"/>
+                  <a:srgbClr val="1B4F8A"/>
                 </a:solidFill>
                 <a:latin typeface="Cambria" pitchFamily="34" charset="0"/>
                 <a:ea typeface="Cambria" pitchFamily="34" charset="-122"/>
@@ -7610,7 +7610,7 @@
             <a:r>
               <a:rPr lang="en-US" sz="1350" b="1" dirty="0">
                 <a:solidFill>
-                  <a:srgbClr val="14211E"/>
+                  <a:srgbClr val="102A43"/>
                 </a:solidFill>
                 <a:latin typeface="Calibri" pitchFamily="34" charset="0"/>
                 <a:ea typeface="Calibri" pitchFamily="34" charset="-122"/>
@@ -7652,7 +7652,7 @@
             <a:r>
               <a:rPr lang="en-US" sz="1050" dirty="0">
                 <a:solidFill>
-                  <a:srgbClr val="3D524C"/>
+                  <a:srgbClr val="3D5270"/>
                 </a:solidFill>
                 <a:latin typeface="Calibri" pitchFamily="34" charset="0"/>
                 <a:ea typeface="Calibri" pitchFamily="34" charset="-122"/>
@@ -7681,7 +7681,7 @@
           <a:noFill/>
           <a:ln w="25400">
             <a:solidFill>
-              <a:srgbClr val="0F5C4C"/>
+              <a:srgbClr val="1B4F8A"/>
             </a:solidFill>
             <a:prstDash val="solid"/>
             <a:tailEnd type="triangle"/>
@@ -7709,13 +7709,13 @@
           </a:solidFill>
           <a:ln w="9525">
             <a:solidFill>
-              <a:srgbClr val="C5D4CF"/>
+              <a:srgbClr val="C5D0E0"/>
             </a:solidFill>
             <a:prstDash val="solid"/>
           </a:ln>
           <a:effectLst>
             <a:outerShdw sx="100000" sy="100000" kx="0" ky="0" algn="bl" rotWithShape="0" blurRad="127000" dist="25400" dir="5400000">
-              <a:srgbClr val="14211e">
+              <a:srgbClr val="102a43">
                 <a:alpha val="10000"/>
               </a:srgbClr>
             </a:outerShdw>
@@ -7749,7 +7749,7 @@
             <a:r>
               <a:rPr lang="en-US" sz="1400" b="1" dirty="0">
                 <a:solidFill>
-                  <a:srgbClr val="0F5C4C"/>
+                  <a:srgbClr val="1B4F8A"/>
                 </a:solidFill>
                 <a:latin typeface="Cambria" pitchFamily="34" charset="0"/>
                 <a:ea typeface="Cambria" pitchFamily="34" charset="-122"/>
@@ -7788,7 +7788,7 @@
             <a:r>
               <a:rPr lang="en-US" sz="1350" b="1" dirty="0">
                 <a:solidFill>
-                  <a:srgbClr val="14211E"/>
+                  <a:srgbClr val="102A43"/>
                 </a:solidFill>
                 <a:latin typeface="Calibri" pitchFamily="34" charset="0"/>
                 <a:ea typeface="Calibri" pitchFamily="34" charset="-122"/>
@@ -7830,7 +7830,7 @@
             <a:r>
               <a:rPr lang="en-US" sz="1050" dirty="0">
                 <a:solidFill>
-                  <a:srgbClr val="3D524C"/>
+                  <a:srgbClr val="3D5270"/>
                 </a:solidFill>
                 <a:latin typeface="Calibri" pitchFamily="34" charset="0"/>
                 <a:ea typeface="Calibri" pitchFamily="34" charset="-122"/>
@@ -7859,7 +7859,7 @@
           <a:noFill/>
           <a:ln w="25400">
             <a:solidFill>
-              <a:srgbClr val="0F5C4C"/>
+              <a:srgbClr val="1B4F8A"/>
             </a:solidFill>
             <a:prstDash val="solid"/>
             <a:tailEnd type="triangle"/>
@@ -7887,13 +7887,13 @@
           </a:solidFill>
           <a:ln w="9525">
             <a:solidFill>
-              <a:srgbClr val="C5D4CF"/>
+              <a:srgbClr val="C5D0E0"/>
             </a:solidFill>
             <a:prstDash val="solid"/>
           </a:ln>
           <a:effectLst>
             <a:outerShdw sx="100000" sy="100000" kx="0" ky="0" algn="bl" rotWithShape="0" blurRad="127000" dist="25400" dir="5400000">
-              <a:srgbClr val="14211e">
+              <a:srgbClr val="102a43">
                 <a:alpha val="10000"/>
               </a:srgbClr>
             </a:outerShdw>
@@ -7927,7 +7927,7 @@
             <a:r>
               <a:rPr lang="en-US" sz="1400" b="1" dirty="0">
                 <a:solidFill>
-                  <a:srgbClr val="0F5C4C"/>
+                  <a:srgbClr val="1B4F8A"/>
                 </a:solidFill>
                 <a:latin typeface="Cambria" pitchFamily="34" charset="0"/>
                 <a:ea typeface="Cambria" pitchFamily="34" charset="-122"/>
@@ -7966,7 +7966,7 @@
             <a:r>
               <a:rPr lang="en-US" sz="1350" b="1" dirty="0">
                 <a:solidFill>
-                  <a:srgbClr val="14211E"/>
+                  <a:srgbClr val="102A43"/>
                 </a:solidFill>
                 <a:latin typeface="Calibri" pitchFamily="34" charset="0"/>
                 <a:ea typeface="Calibri" pitchFamily="34" charset="-122"/>
@@ -8008,7 +8008,7 @@
             <a:r>
               <a:rPr lang="en-US" sz="1050" dirty="0">
                 <a:solidFill>
-                  <a:srgbClr val="3D524C"/>
+                  <a:srgbClr val="3D5270"/>
                 </a:solidFill>
                 <a:latin typeface="Calibri" pitchFamily="34" charset="0"/>
                 <a:ea typeface="Calibri" pitchFamily="34" charset="-122"/>
@@ -8023,30 +8023,6 @@
       <p:sp>
         <p:nvSpPr>
           <p:cNvPr id="42" name="Shape 40"/>
-          <p:cNvSpPr/>
-          <p:nvPr/>
-        </p:nvSpPr>
-        <p:spPr>
-          <a:xfrm>
-            <a:off x="11292840" y="2743200"/>
-            <a:ext cx="0" cy="256032"/>
-          </a:xfrm>
-          <a:prstGeom prst="line">
-            <a:avLst/>
-          </a:prstGeom>
-          <a:noFill/>
-          <a:ln w="25400">
-            <a:solidFill>
-              <a:srgbClr val="0F5C4C"/>
-            </a:solidFill>
-            <a:prstDash val="solid"/>
-            <a:tailEnd type="triangle"/>
-          </a:ln>
-        </p:spPr>
-      </p:sp>
-      <p:sp>
-        <p:nvSpPr>
-          <p:cNvPr id="43" name="Shape 41"/>
           <p:cNvSpPr/>
           <p:nvPr/>
         </p:nvSpPr>
@@ -8065,13 +8041,13 @@
           </a:solidFill>
           <a:ln w="9525">
             <a:solidFill>
-              <a:srgbClr val="C5D4CF"/>
+              <a:srgbClr val="C5D0E0"/>
             </a:solidFill>
             <a:prstDash val="solid"/>
           </a:ln>
           <a:effectLst>
             <a:outerShdw sx="100000" sy="100000" kx="0" ky="0" algn="bl" rotWithShape="0" blurRad="127000" dist="25400" dir="5400000">
-              <a:srgbClr val="14211e">
+              <a:srgbClr val="102a43">
                 <a:alpha val="10000"/>
               </a:srgbClr>
             </a:outerShdw>
@@ -8080,7 +8056,7 @@
       </p:sp>
       <p:sp>
         <p:nvSpPr>
-          <p:cNvPr id="44" name="Text 42"/>
+          <p:cNvPr id="43" name="Text 41"/>
           <p:cNvSpPr/>
           <p:nvPr/>
         </p:nvSpPr>
@@ -8105,7 +8081,7 @@
             <a:r>
               <a:rPr lang="en-US" sz="1150" b="1" spc="140" kern="0" dirty="0">
                 <a:solidFill>
-                  <a:srgbClr val="0F5C4C"/>
+                  <a:srgbClr val="1B4F8A"/>
                 </a:solidFill>
                 <a:latin typeface="Calibri" pitchFamily="34" charset="0"/>
                 <a:ea typeface="Calibri" pitchFamily="34" charset="-122"/>
@@ -8119,7 +8095,7 @@
       </p:sp>
       <p:sp>
         <p:nvSpPr>
-          <p:cNvPr id="45" name="Text 43"/>
+          <p:cNvPr id="44" name="Text 42"/>
           <p:cNvSpPr/>
           <p:nvPr/>
         </p:nvSpPr>
@@ -8144,7 +8120,7 @@
             <a:r>
               <a:rPr lang="en-US" sz="1200" b="1" dirty="0">
                 <a:solidFill>
-                  <a:srgbClr val="14211E"/>
+                  <a:srgbClr val="102A43"/>
                 </a:solidFill>
                 <a:latin typeface="Courier New" pitchFamily="34" charset="0"/>
                 <a:ea typeface="Courier New" pitchFamily="34" charset="-122"/>
@@ -8158,7 +8134,7 @@
       </p:sp>
       <p:sp>
         <p:nvSpPr>
-          <p:cNvPr id="46" name="Text 44"/>
+          <p:cNvPr id="45" name="Text 43"/>
           <p:cNvSpPr/>
           <p:nvPr/>
         </p:nvSpPr>
@@ -8183,7 +8159,7 @@
             <a:r>
               <a:rPr lang="en-US" sz="1200" dirty="0">
                 <a:solidFill>
-                  <a:srgbClr val="3D524C"/>
+                  <a:srgbClr val="3D5270"/>
                 </a:solidFill>
                 <a:latin typeface="Calibri" pitchFamily="34" charset="0"/>
                 <a:ea typeface="Calibri" pitchFamily="34" charset="-122"/>
@@ -8197,7 +8173,7 @@
       </p:sp>
       <p:sp>
         <p:nvSpPr>
-          <p:cNvPr id="47" name="Shape 45"/>
+          <p:cNvPr id="46" name="Shape 44"/>
           <p:cNvSpPr/>
           <p:nvPr/>
         </p:nvSpPr>
@@ -8217,7 +8193,7 @@
           <a:ln/>
           <a:effectLst>
             <a:outerShdw sx="100000" sy="100000" kx="0" ky="0" algn="bl" rotWithShape="0" blurRad="127000" dist="25400" dir="5400000">
-              <a:srgbClr val="14211e">
+              <a:srgbClr val="102a43">
                 <a:alpha val="10000"/>
               </a:srgbClr>
             </a:outerShdw>
@@ -8226,7 +8202,7 @@
       </p:sp>
       <p:sp>
         <p:nvSpPr>
-          <p:cNvPr id="48" name="Text 46"/>
+          <p:cNvPr id="47" name="Text 45"/>
           <p:cNvSpPr/>
           <p:nvPr/>
         </p:nvSpPr>
@@ -8265,7 +8241,7 @@
       </p:sp>
       <p:sp>
         <p:nvSpPr>
-          <p:cNvPr id="49" name="Text 47"/>
+          <p:cNvPr id="48" name="Text 46"/>
           <p:cNvSpPr/>
           <p:nvPr/>
         </p:nvSpPr>
@@ -8290,7 +8266,7 @@
             <a:r>
               <a:rPr lang="en-US" sz="1500" b="1" dirty="0">
                 <a:solidFill>
-                  <a:srgbClr val="14211E"/>
+                  <a:srgbClr val="102A43"/>
                 </a:solidFill>
                 <a:latin typeface="Calibri" pitchFamily="34" charset="0"/>
                 <a:ea typeface="Calibri" pitchFamily="34" charset="-122"/>
@@ -8304,7 +8280,7 @@
       </p:sp>
       <p:sp>
         <p:nvSpPr>
-          <p:cNvPr id="50" name="Text 48"/>
+          <p:cNvPr id="49" name="Text 47"/>
           <p:cNvSpPr/>
           <p:nvPr/>
         </p:nvSpPr>
@@ -8329,7 +8305,7 @@
             <a:r>
               <a:rPr lang="en-US" sz="1150" dirty="0">
                 <a:solidFill>
-                  <a:srgbClr val="3D524C"/>
+                  <a:srgbClr val="3D5270"/>
                 </a:solidFill>
                 <a:latin typeface="Calibri" pitchFamily="34" charset="0"/>
                 <a:ea typeface="Calibri" pitchFamily="34" charset="-122"/>
@@ -8343,7 +8319,7 @@
       </p:sp>
       <p:sp>
         <p:nvSpPr>
-          <p:cNvPr id="51" name="Text 49"/>
+          <p:cNvPr id="50" name="Text 48"/>
           <p:cNvSpPr/>
           <p:nvPr/>
         </p:nvSpPr>
@@ -8368,7 +8344,7 @@
             <a:r>
               <a:rPr lang="en-US" sz="1050" dirty="0">
                 <a:solidFill>
-                  <a:srgbClr val="3D524C"/>
+                  <a:srgbClr val="3D5270"/>
                 </a:solidFill>
                 <a:latin typeface="Calibri" pitchFamily="34" charset="0"/>
                 <a:ea typeface="Calibri" pitchFamily="34" charset="-122"/>
@@ -8394,7 +8370,7 @@
     <p:bg>
       <p:bgPr>
         <a:solidFill>
-          <a:srgbClr val="F4F7F6"/>
+          <a:srgbClr val="F4F7FB"/>
         </a:solidFill>
       </p:bgPr>
     </p:bg>
@@ -8439,7 +8415,7 @@
             <a:r>
               <a:rPr lang="en-US" sz="1150" b="1" spc="160" kern="0" dirty="0">
                 <a:solidFill>
-                  <a:srgbClr val="0F5C4C"/>
+                  <a:srgbClr val="1B4F8A"/>
                 </a:solidFill>
                 <a:latin typeface="Calibri" pitchFamily="34" charset="0"/>
                 <a:ea typeface="Calibri" pitchFamily="34" charset="-122"/>
@@ -8478,7 +8454,7 @@
             <a:r>
               <a:rPr lang="en-US" sz="3800" b="1" dirty="0">
                 <a:solidFill>
-                  <a:srgbClr val="14211E"/>
+                  <a:srgbClr val="102A43"/>
                 </a:solidFill>
                 <a:latin typeface="Cambria" pitchFamily="34" charset="0"/>
                 <a:ea typeface="Cambria" pitchFamily="34" charset="-122"/>
@@ -8512,7 +8488,7 @@
           <a:ln/>
           <a:effectLst>
             <a:outerShdw sx="100000" sy="100000" kx="0" ky="0" algn="bl" rotWithShape="0" blurRad="127000" dist="25400" dir="5400000">
-              <a:srgbClr val="14211e">
+              <a:srgbClr val="102a43">
                 <a:alpha val="10000"/>
               </a:srgbClr>
             </a:outerShdw>
@@ -8585,7 +8561,7 @@
             <a:r>
               <a:rPr lang="en-US" sz="1400" b="1" dirty="0">
                 <a:solidFill>
-                  <a:srgbClr val="14211E"/>
+                  <a:srgbClr val="102A43"/>
                 </a:solidFill>
                 <a:latin typeface="Calibri" pitchFamily="34" charset="0"/>
                 <a:ea typeface="Calibri" pitchFamily="34" charset="-122"/>
@@ -8627,7 +8603,7 @@
             <a:r>
               <a:rPr lang="en-US" sz="1150" dirty="0">
                 <a:solidFill>
-                  <a:srgbClr val="3D524C"/>
+                  <a:srgbClr val="3D5270"/>
                 </a:solidFill>
                 <a:latin typeface="Calibri" pitchFamily="34" charset="0"/>
                 <a:ea typeface="Calibri" pitchFamily="34" charset="-122"/>
@@ -8656,7 +8632,7 @@
           <a:noFill/>
           <a:ln w="25400">
             <a:solidFill>
-              <a:srgbClr val="0F5C4C"/>
+              <a:srgbClr val="1B4F8A"/>
             </a:solidFill>
             <a:prstDash val="solid"/>
             <a:tailEnd type="triangle"/>
@@ -8685,7 +8661,7 @@
           <a:ln/>
           <a:effectLst>
             <a:outerShdw sx="100000" sy="100000" kx="0" ky="0" algn="bl" rotWithShape="0" blurRad="127000" dist="25400" dir="5400000">
-              <a:srgbClr val="14211e">
+              <a:srgbClr val="102a43">
                 <a:alpha val="10000"/>
               </a:srgbClr>
             </a:outerShdw>
@@ -8719,7 +8695,7 @@
             <a:r>
               <a:rPr lang="en-US" sz="1400" b="1" dirty="0">
                 <a:solidFill>
-                  <a:srgbClr val="0F5C4C"/>
+                  <a:srgbClr val="1B4F8A"/>
                 </a:solidFill>
                 <a:latin typeface="Cambria" pitchFamily="34" charset="0"/>
                 <a:ea typeface="Cambria" pitchFamily="34" charset="-122"/>
@@ -8758,7 +8734,7 @@
             <a:r>
               <a:rPr lang="en-US" sz="1400" b="1" dirty="0">
                 <a:solidFill>
-                  <a:srgbClr val="14211E"/>
+                  <a:srgbClr val="102A43"/>
                 </a:solidFill>
                 <a:latin typeface="Calibri" pitchFamily="34" charset="0"/>
                 <a:ea typeface="Calibri" pitchFamily="34" charset="-122"/>
@@ -8800,7 +8776,7 @@
             <a:r>
               <a:rPr lang="en-US" sz="1150" dirty="0">
                 <a:solidFill>
-                  <a:srgbClr val="3D524C"/>
+                  <a:srgbClr val="3D5270"/>
                 </a:solidFill>
                 <a:latin typeface="Calibri" pitchFamily="34" charset="0"/>
                 <a:ea typeface="Calibri" pitchFamily="34" charset="-122"/>
@@ -8829,7 +8805,7 @@
           <a:noFill/>
           <a:ln w="25400">
             <a:solidFill>
-              <a:srgbClr val="0F5C4C"/>
+              <a:srgbClr val="1B4F8A"/>
             </a:solidFill>
             <a:prstDash val="solid"/>
             <a:tailEnd type="triangle"/>
@@ -8858,7 +8834,7 @@
           <a:ln/>
           <a:effectLst>
             <a:outerShdw sx="100000" sy="100000" kx="0" ky="0" algn="bl" rotWithShape="0" blurRad="127000" dist="25400" dir="5400000">
-              <a:srgbClr val="14211e">
+              <a:srgbClr val="102a43">
                 <a:alpha val="10000"/>
               </a:srgbClr>
             </a:outerShdw>
@@ -8892,7 +8868,7 @@
             <a:r>
               <a:rPr lang="en-US" sz="1400" b="1" dirty="0">
                 <a:solidFill>
-                  <a:srgbClr val="0F5C4C"/>
+                  <a:srgbClr val="1B4F8A"/>
                 </a:solidFill>
                 <a:latin typeface="Cambria" pitchFamily="34" charset="0"/>
                 <a:ea typeface="Cambria" pitchFamily="34" charset="-122"/>
@@ -8931,7 +8907,7 @@
             <a:r>
               <a:rPr lang="en-US" sz="1400" b="1" dirty="0">
                 <a:solidFill>
-                  <a:srgbClr val="14211E"/>
+                  <a:srgbClr val="102A43"/>
                 </a:solidFill>
                 <a:latin typeface="Calibri" pitchFamily="34" charset="0"/>
                 <a:ea typeface="Calibri" pitchFamily="34" charset="-122"/>
@@ -8973,7 +8949,7 @@
             <a:r>
               <a:rPr lang="en-US" sz="1150" dirty="0">
                 <a:solidFill>
-                  <a:srgbClr val="3D524C"/>
+                  <a:srgbClr val="3D5270"/>
                 </a:solidFill>
                 <a:latin typeface="Calibri" pitchFamily="34" charset="0"/>
                 <a:ea typeface="Calibri" pitchFamily="34" charset="-122"/>
@@ -9002,7 +8978,7 @@
           <a:noFill/>
           <a:ln w="25400">
             <a:solidFill>
-              <a:srgbClr val="0F5C4C"/>
+              <a:srgbClr val="1B4F8A"/>
             </a:solidFill>
             <a:prstDash val="solid"/>
             <a:tailEnd type="triangle"/>
@@ -9031,7 +9007,7 @@
           <a:ln/>
           <a:effectLst>
             <a:outerShdw sx="100000" sy="100000" kx="0" ky="0" algn="bl" rotWithShape="0" blurRad="127000" dist="25400" dir="5400000">
-              <a:srgbClr val="14211e">
+              <a:srgbClr val="102a43">
                 <a:alpha val="10000"/>
               </a:srgbClr>
             </a:outerShdw>
@@ -9065,7 +9041,7 @@
             <a:r>
               <a:rPr lang="en-US" sz="1400" b="1" dirty="0">
                 <a:solidFill>
-                  <a:srgbClr val="0F5C4C"/>
+                  <a:srgbClr val="1B4F8A"/>
                 </a:solidFill>
                 <a:latin typeface="Cambria" pitchFamily="34" charset="0"/>
                 <a:ea typeface="Cambria" pitchFamily="34" charset="-122"/>
@@ -9104,7 +9080,7 @@
             <a:r>
               <a:rPr lang="en-US" sz="1400" b="1" dirty="0">
                 <a:solidFill>
-                  <a:srgbClr val="14211E"/>
+                  <a:srgbClr val="102A43"/>
                 </a:solidFill>
                 <a:latin typeface="Calibri" pitchFamily="34" charset="0"/>
                 <a:ea typeface="Calibri" pitchFamily="34" charset="-122"/>
@@ -9146,7 +9122,7 @@
             <a:r>
               <a:rPr lang="en-US" sz="1150" dirty="0">
                 <a:solidFill>
-                  <a:srgbClr val="3D524C"/>
+                  <a:srgbClr val="3D5270"/>
                 </a:solidFill>
                 <a:latin typeface="Calibri" pitchFamily="34" charset="0"/>
                 <a:ea typeface="Calibri" pitchFamily="34" charset="-122"/>
@@ -9175,7 +9151,7 @@
           <a:noFill/>
           <a:ln w="25400">
             <a:solidFill>
-              <a:srgbClr val="0F5C4C"/>
+              <a:srgbClr val="1B4F8A"/>
             </a:solidFill>
             <a:prstDash val="solid"/>
             <a:tailEnd type="triangle"/>
@@ -9204,7 +9180,7 @@
           <a:ln/>
           <a:effectLst>
             <a:outerShdw sx="100000" sy="100000" kx="0" ky="0" algn="bl" rotWithShape="0" blurRad="127000" dist="25400" dir="5400000">
-              <a:srgbClr val="14211e">
+              <a:srgbClr val="102a43">
                 <a:alpha val="10000"/>
               </a:srgbClr>
             </a:outerShdw>
@@ -9238,7 +9214,7 @@
             <a:r>
               <a:rPr lang="en-US" sz="1400" b="1" dirty="0">
                 <a:solidFill>
-                  <a:srgbClr val="0F5C4C"/>
+                  <a:srgbClr val="1B4F8A"/>
                 </a:solidFill>
                 <a:latin typeface="Cambria" pitchFamily="34" charset="0"/>
                 <a:ea typeface="Cambria" pitchFamily="34" charset="-122"/>
@@ -9277,7 +9253,7 @@
             <a:r>
               <a:rPr lang="en-US" sz="1400" b="1" dirty="0">
                 <a:solidFill>
-                  <a:srgbClr val="14211E"/>
+                  <a:srgbClr val="102A43"/>
                 </a:solidFill>
                 <a:latin typeface="Calibri" pitchFamily="34" charset="0"/>
                 <a:ea typeface="Calibri" pitchFamily="34" charset="-122"/>
@@ -9319,7 +9295,7 @@
             <a:r>
               <a:rPr lang="en-US" sz="1150" dirty="0">
                 <a:solidFill>
-                  <a:srgbClr val="3D524C"/>
+                  <a:srgbClr val="3D5270"/>
                 </a:solidFill>
                 <a:latin typeface="Calibri" pitchFamily="34" charset="0"/>
                 <a:ea typeface="Calibri" pitchFamily="34" charset="-122"/>
@@ -9352,13 +9328,13 @@
           </a:solidFill>
           <a:ln w="9525">
             <a:solidFill>
-              <a:srgbClr val="C5D4CF"/>
+              <a:srgbClr val="C5D0E0"/>
             </a:solidFill>
             <a:prstDash val="solid"/>
           </a:ln>
           <a:effectLst>
             <a:outerShdw sx="100000" sy="100000" kx="0" ky="0" algn="bl" rotWithShape="0" blurRad="127000" dist="25400" dir="5400000">
-              <a:srgbClr val="14211e">
+              <a:srgbClr val="102a43">
                 <a:alpha val="10000"/>
               </a:srgbClr>
             </a:outerShdw>
@@ -9392,7 +9368,7 @@
             <a:r>
               <a:rPr lang="en-US" sz="1600" b="1" dirty="0">
                 <a:solidFill>
-                  <a:srgbClr val="14211E"/>
+                  <a:srgbClr val="102A43"/>
                 </a:solidFill>
                 <a:latin typeface="Calibri" pitchFamily="34" charset="0"/>
                 <a:ea typeface="Calibri" pitchFamily="34" charset="-122"/>
@@ -9434,7 +9410,7 @@
             <a:r>
               <a:rPr lang="en-US" sz="1300" dirty="0">
                 <a:solidFill>
-                  <a:srgbClr val="3D524C"/>
+                  <a:srgbClr val="3D5270"/>
                 </a:solidFill>
                 <a:latin typeface="Calibri" pitchFamily="34" charset="0"/>
                 <a:ea typeface="Calibri" pitchFamily="34" charset="-122"/>
@@ -9463,12 +9439,12 @@
             </a:avLst>
           </a:prstGeom>
           <a:solidFill>
-            <a:srgbClr val="0F5C4C"/>
+            <a:srgbClr val="1B4F8A"/>
           </a:solidFill>
           <a:ln/>
           <a:effectLst>
             <a:outerShdw sx="100000" sy="100000" kx="0" ky="0" algn="bl" rotWithShape="0" blurRad="127000" dist="25400" dir="5400000">
-              <a:srgbClr val="14211e">
+              <a:srgbClr val="102a43">
                 <a:alpha val="10000"/>
               </a:srgbClr>
             </a:outerShdw>
@@ -9502,7 +9478,7 @@
             <a:r>
               <a:rPr lang="en-US" sz="1600" b="1" dirty="0">
                 <a:solidFill>
-                  <a:srgbClr val="F4F7F6"/>
+                  <a:srgbClr val="F4F7FB"/>
                 </a:solidFill>
                 <a:latin typeface="Calibri" pitchFamily="34" charset="0"/>
                 <a:ea typeface="Calibri" pitchFamily="34" charset="-122"/>
@@ -9544,7 +9520,7 @@
             <a:r>
               <a:rPr lang="en-US" sz="1300" dirty="0">
                 <a:solidFill>
-                  <a:srgbClr val="C5D4CF"/>
+                  <a:srgbClr val="C5D0E0"/>
                 </a:solidFill>
                 <a:latin typeface="Calibri" pitchFamily="34" charset="0"/>
                 <a:ea typeface="Calibri" pitchFamily="34" charset="-122"/>
@@ -9583,7 +9559,7 @@
             <a:r>
               <a:rPr lang="en-US" sz="1050" dirty="0">
                 <a:solidFill>
-                  <a:srgbClr val="3D524C"/>
+                  <a:srgbClr val="3D5270"/>
                 </a:solidFill>
                 <a:latin typeface="Calibri" pitchFamily="34" charset="0"/>
                 <a:ea typeface="Calibri" pitchFamily="34" charset="-122"/>
@@ -9609,7 +9585,7 @@
     <p:bg>
       <p:bgPr>
         <a:solidFill>
-          <a:srgbClr val="F4F7F6"/>
+          <a:srgbClr val="F4F7FB"/>
         </a:solidFill>
       </p:bgPr>
     </p:bg>
@@ -9654,7 +9630,7 @@
             <a:r>
               <a:rPr lang="en-US" sz="1150" b="1" spc="160" kern="0" dirty="0">
                 <a:solidFill>
-                  <a:srgbClr val="0F5C4C"/>
+                  <a:srgbClr val="1B4F8A"/>
                 </a:solidFill>
                 <a:latin typeface="Calibri" pitchFamily="34" charset="0"/>
                 <a:ea typeface="Calibri" pitchFamily="34" charset="-122"/>
@@ -9693,7 +9669,7 @@
             <a:r>
               <a:rPr lang="en-US" sz="3800" b="1" dirty="0">
                 <a:solidFill>
-                  <a:srgbClr val="14211E"/>
+                  <a:srgbClr val="102A43"/>
                 </a:solidFill>
                 <a:latin typeface="Cambria" pitchFamily="34" charset="0"/>
                 <a:ea typeface="Cambria" pitchFamily="34" charset="-122"/>
@@ -9714,11 +9690,11 @@
         <p:spPr>
           <a:xfrm>
             <a:off x="548640" y="1783080"/>
-            <a:ext cx="3931920" cy="2606040"/>
+            <a:ext cx="3931920" cy="2468880"/>
           </a:xfrm>
           <a:prstGeom prst="roundRect">
             <a:avLst>
-              <a:gd name="adj" fmla="val 4912"/>
+              <a:gd name="adj" fmla="val 5185"/>
             </a:avLst>
           </a:prstGeom>
           <a:solidFill>
@@ -9726,13 +9702,13 @@
           </a:solidFill>
           <a:ln w="9525">
             <a:solidFill>
-              <a:srgbClr val="C5D4CF"/>
+              <a:srgbClr val="C5D0E0"/>
             </a:solidFill>
             <a:prstDash val="solid"/>
           </a:ln>
           <a:effectLst>
             <a:outerShdw sx="100000" sy="100000" kx="0" ky="0" algn="bl" rotWithShape="0" blurRad="127000" dist="25400" dir="5400000">
-              <a:srgbClr val="14211e">
+              <a:srgbClr val="102a43">
                 <a:alpha val="10000"/>
               </a:srgbClr>
             </a:outerShdw>
@@ -9766,7 +9742,7 @@
             <a:r>
               <a:rPr lang="en-US" sz="1800" b="1" dirty="0">
                 <a:solidFill>
-                  <a:srgbClr val="14211E"/>
+                  <a:srgbClr val="102A43"/>
                 </a:solidFill>
                 <a:latin typeface="Calibri" pitchFamily="34" charset="0"/>
                 <a:ea typeface="Calibri" pitchFamily="34" charset="-122"/>
@@ -9786,22 +9762,22 @@
         </p:nvSpPr>
         <p:spPr>
           <a:xfrm>
-            <a:off x="841248" y="2487168"/>
-            <a:ext cx="3346704" cy="1645920"/>
-          </a:xfrm>
-          <a:prstGeom prst="rect">
-            <a:avLst/>
-          </a:prstGeom>
-          <a:noFill/>
-          <a:ln/>
-        </p:spPr>
-        <p:txBody>
-          <a:bodyPr wrap="square" lIns="0" tIns="0" rIns="0" bIns="0" rtlCol="0" anchor="t"/>
-          <a:lstStyle/>
-          <a:p>
-            <a:pPr algn="l" marL="342900" indent="-342900">
+            <a:off x="841248" y="2450592"/>
+            <a:ext cx="3346704" cy="1280160"/>
+          </a:xfrm>
+          <a:prstGeom prst="rect">
+            <a:avLst/>
+          </a:prstGeom>
+          <a:noFill/>
+          <a:ln/>
+        </p:spPr>
+        <p:txBody>
+          <a:bodyPr wrap="square" lIns="0" tIns="0" rIns="0" bIns="0" rtlCol="0" anchor="t"/>
+          <a:lstStyle/>
+          <a:p>
+            <a:pPr algn="l" marL="203200" indent="-203200">
               <a:spcAft>
-                <a:spcPts val="800"/>
+                <a:spcPts val="1200"/>
               </a:spcAft>
               <a:buSzPct val="100000"/>
               <a:buChar char="•"/>
@@ -9809,7 +9785,7 @@
             <a:r>
               <a:rPr lang="en-US" sz="1350" dirty="0">
                 <a:solidFill>
-                  <a:srgbClr val="3D524C"/>
+                  <a:srgbClr val="3D5270"/>
                 </a:solidFill>
                 <a:latin typeface="Calibri" pitchFamily="34" charset="0"/>
                 <a:ea typeface="Calibri" pitchFamily="34" charset="-122"/>
@@ -9820,9 +9796,9 @@
             <a:endParaRPr lang="en-US" sz="1350" dirty="0"/>
           </a:p>
           <a:p>
-            <a:pPr algn="l" marL="342900" indent="-342900">
+            <a:pPr algn="l" marL="203200" indent="-203200">
               <a:spcAft>
-                <a:spcPts val="800"/>
+                <a:spcPts val="1200"/>
               </a:spcAft>
               <a:buSzPct val="100000"/>
               <a:buChar char="•"/>
@@ -9830,7 +9806,7 @@
             <a:r>
               <a:rPr lang="en-US" sz="1350" dirty="0">
                 <a:solidFill>
-                  <a:srgbClr val="3D524C"/>
+                  <a:srgbClr val="3D5270"/>
                 </a:solidFill>
                 <a:latin typeface="Calibri" pitchFamily="34" charset="0"/>
                 <a:ea typeface="Calibri" pitchFamily="34" charset="-122"/>
@@ -9841,9 +9817,9 @@
             <a:endParaRPr lang="en-US" sz="1350" dirty="0"/>
           </a:p>
           <a:p>
-            <a:pPr algn="l" marL="342900" indent="-342900">
+            <a:pPr algn="l" marL="203200" indent="-203200">
               <a:spcAft>
-                <a:spcPts val="800"/>
+                <a:spcPts val="1200"/>
               </a:spcAft>
               <a:buSzPct val="100000"/>
               <a:buChar char="•"/>
@@ -9851,7 +9827,7 @@
             <a:r>
               <a:rPr lang="en-US" sz="1350" dirty="0">
                 <a:solidFill>
-                  <a:srgbClr val="3D524C"/>
+                  <a:srgbClr val="3D5270"/>
                 </a:solidFill>
                 <a:latin typeface="Calibri" pitchFamily="34" charset="0"/>
                 <a:ea typeface="Calibri" pitchFamily="34" charset="-122"/>
@@ -9871,21 +9847,21 @@
         </p:nvSpPr>
         <p:spPr>
           <a:xfrm>
-            <a:off x="4892040" y="2377440"/>
-            <a:ext cx="2377440" cy="1417320"/>
+            <a:off x="4892040" y="2331720"/>
+            <a:ext cx="2377440" cy="1371600"/>
           </a:xfrm>
           <a:prstGeom prst="roundRect">
             <a:avLst>
-              <a:gd name="adj" fmla="val 9032"/>
+              <a:gd name="adj" fmla="val 9333"/>
             </a:avLst>
           </a:prstGeom>
           <a:solidFill>
-            <a:srgbClr val="0F5C4C"/>
+            <a:srgbClr val="1B4F8A"/>
           </a:solidFill>
           <a:ln/>
           <a:effectLst>
             <a:outerShdw sx="100000" sy="100000" kx="0" ky="0" algn="bl" rotWithShape="0" blurRad="127000" dist="25400" dir="5400000">
-              <a:srgbClr val="14211e">
+              <a:srgbClr val="102a43">
                 <a:alpha val="10000"/>
               </a:srgbClr>
             </a:outerShdw>
@@ -9900,7 +9876,7 @@
         </p:nvSpPr>
         <p:spPr>
           <a:xfrm>
-            <a:off x="5120640" y="2578608"/>
+            <a:off x="5120640" y="2532888"/>
             <a:ext cx="1920240" cy="274320"/>
           </a:xfrm>
           <a:prstGeom prst="rect">
@@ -9919,7 +9895,7 @@
             <a:r>
               <a:rPr lang="en-US" sz="1150" b="1" spc="140" kern="0" dirty="0">
                 <a:solidFill>
-                  <a:srgbClr val="C5D4CF"/>
+                  <a:srgbClr val="C5D0E0"/>
                 </a:solidFill>
                 <a:latin typeface="Calibri" pitchFamily="34" charset="0"/>
                 <a:ea typeface="Calibri" pitchFamily="34" charset="-122"/>
@@ -9939,7 +9915,7 @@
         </p:nvSpPr>
         <p:spPr>
           <a:xfrm>
-            <a:off x="5120640" y="2889504"/>
+            <a:off x="5120640" y="2843784"/>
             <a:ext cx="1920240" cy="310896"/>
           </a:xfrm>
           <a:prstGeom prst="rect">
@@ -9958,7 +9934,7 @@
             <a:r>
               <a:rPr lang="en-US" sz="1800" b="1" dirty="0">
                 <a:solidFill>
-                  <a:srgbClr val="F4F7F6"/>
+                  <a:srgbClr val="F4F7FB"/>
                 </a:solidFill>
                 <a:latin typeface="Calibri" pitchFamily="34" charset="0"/>
                 <a:ea typeface="Calibri" pitchFamily="34" charset="-122"/>
@@ -9978,7 +9954,7 @@
         </p:nvSpPr>
         <p:spPr>
           <a:xfrm>
-            <a:off x="5120640" y="3236976"/>
+            <a:off x="5120640" y="3191256"/>
             <a:ext cx="1920240" cy="457200"/>
           </a:xfrm>
           <a:prstGeom prst="rect">
@@ -10000,7 +9976,7 @@
             <a:r>
               <a:rPr lang="en-US" sz="1100" dirty="0">
                 <a:solidFill>
-                  <a:srgbClr val="C5D4CF"/>
+                  <a:srgbClr val="C5D0E0"/>
                 </a:solidFill>
                 <a:latin typeface="Calibri" pitchFamily="34" charset="0"/>
                 <a:ea typeface="Calibri" pitchFamily="34" charset="-122"/>
@@ -10020,7 +9996,7 @@
         </p:nvSpPr>
         <p:spPr>
           <a:xfrm>
-            <a:off x="4553712" y="3081528"/>
+            <a:off x="4553712" y="3017520"/>
             <a:ext cx="274320" cy="0"/>
           </a:xfrm>
           <a:prstGeom prst="line">
@@ -10029,7 +10005,7 @@
           <a:noFill/>
           <a:ln w="25400">
             <a:solidFill>
-              <a:srgbClr val="0F5C4C"/>
+              <a:srgbClr val="1B4F8A"/>
             </a:solidFill>
             <a:prstDash val="solid"/>
             <a:tailEnd type="triangle"/>
@@ -10044,7 +10020,7 @@
         </p:nvSpPr>
         <p:spPr>
           <a:xfrm>
-            <a:off x="7342632" y="3081528"/>
+            <a:off x="7342632" y="3017520"/>
             <a:ext cx="274320" cy="0"/>
           </a:xfrm>
           <a:prstGeom prst="line">
@@ -10053,7 +10029,7 @@
           <a:noFill/>
           <a:ln w="25400">
             <a:solidFill>
-              <a:srgbClr val="0F5C4C"/>
+              <a:srgbClr val="1B4F8A"/>
             </a:solidFill>
             <a:prstDash val="solid"/>
             <a:tailEnd type="triangle"/>
@@ -10069,11 +10045,11 @@
         <p:spPr>
           <a:xfrm>
             <a:off x="7680960" y="1783080"/>
-            <a:ext cx="3931920" cy="2606040"/>
+            <a:ext cx="3931920" cy="2468880"/>
           </a:xfrm>
           <a:prstGeom prst="roundRect">
             <a:avLst>
-              <a:gd name="adj" fmla="val 4912"/>
+              <a:gd name="adj" fmla="val 5185"/>
             </a:avLst>
           </a:prstGeom>
           <a:solidFill>
@@ -10081,13 +10057,13 @@
           </a:solidFill>
           <a:ln w="9525">
             <a:solidFill>
-              <a:srgbClr val="C5D4CF"/>
+              <a:srgbClr val="C5D0E0"/>
             </a:solidFill>
             <a:prstDash val="solid"/>
           </a:ln>
           <a:effectLst>
             <a:outerShdw sx="100000" sy="100000" kx="0" ky="0" algn="bl" rotWithShape="0" blurRad="127000" dist="25400" dir="5400000">
-              <a:srgbClr val="14211e">
+              <a:srgbClr val="102a43">
                 <a:alpha val="10000"/>
               </a:srgbClr>
             </a:outerShdw>
@@ -10121,7 +10097,7 @@
             <a:r>
               <a:rPr lang="en-US" sz="1800" b="1" dirty="0">
                 <a:solidFill>
-                  <a:srgbClr val="14211E"/>
+                  <a:srgbClr val="102A43"/>
                 </a:solidFill>
                 <a:latin typeface="Calibri" pitchFamily="34" charset="0"/>
                 <a:ea typeface="Calibri" pitchFamily="34" charset="-122"/>
@@ -10141,22 +10117,22 @@
         </p:nvSpPr>
         <p:spPr>
           <a:xfrm>
-            <a:off x="7973568" y="2487168"/>
-            <a:ext cx="3346704" cy="1645920"/>
-          </a:xfrm>
-          <a:prstGeom prst="rect">
-            <a:avLst/>
-          </a:prstGeom>
-          <a:noFill/>
-          <a:ln/>
-        </p:spPr>
-        <p:txBody>
-          <a:bodyPr wrap="square" lIns="0" tIns="0" rIns="0" bIns="0" rtlCol="0" anchor="t"/>
-          <a:lstStyle/>
-          <a:p>
-            <a:pPr algn="l" marL="342900" indent="-342900">
+            <a:off x="7973568" y="2450592"/>
+            <a:ext cx="3346704" cy="1280160"/>
+          </a:xfrm>
+          <a:prstGeom prst="rect">
+            <a:avLst/>
+          </a:prstGeom>
+          <a:noFill/>
+          <a:ln/>
+        </p:spPr>
+        <p:txBody>
+          <a:bodyPr wrap="square" lIns="0" tIns="0" rIns="0" bIns="0" rtlCol="0" anchor="t"/>
+          <a:lstStyle/>
+          <a:p>
+            <a:pPr algn="l" marL="203200" indent="-203200">
               <a:spcAft>
-                <a:spcPts val="800"/>
+                <a:spcPts val="1200"/>
               </a:spcAft>
               <a:buSzPct val="100000"/>
               <a:buChar char="•"/>
@@ -10164,7 +10140,7 @@
             <a:r>
               <a:rPr lang="en-US" sz="1350" dirty="0">
                 <a:solidFill>
-                  <a:srgbClr val="3D524C"/>
+                  <a:srgbClr val="3D5270"/>
                 </a:solidFill>
                 <a:latin typeface="Calibri" pitchFamily="34" charset="0"/>
                 <a:ea typeface="Calibri" pitchFamily="34" charset="-122"/>
@@ -10175,9 +10151,9 @@
             <a:endParaRPr lang="en-US" sz="1350" dirty="0"/>
           </a:p>
           <a:p>
-            <a:pPr algn="l" marL="342900" indent="-342900">
+            <a:pPr algn="l" marL="203200" indent="-203200">
               <a:spcAft>
-                <a:spcPts val="800"/>
+                <a:spcPts val="1200"/>
               </a:spcAft>
               <a:buSzPct val="100000"/>
               <a:buChar char="•"/>
@@ -10185,7 +10161,7 @@
             <a:r>
               <a:rPr lang="en-US" sz="1350" dirty="0">
                 <a:solidFill>
-                  <a:srgbClr val="3D524C"/>
+                  <a:srgbClr val="3D5270"/>
                 </a:solidFill>
                 <a:latin typeface="Calibri" pitchFamily="34" charset="0"/>
                 <a:ea typeface="Calibri" pitchFamily="34" charset="-122"/>
@@ -10196,9 +10172,9 @@
             <a:endParaRPr lang="en-US" sz="1350" dirty="0"/>
           </a:p>
           <a:p>
-            <a:pPr algn="l" marL="342900" indent="-342900">
+            <a:pPr algn="l" marL="203200" indent="-203200">
               <a:spcAft>
-                <a:spcPts val="800"/>
+                <a:spcPts val="1200"/>
               </a:spcAft>
               <a:buSzPct val="100000"/>
               <a:buChar char="•"/>
@@ -10206,7 +10182,7 @@
             <a:r>
               <a:rPr lang="en-US" sz="1350" dirty="0">
                 <a:solidFill>
-                  <a:srgbClr val="3D524C"/>
+                  <a:srgbClr val="3D5270"/>
                 </a:solidFill>
                 <a:latin typeface="Calibri" pitchFamily="34" charset="0"/>
                 <a:ea typeface="Calibri" pitchFamily="34" charset="-122"/>
@@ -10226,7 +10202,7 @@
         </p:nvSpPr>
         <p:spPr>
           <a:xfrm>
-            <a:off x="7973568" y="3986784"/>
+            <a:off x="7973568" y="3840480"/>
             <a:ext cx="3346704" cy="310896"/>
           </a:xfrm>
           <a:prstGeom prst="rect">
@@ -10245,7 +10221,7 @@
             <a:r>
               <a:rPr lang="en-US" sz="1150" i="1" dirty="0">
                 <a:solidFill>
-                  <a:srgbClr val="0F5C4C"/>
+                  <a:srgbClr val="1B4F8A"/>
                 </a:solidFill>
                 <a:latin typeface="Calibri" pitchFamily="34" charset="0"/>
                 <a:ea typeface="Calibri" pitchFamily="34" charset="-122"/>
@@ -10265,7 +10241,7 @@
         </p:nvSpPr>
         <p:spPr>
           <a:xfrm>
-            <a:off x="548640" y="4663440"/>
+            <a:off x="548640" y="4572000"/>
             <a:ext cx="11064240" cy="1051560"/>
           </a:xfrm>
           <a:prstGeom prst="roundRect">
@@ -10274,12 +10250,12 @@
             </a:avLst>
           </a:prstGeom>
           <a:solidFill>
-            <a:srgbClr val="14211E"/>
+            <a:srgbClr val="102A43"/>
           </a:solidFill>
           <a:ln/>
           <a:effectLst>
             <a:outerShdw sx="100000" sy="100000" kx="0" ky="0" algn="bl" rotWithShape="0" blurRad="127000" dist="25400" dir="5400000">
-              <a:srgbClr val="14211e">
+              <a:srgbClr val="102a43">
                 <a:alpha val="10000"/>
               </a:srgbClr>
             </a:outerShdw>
@@ -10294,7 +10270,7 @@
         </p:nvSpPr>
         <p:spPr>
           <a:xfrm>
-            <a:off x="914400" y="4892040"/>
+            <a:off x="914400" y="4800600"/>
             <a:ext cx="10332720" cy="640080"/>
           </a:xfrm>
           <a:prstGeom prst="rect">
@@ -10316,7 +10292,7 @@
             <a:r>
               <a:rPr lang="en-US" sz="1550" b="1" dirty="0">
                 <a:solidFill>
-                  <a:srgbClr val="F4F7F6"/>
+                  <a:srgbClr val="F4F7FB"/>
                 </a:solidFill>
                 <a:latin typeface="Calibri" pitchFamily="34" charset="0"/>
                 <a:ea typeface="Calibri" pitchFamily="34" charset="-122"/>
@@ -10355,7 +10331,7 @@
             <a:r>
               <a:rPr lang="en-US" sz="1050" dirty="0">
                 <a:solidFill>
-                  <a:srgbClr val="3D524C"/>
+                  <a:srgbClr val="3D5270"/>
                 </a:solidFill>
                 <a:latin typeface="Calibri" pitchFamily="34" charset="0"/>
                 <a:ea typeface="Calibri" pitchFamily="34" charset="-122"/>
@@ -10381,7 +10357,7 @@
     <p:bg>
       <p:bgPr>
         <a:solidFill>
-          <a:srgbClr val="F4F7F6"/>
+          <a:srgbClr val="F4F7FB"/>
         </a:solidFill>
       </p:bgPr>
     </p:bg>
@@ -10426,7 +10402,7 @@
             <a:r>
               <a:rPr lang="en-US" sz="1150" b="1" spc="160" kern="0" dirty="0">
                 <a:solidFill>
-                  <a:srgbClr val="0F5C4C"/>
+                  <a:srgbClr val="1B4F8A"/>
                 </a:solidFill>
                 <a:latin typeface="Calibri" pitchFamily="34" charset="0"/>
                 <a:ea typeface="Calibri" pitchFamily="34" charset="-122"/>
@@ -10465,7 +10441,7 @@
             <a:r>
               <a:rPr lang="en-US" sz="3800" b="1" dirty="0">
                 <a:solidFill>
-                  <a:srgbClr val="14211E"/>
+                  <a:srgbClr val="102A43"/>
                 </a:solidFill>
                 <a:latin typeface="Cambria" pitchFamily="34" charset="0"/>
                 <a:ea typeface="Cambria" pitchFamily="34" charset="-122"/>
@@ -10499,7 +10475,7 @@
           <a:ln/>
           <a:effectLst>
             <a:outerShdw sx="100000" sy="100000" kx="0" ky="0" algn="bl" rotWithShape="0" blurRad="127000" dist="25400" dir="5400000">
-              <a:srgbClr val="14211e">
+              <a:srgbClr val="102a43">
                 <a:alpha val="10000"/>
               </a:srgbClr>
             </a:outerShdw>
@@ -10572,7 +10548,7 @@
             <a:r>
               <a:rPr lang="en-US" sz="2100" b="1" dirty="0">
                 <a:solidFill>
-                  <a:srgbClr val="14211E"/>
+                  <a:srgbClr val="102A43"/>
                 </a:solidFill>
                 <a:latin typeface="Cambria" pitchFamily="34" charset="0"/>
                 <a:ea typeface="Cambria" pitchFamily="34" charset="-122"/>
@@ -10614,7 +10590,7 @@
             <a:r>
               <a:rPr lang="en-US" sz="1300" dirty="0">
                 <a:solidFill>
-                  <a:srgbClr val="3D524C"/>
+                  <a:srgbClr val="3D5270"/>
                 </a:solidFill>
                 <a:latin typeface="Calibri" pitchFamily="34" charset="0"/>
                 <a:ea typeface="Calibri" pitchFamily="34" charset="-122"/>
@@ -10647,13 +10623,13 @@
           </a:solidFill>
           <a:ln w="9525">
             <a:solidFill>
-              <a:srgbClr val="C5D4CF"/>
+              <a:srgbClr val="C5D0E0"/>
             </a:solidFill>
             <a:prstDash val="solid"/>
           </a:ln>
           <a:effectLst>
             <a:outerShdw sx="100000" sy="100000" kx="0" ky="0" algn="bl" rotWithShape="0" blurRad="127000" dist="25400" dir="5400000">
-              <a:srgbClr val="14211e">
+              <a:srgbClr val="102a43">
                 <a:alpha val="10000"/>
               </a:srgbClr>
             </a:outerShdw>
@@ -10687,7 +10663,7 @@
             <a:r>
               <a:rPr lang="en-US" sz="5000" b="1" dirty="0">
                 <a:solidFill>
-                  <a:srgbClr val="3D524C"/>
+                  <a:srgbClr val="3D5270"/>
                 </a:solidFill>
                 <a:latin typeface="Cambria" pitchFamily="34" charset="0"/>
                 <a:ea typeface="Cambria" pitchFamily="34" charset="-122"/>
@@ -10726,7 +10702,7 @@
             <a:r>
               <a:rPr lang="en-US" sz="1350" b="1" dirty="0">
                 <a:solidFill>
-                  <a:srgbClr val="14211E"/>
+                  <a:srgbClr val="102A43"/>
                 </a:solidFill>
                 <a:latin typeface="Calibri" pitchFamily="34" charset="0"/>
                 <a:ea typeface="Calibri" pitchFamily="34" charset="-122"/>
@@ -10768,7 +10744,7 @@
             <a:r>
               <a:rPr lang="en-US" sz="1250" dirty="0">
                 <a:solidFill>
-                  <a:srgbClr val="3D524C"/>
+                  <a:srgbClr val="3D5270"/>
                 </a:solidFill>
                 <a:latin typeface="Calibri" pitchFamily="34" charset="0"/>
                 <a:ea typeface="Calibri" pitchFamily="34" charset="-122"/>
@@ -10801,13 +10777,13 @@
           </a:solidFill>
           <a:ln w="9525">
             <a:solidFill>
-              <a:srgbClr val="C5D4CF"/>
+              <a:srgbClr val="C5D0E0"/>
             </a:solidFill>
             <a:prstDash val="solid"/>
           </a:ln>
           <a:effectLst>
             <a:outerShdw sx="100000" sy="100000" kx="0" ky="0" algn="bl" rotWithShape="0" blurRad="127000" dist="25400" dir="5400000">
-              <a:srgbClr val="14211e">
+              <a:srgbClr val="102a43">
                 <a:alpha val="10000"/>
               </a:srgbClr>
             </a:outerShdw>
@@ -10841,7 +10817,7 @@
             <a:r>
               <a:rPr lang="en-US" sz="5000" b="1" dirty="0">
                 <a:solidFill>
-                  <a:srgbClr val="0F5C4C"/>
+                  <a:srgbClr val="1B4F8A"/>
                 </a:solidFill>
                 <a:latin typeface="Cambria" pitchFamily="34" charset="0"/>
                 <a:ea typeface="Cambria" pitchFamily="34" charset="-122"/>
@@ -10880,7 +10856,7 @@
             <a:r>
               <a:rPr lang="en-US" sz="1350" b="1" dirty="0">
                 <a:solidFill>
-                  <a:srgbClr val="14211E"/>
+                  <a:srgbClr val="102A43"/>
                 </a:solidFill>
                 <a:latin typeface="Calibri" pitchFamily="34" charset="0"/>
                 <a:ea typeface="Calibri" pitchFamily="34" charset="-122"/>
@@ -10922,7 +10898,7 @@
             <a:r>
               <a:rPr lang="en-US" sz="1250" dirty="0">
                 <a:solidFill>
-                  <a:srgbClr val="3D524C"/>
+                  <a:srgbClr val="3D5270"/>
                 </a:solidFill>
                 <a:latin typeface="Calibri" pitchFamily="34" charset="0"/>
                 <a:ea typeface="Calibri" pitchFamily="34" charset="-122"/>
@@ -10955,13 +10931,13 @@
           </a:solidFill>
           <a:ln w="9525">
             <a:solidFill>
-              <a:srgbClr val="C5D4CF"/>
+              <a:srgbClr val="C5D0E0"/>
             </a:solidFill>
             <a:prstDash val="solid"/>
           </a:ln>
           <a:effectLst>
             <a:outerShdw sx="100000" sy="100000" kx="0" ky="0" algn="bl" rotWithShape="0" blurRad="127000" dist="25400" dir="5400000">
-              <a:srgbClr val="14211e">
+              <a:srgbClr val="102a43">
                 <a:alpha val="10000"/>
               </a:srgbClr>
             </a:outerShdw>
@@ -10995,7 +10971,7 @@
             <a:r>
               <a:rPr lang="en-US" sz="1600" b="1" dirty="0">
                 <a:solidFill>
-                  <a:srgbClr val="14211E"/>
+                  <a:srgbClr val="102A43"/>
                 </a:solidFill>
                 <a:latin typeface="Calibri" pitchFamily="34" charset="0"/>
                 <a:ea typeface="Calibri" pitchFamily="34" charset="-122"/>
@@ -11037,7 +11013,7 @@
             <a:r>
               <a:rPr lang="en-US" sz="1300" dirty="0">
                 <a:solidFill>
-                  <a:srgbClr val="3D524C"/>
+                  <a:srgbClr val="3D5270"/>
                 </a:solidFill>
                 <a:latin typeface="Calibri" pitchFamily="34" charset="0"/>
                 <a:ea typeface="Calibri" pitchFamily="34" charset="-122"/>
@@ -11066,12 +11042,12 @@
             </a:avLst>
           </a:prstGeom>
           <a:solidFill>
-            <a:srgbClr val="0F5C4C"/>
+            <a:srgbClr val="1B4F8A"/>
           </a:solidFill>
           <a:ln/>
           <a:effectLst>
             <a:outerShdw sx="100000" sy="100000" kx="0" ky="0" algn="bl" rotWithShape="0" blurRad="127000" dist="25400" dir="5400000">
-              <a:srgbClr val="14211e">
+              <a:srgbClr val="102a43">
                 <a:alpha val="10000"/>
               </a:srgbClr>
             </a:outerShdw>
@@ -11105,7 +11081,7 @@
             <a:r>
               <a:rPr lang="en-US" sz="1600" b="1" dirty="0">
                 <a:solidFill>
-                  <a:srgbClr val="F4F7F6"/>
+                  <a:srgbClr val="F4F7FB"/>
                 </a:solidFill>
                 <a:latin typeface="Calibri" pitchFamily="34" charset="0"/>
                 <a:ea typeface="Calibri" pitchFamily="34" charset="-122"/>
@@ -11147,7 +11123,7 @@
             <a:r>
               <a:rPr lang="en-US" sz="1300" dirty="0">
                 <a:solidFill>
-                  <a:srgbClr val="C5D4CF"/>
+                  <a:srgbClr val="C5D0E0"/>
                 </a:solidFill>
                 <a:latin typeface="Calibri" pitchFamily="34" charset="0"/>
                 <a:ea typeface="Calibri" pitchFamily="34" charset="-122"/>
@@ -11186,7 +11162,7 @@
             <a:r>
               <a:rPr lang="en-US" sz="1050" dirty="0">
                 <a:solidFill>
-                  <a:srgbClr val="3D524C"/>
+                  <a:srgbClr val="3D5270"/>
                 </a:solidFill>
                 <a:latin typeface="Calibri" pitchFamily="34" charset="0"/>
                 <a:ea typeface="Calibri" pitchFamily="34" charset="-122"/>

</xml_diff>